<commit_message>
Lesson sd-10-021: keep the star scale and illustrate the advice with three algorithms from the Cassandra and etcd-io/raft documentation, with the figure, metadata and deck
Co-Authored-By: Claude Sonnet 5.5 <noreply@anthropic.com>
Claude-Session: https://claude.ai/code/session_011dmt3ZFdN8sjiTfDnyUVN7
</commit_message>
<xml_diff>
--- a/system-design-101/vi/lessons/sd-10-021/slides/sd-10-021.pptx
+++ b/system-design-101/vi/lessons/sd-10-021/slides/sd-10-021.pptx
@@ -2396,10 +2396,10 @@
                 <a:ea typeface="Be Vietnam Pro" pitchFamily="34" charset="-122"/>
                 <a:cs typeface="Be Vietnam Pro" pitchFamily="34" charset="-120"/>
               </a:rPr>
-              <a:t> toán</a:t>
-            </a:r>
-            <a:r>
-              <a:rPr lang="en-US" sz="1650" dirty="0" spc="1" kern="0">
+              <a:t> toán gán</a:t>
+            </a:r>
+            <a:r>
+              <a:rPr lang="en-US" sz="1650" dirty="0" spc="-4" kern="0">
                 <a:solidFill>
                   <a:srgbClr val="C4C8D6"/>
                 </a:solidFill>
@@ -2407,18 +2407,7 @@
                 <a:ea typeface="Be Vietnam Pro" pitchFamily="34" charset="-122"/>
                 <a:cs typeface="Be Vietnam Pro" pitchFamily="34" charset="-120"/>
               </a:rPr>
-              <a:t> nêu</a:t>
-            </a:r>
-            <a:r>
-              <a:rPr lang="en-US" sz="1650" dirty="0" spc="-6" kern="0">
-                <a:solidFill>
-                  <a:srgbClr val="C4C8D6"/>
-                </a:solidFill>
-                <a:latin typeface="Be Vietnam Pro" pitchFamily="34" charset="0"/>
-                <a:ea typeface="Be Vietnam Pro" pitchFamily="34" charset="-122"/>
-                <a:cs typeface="Be Vietnam Pro" pitchFamily="34" charset="-120"/>
-              </a:rPr>
-              <a:t> tên</a:t>
+              <a:t> sao</a:t>
             </a:r>
             <a:endParaRPr lang="en-US" sz="1650" dirty="0"/>
           </a:p>
@@ -4439,15 +4428,70 @@
               <a:t> biết</a:t>
             </a:r>
             <a:r>
-              <a:rPr lang="en-US" sz="2700" dirty="0" spc="8" kern="0">
-                <a:solidFill>
-                  <a:srgbClr val="14161C"/>
-                </a:solidFill>
-                <a:latin typeface="Be Vietnam Pro" pitchFamily="34" charset="0"/>
-                <a:ea typeface="Be Vietnam Pro" pitchFamily="34" charset="-122"/>
-                <a:cs typeface="Be Vietnam Pro" pitchFamily="34" charset="-120"/>
-              </a:rPr>
-              <a:t> trước</a:t>
+              <a:rPr lang="en-US" sz="2700" dirty="0" spc="0" kern="0">
+                <a:solidFill>
+                  <a:srgbClr val="14161C"/>
+                </a:solidFill>
+                <a:latin typeface="Be Vietnam Pro" pitchFamily="34" charset="0"/>
+                <a:ea typeface="Be Vietnam Pro" pitchFamily="34" charset="-122"/>
+                <a:cs typeface="Be Vietnam Pro" pitchFamily="34" charset="-120"/>
+              </a:rPr>
+              <a:t> thành</a:t>
+            </a:r>
+            <a:r>
+              <a:rPr lang="en-US" sz="2700" dirty="0" spc="-8" kern="0">
+                <a:solidFill>
+                  <a:srgbClr val="14161C"/>
+                </a:solidFill>
+                <a:latin typeface="Be Vietnam Pro" pitchFamily="34" charset="0"/>
+                <a:ea typeface="Be Vietnam Pro" pitchFamily="34" charset="-122"/>
+                <a:cs typeface="Be Vietnam Pro" pitchFamily="34" charset="-120"/>
+              </a:rPr>
+              <a:t> ba</a:t>
+            </a:r>
+            <a:r>
+              <a:rPr lang="en-US" sz="2700" dirty="0" spc="9" kern="0">
+                <a:solidFill>
+                  <a:srgbClr val="14161C"/>
+                </a:solidFill>
+                <a:latin typeface="Be Vietnam Pro" pitchFamily="34" charset="0"/>
+                <a:ea typeface="Be Vietnam Pro" pitchFamily="34" charset="-122"/>
+                <a:cs typeface="Be Vietnam Pro" pitchFamily="34" charset="-120"/>
+              </a:rPr>
+              <a:t> mức</a:t>
+            </a:r>
+            <a:r>
+              <a:rPr lang="en-US" sz="2700" dirty="0" spc="-9" kern="0">
+                <a:solidFill>
+                  <a:srgbClr val="14161C"/>
+                </a:solidFill>
+                <a:latin typeface="Be Vietnam Pro" pitchFamily="34" charset="0"/>
+                <a:ea typeface="Be Vietnam Pro" pitchFamily="34" charset="-122"/>
+                <a:cs typeface="Be Vietnam Pro" pitchFamily="34" charset="-120"/>
+              </a:rPr>
+              <a:t> sao.</a:t>
+            </a:r>
+            <a:r>
+              <a:rPr lang="en-US" sz="2700" dirty="0" spc="-2" kern="0">
+                <a:solidFill>
+                  <a:srgbClr val="14161C"/>
+                </a:solidFill>
+                <a:latin typeface="Be Vietnam Pro" pitchFamily="34" charset="0"/>
+                <a:ea typeface="Be Vietnam Pro" pitchFamily="34" charset="-122"/>
+                <a:cs typeface="Be Vietnam Pro" pitchFamily="34" charset="-120"/>
+              </a:rPr>
+              <a:t> Bài</a:t>
+            </a:r>
+            <a:r>
+              <a:rPr lang="en-US" sz="2700" dirty="0" spc="-3" kern="0">
+                <a:solidFill>
+                  <a:srgbClr val="14161C"/>
+                </a:solidFill>
+                <a:latin typeface="Be Vietnam Pro" pitchFamily="34" charset="0"/>
+                <a:ea typeface="Be Vietnam Pro" pitchFamily="34" charset="-122"/>
+                <a:cs typeface="Be Vietnam Pro" pitchFamily="34" charset="-120"/>
+              </a:rPr>
+              <a:t> giữ</a:t>
             </a:r>
             <a:r>
               <a:rPr lang="en-US" sz="2700" dirty="0" spc="-1" kern="0">
@@ -4458,7 +4502,29 @@
                 <a:ea typeface="Be Vietnam Pro" pitchFamily="34" charset="-122"/>
                 <a:cs typeface="Be Vietnam Pro" pitchFamily="34" charset="-120"/>
               </a:rPr>
-              <a:t> buổi</a:t>
+              <a:t> thang</a:t>
+            </a:r>
+            <a:r>
+              <a:rPr lang="en-US" sz="2700" dirty="0" spc="16" kern="0">
+                <a:solidFill>
+                  <a:srgbClr val="14161C"/>
+                </a:solidFill>
+                <a:latin typeface="Be Vietnam Pro" pitchFamily="34" charset="0"/>
+                <a:ea typeface="Be Vietnam Pro" pitchFamily="34" charset="-122"/>
+                <a:cs typeface="Be Vietnam Pro" pitchFamily="34" charset="-120"/>
+              </a:rPr>
+              <a:t> đó</a:t>
+            </a:r>
+            <a:r>
+              <a:rPr lang="en-US" sz="2700" dirty="0" spc="-17" kern="0">
+                <a:solidFill>
+                  <a:srgbClr val="14161C"/>
+                </a:solidFill>
+                <a:latin typeface="Be Vietnam Pro" pitchFamily="34" charset="0"/>
+                <a:ea typeface="Be Vietnam Pro" pitchFamily="34" charset="-122"/>
+                <a:cs typeface="Be Vietnam Pro" pitchFamily="34" charset="-120"/>
+              </a:rPr>
+              <a:t> và</a:t>
             </a:r>
             <a:r>
               <a:rPr lang="en-US" sz="2700" dirty="0" spc="-2" kern="0">
@@ -4469,32 +4535,10 @@
                 <a:ea typeface="Be Vietnam Pro" pitchFamily="34" charset="-122"/>
                 <a:cs typeface="Be Vietnam Pro" pitchFamily="34" charset="-120"/>
               </a:rPr>
-              <a:t> phỏng</a:t>
-            </a:r>
-            <a:r>
-              <a:rPr lang="en-US" sz="2700" dirty="0" spc="-14" kern="0">
-                <a:solidFill>
-                  <a:srgbClr val="14161C"/>
-                </a:solidFill>
-                <a:latin typeface="Be Vietnam Pro" pitchFamily="34" charset="0"/>
-                <a:ea typeface="Be Vietnam Pro" pitchFamily="34" charset="-122"/>
-                <a:cs typeface="Be Vietnam Pro" pitchFamily="34" charset="-120"/>
-              </a:rPr>
-              <a:t> vấn</a:t>
-            </a:r>
-            <a:r>
-              <a:rPr lang="en-US" sz="2700" dirty="0" spc="0" kern="0">
-                <a:solidFill>
-                  <a:srgbClr val="14161C"/>
-                </a:solidFill>
-                <a:latin typeface="Be Vietnam Pro" pitchFamily="34" charset="0"/>
-                <a:ea typeface="Be Vietnam Pro" pitchFamily="34" charset="-122"/>
-                <a:cs typeface="Be Vietnam Pro" pitchFamily="34" charset="-120"/>
-              </a:rPr>
-              <a:t> thành</a:t>
-            </a:r>
-            <a:r>
-              <a:rPr lang="en-US" sz="2700" dirty="0" spc="-9" kern="0">
+              <a:t> thêm</a:t>
+            </a:r>
+            <a:r>
+              <a:rPr lang="en-US" sz="2700" dirty="0" spc="-7" kern="0">
                 <a:solidFill>
                   <a:srgbClr val="14161C"/>
                 </a:solidFill>
@@ -4505,50 +4549,6 @@
               <a:t> ba</a:t>
             </a:r>
             <a:r>
-              <a:rPr lang="en-US" sz="2700" dirty="0" spc="9" kern="0">
-                <a:solidFill>
-                  <a:srgbClr val="14161C"/>
-                </a:solidFill>
-                <a:latin typeface="Be Vietnam Pro" pitchFamily="34" charset="0"/>
-                <a:ea typeface="Be Vietnam Pro" pitchFamily="34" charset="-122"/>
-                <a:cs typeface="Be Vietnam Pro" pitchFamily="34" charset="-120"/>
-              </a:rPr>
-              <a:t> mức</a:t>
-            </a:r>
-            <a:r>
-              <a:rPr lang="en-US" sz="2700" dirty="0" spc="-9" kern="0">
-                <a:solidFill>
-                  <a:srgbClr val="14161C"/>
-                </a:solidFill>
-                <a:latin typeface="Be Vietnam Pro" pitchFamily="34" charset="0"/>
-                <a:ea typeface="Be Vietnam Pro" pitchFamily="34" charset="-122"/>
-                <a:cs typeface="Be Vietnam Pro" pitchFamily="34" charset="-120"/>
-              </a:rPr>
-              <a:t> sao.</a:t>
-            </a:r>
-            <a:r>
-              <a:rPr lang="en-US" sz="2700" dirty="0" spc="-2" kern="0">
-                <a:solidFill>
-                  <a:srgbClr val="14161C"/>
-                </a:solidFill>
-                <a:latin typeface="Be Vietnam Pro" pitchFamily="34" charset="0"/>
-                <a:ea typeface="Be Vietnam Pro" pitchFamily="34" charset="-122"/>
-                <a:cs typeface="Be Vietnam Pro" pitchFamily="34" charset="-120"/>
-              </a:rPr>
-              <a:t> Bài</a:t>
-            </a:r>
-            <a:r>
-              <a:rPr lang="en-US" sz="2700" dirty="0" spc="-12" kern="0">
-                <a:solidFill>
-                  <a:srgbClr val="14161C"/>
-                </a:solidFill>
-                <a:latin typeface="Be Vietnam Pro" pitchFamily="34" charset="0"/>
-                <a:ea typeface="Be Vietnam Pro" pitchFamily="34" charset="-122"/>
-                <a:cs typeface="Be Vietnam Pro" pitchFamily="34" charset="-120"/>
-              </a:rPr>
-              <a:t> này</a:t>
-            </a:r>
-            <a:r>
               <a:rPr lang="en-US" sz="2700" dirty="0" spc="-1" kern="0">
                 <a:solidFill>
                   <a:srgbClr val="14161C"/>
@@ -4557,62 +4557,40 @@
                 <a:ea typeface="Be Vietnam Pro" pitchFamily="34" charset="-122"/>
                 <a:cs typeface="Be Vietnam Pro" pitchFamily="34" charset="-120"/>
               </a:rPr>
-              <a:t> chỉ</a:t>
-            </a:r>
-            <a:r>
-              <a:rPr lang="en-US" sz="2700" dirty="0" spc="-2" kern="0">
-                <a:solidFill>
-                  <a:srgbClr val="14161C"/>
-                </a:solidFill>
-                <a:latin typeface="Be Vietnam Pro" pitchFamily="34" charset="0"/>
-                <a:ea typeface="Be Vietnam Pro" pitchFamily="34" charset="-122"/>
-                <a:cs typeface="Be Vietnam Pro" pitchFamily="34" charset="-120"/>
-              </a:rPr>
-              <a:t> nói</a:t>
-            </a:r>
-            <a:r>
-              <a:rPr lang="en-US" sz="2700" dirty="0" spc="1" kern="0">
-                <a:solidFill>
-                  <a:srgbClr val="14161C"/>
-                </a:solidFill>
-                <a:latin typeface="Be Vietnam Pro" pitchFamily="34" charset="0"/>
-                <a:ea typeface="Be Vietnam Pro" pitchFamily="34" charset="-122"/>
-                <a:cs typeface="Be Vietnam Pro" pitchFamily="34" charset="-120"/>
-              </a:rPr>
-              <a:t> cách</a:t>
-            </a:r>
-            <a:r>
-              <a:rPr lang="en-US" sz="2700" dirty="0" spc="10" kern="0">
-                <a:solidFill>
-                  <a:srgbClr val="14161C"/>
-                </a:solidFill>
-                <a:latin typeface="Be Vietnam Pro" pitchFamily="34" charset="0"/>
-                <a:ea typeface="Be Vietnam Pro" pitchFamily="34" charset="-122"/>
-                <a:cs typeface="Be Vietnam Pro" pitchFamily="34" charset="-120"/>
-              </a:rPr>
-              <a:t> đọc</a:t>
-            </a:r>
-            <a:r>
-              <a:rPr lang="en-US" sz="2700" dirty="0" spc="-1" kern="0">
-                <a:solidFill>
-                  <a:srgbClr val="14161C"/>
-                </a:solidFill>
-                <a:latin typeface="Be Vietnam Pro" pitchFamily="34" charset="0"/>
-                <a:ea typeface="Be Vietnam Pro" pitchFamily="34" charset="-122"/>
-                <a:cs typeface="Be Vietnam Pro" pitchFamily="34" charset="-120"/>
-              </a:rPr>
-              <a:t> thang</a:t>
-            </a:r>
-            <a:r>
-              <a:rPr lang="en-US" sz="2700" dirty="0" spc="11" kern="0">
-                <a:solidFill>
-                  <a:srgbClr val="14161C"/>
-                </a:solidFill>
-                <a:latin typeface="Be Vietnam Pro" pitchFamily="34" charset="0"/>
-                <a:ea typeface="Be Vietnam Pro" pitchFamily="34" charset="-122"/>
-                <a:cs typeface="Be Vietnam Pro" pitchFamily="34" charset="-120"/>
-              </a:rPr>
-              <a:t> đó.</a:t>
+              <a:t> ví</a:t>
+            </a:r>
+            <a:r>
+              <a:rPr lang="en-US" sz="2700" dirty="0" spc="-4" kern="0">
+                <a:solidFill>
+                  <a:srgbClr val="14161C"/>
+                </a:solidFill>
+                <a:latin typeface="Be Vietnam Pro" pitchFamily="34" charset="0"/>
+                <a:ea typeface="Be Vietnam Pro" pitchFamily="34" charset="-122"/>
+                <a:cs typeface="Be Vietnam Pro" pitchFamily="34" charset="-120"/>
+              </a:rPr>
+              <a:t> dụ</a:t>
+            </a:r>
+            <a:r>
+              <a:rPr lang="en-US" sz="2700" dirty="0" spc="-3" kern="0">
+                <a:solidFill>
+                  <a:srgbClr val="14161C"/>
+                </a:solidFill>
+                <a:latin typeface="Be Vietnam Pro" pitchFamily="34" charset="0"/>
+                <a:ea typeface="Be Vietnam Pro" pitchFamily="34" charset="-122"/>
+                <a:cs typeface="Be Vietnam Pro" pitchFamily="34" charset="-120"/>
+              </a:rPr>
+              <a:t> dùng</a:t>
+            </a:r>
+            <a:r>
+              <a:rPr lang="en-US" sz="2700" dirty="0" spc="-8" kern="0">
+                <a:solidFill>
+                  <a:srgbClr val="14161C"/>
+                </a:solidFill>
+                <a:latin typeface="Be Vietnam Pro" pitchFamily="34" charset="0"/>
+                <a:ea typeface="Be Vietnam Pro" pitchFamily="34" charset="-122"/>
+                <a:cs typeface="Be Vietnam Pro" pitchFamily="34" charset="-120"/>
+              </a:rPr>
+              <a:t> thật.</a:t>
             </a:r>
             <a:endParaRPr lang="en-US" sz="2700" dirty="0"/>
           </a:p>
@@ -4891,6 +4869,17 @@
               <a:buChar char="•"/>
             </a:pPr>
             <a:r>
+              <a:rPr lang="en-US" sz="2550" dirty="0" spc="-11" kern="0">
+                <a:solidFill>
+                  <a:srgbClr val="14161C"/>
+                </a:solidFill>
+                <a:latin typeface="Be Vietnam Pro" pitchFamily="34" charset="0"/>
+                <a:ea typeface="Be Vietnam Pro" pitchFamily="34" charset="-122"/>
+                <a:cs typeface="Be Vietnam Pro" pitchFamily="34" charset="-120"/>
+              </a:rPr>
+              <a:t>Thấy</a:t>
+            </a:r>
+            <a:r>
               <a:rPr lang="en-US" sz="2550" dirty="0" spc="-4" kern="0">
                 <a:solidFill>
                   <a:srgbClr val="14161C"/>
@@ -4899,7 +4888,40 @@
                 <a:ea typeface="Be Vietnam Pro" pitchFamily="34" charset="-122"/>
                 <a:cs typeface="Be Vietnam Pro" pitchFamily="34" charset="-120"/>
               </a:rPr>
-              <a:t>Biết</a:t>
+              <a:t> ba</a:t>
+            </a:r>
+            <a:r>
+              <a:rPr lang="en-US" sz="2550" dirty="0" spc="-6" kern="0">
+                <a:solidFill>
+                  <a:srgbClr val="14161C"/>
+                </a:solidFill>
+                <a:latin typeface="Be Vietnam Pro" pitchFamily="34" charset="0"/>
+                <a:ea typeface="Be Vietnam Pro" pitchFamily="34" charset="-122"/>
+                <a:cs typeface="Be Vietnam Pro" pitchFamily="34" charset="-120"/>
+              </a:rPr>
+              <a:t> thuật</a:t>
+            </a:r>
+            <a:r>
+              <a:rPr lang="en-US" sz="2550" dirty="0" spc="-12" kern="0">
+                <a:solidFill>
+                  <a:srgbClr val="14161C"/>
+                </a:solidFill>
+                <a:latin typeface="Be Vietnam Pro" pitchFamily="34" charset="0"/>
+                <a:ea typeface="Be Vietnam Pro" pitchFamily="34" charset="-122"/>
+                <a:cs typeface="Be Vietnam Pro" pitchFamily="34" charset="-120"/>
+              </a:rPr>
+              <a:t> toán</a:t>
+            </a:r>
+            <a:r>
+              <a:rPr lang="en-US" sz="2550" dirty="0" spc="-17" kern="0">
+                <a:solidFill>
+                  <a:srgbClr val="14161C"/>
+                </a:solidFill>
+                <a:latin typeface="Be Vietnam Pro" pitchFamily="34" charset="0"/>
+                <a:ea typeface="Be Vietnam Pro" pitchFamily="34" charset="-122"/>
+                <a:cs typeface="Be Vietnam Pro" pitchFamily="34" charset="-120"/>
+              </a:rPr>
+              <a:t> trong</a:t>
             </a:r>
             <a:r>
               <a:rPr lang="en-US" sz="2550" dirty="0" spc="1" kern="0">
@@ -4910,62 +4932,18 @@
                 <a:ea typeface="Be Vietnam Pro" pitchFamily="34" charset="-122"/>
                 <a:cs typeface="Be Vietnam Pro" pitchFamily="34" charset="-120"/>
               </a:rPr>
-              <a:t> thang</a:t>
-            </a:r>
-            <a:r>
-              <a:rPr lang="en-US" sz="2550" dirty="0" spc="-10" kern="0">
-                <a:solidFill>
-                  <a:srgbClr val="14161C"/>
-                </a:solidFill>
-                <a:latin typeface="Be Vietnam Pro" pitchFamily="34" charset="0"/>
-                <a:ea typeface="Be Vietnam Pro" pitchFamily="34" charset="-122"/>
-                <a:cs typeface="Be Vietnam Pro" pitchFamily="34" charset="-120"/>
-              </a:rPr>
-              <a:t> này</a:t>
-            </a:r>
-            <a:r>
-              <a:rPr lang="en-US" sz="2550" dirty="0" spc="0" kern="0">
-                <a:solidFill>
-                  <a:srgbClr val="14161C"/>
-                </a:solidFill>
-                <a:latin typeface="Be Vietnam Pro" pitchFamily="34" charset="0"/>
-                <a:ea typeface="Be Vietnam Pro" pitchFamily="34" charset="-122"/>
-                <a:cs typeface="Be Vietnam Pro" pitchFamily="34" charset="-120"/>
-              </a:rPr>
-              <a:t> có</a:t>
-            </a:r>
-            <a:r>
-              <a:rPr lang="en-US" sz="2550" dirty="0" spc="-1" kern="0">
-                <a:solidFill>
-                  <a:srgbClr val="14161C"/>
-                </a:solidFill>
-                <a:latin typeface="Be Vietnam Pro" pitchFamily="34" charset="0"/>
-                <a:ea typeface="Be Vietnam Pro" pitchFamily="34" charset="-122"/>
-                <a:cs typeface="Be Vietnam Pro" pitchFamily="34" charset="-120"/>
-              </a:rPr>
-              <a:t> giới</a:t>
-            </a:r>
-            <a:r>
-              <a:rPr lang="en-US" sz="2550" dirty="0" spc="0" kern="0">
-                <a:solidFill>
-                  <a:srgbClr val="14161C"/>
-                </a:solidFill>
-                <a:latin typeface="Be Vietnam Pro" pitchFamily="34" charset="0"/>
-                <a:ea typeface="Be Vietnam Pro" pitchFamily="34" charset="-122"/>
-                <a:cs typeface="Be Vietnam Pro" pitchFamily="34" charset="-120"/>
-              </a:rPr>
-              <a:t> hạn</a:t>
-            </a:r>
-            <a:r>
-              <a:rPr lang="en-US" sz="2550" dirty="0" spc="3" kern="0">
-                <a:solidFill>
-                  <a:srgbClr val="14161C"/>
-                </a:solidFill>
-                <a:latin typeface="Be Vietnam Pro" pitchFamily="34" charset="0"/>
-                <a:ea typeface="Be Vietnam Pro" pitchFamily="34" charset="-122"/>
-                <a:cs typeface="Be Vietnam Pro" pitchFamily="34" charset="-120"/>
-              </a:rPr>
-              <a:t> gì.</a:t>
+              <a:t> hệ thống</a:t>
+            </a:r>
+            <a:r>
+              <a:rPr lang="en-US" sz="2550" dirty="0" spc="-7" kern="0">
+                <a:solidFill>
+                  <a:srgbClr val="14161C"/>
+                </a:solidFill>
+                <a:latin typeface="Be Vietnam Pro" pitchFamily="34" charset="0"/>
+                <a:ea typeface="Be Vietnam Pro" pitchFamily="34" charset="-122"/>
+                <a:cs typeface="Be Vietnam Pro" pitchFamily="34" charset="-120"/>
+              </a:rPr>
+              <a:t> thật.</a:t>
             </a:r>
             <a:endParaRPr lang="en-US" sz="2550" dirty="0"/>
           </a:p>
@@ -6395,26 +6373,15 @@
               <a:t>Bài</a:t>
             </a:r>
             <a:r>
-              <a:rPr lang="en-US" sz="2550" b="1" dirty="0" spc="-12" kern="0">
-                <a:solidFill>
-                  <a:srgbClr val="14161C"/>
-                </a:solidFill>
-                <a:latin typeface="Be Vietnam Pro" pitchFamily="34" charset="0"/>
-                <a:ea typeface="Be Vietnam Pro" pitchFamily="34" charset="-122"/>
-                <a:cs typeface="Be Vietnam Pro" pitchFamily="34" charset="-120"/>
-              </a:rPr>
-              <a:t> này</a:t>
-            </a:r>
-            <a:r>
-              <a:rPr lang="en-US" sz="2550" b="1" dirty="0" spc="0" kern="0">
-                <a:solidFill>
-                  <a:srgbClr val="14161C"/>
-                </a:solidFill>
-                <a:latin typeface="Be Vietnam Pro" pitchFamily="34" charset="0"/>
-                <a:ea typeface="Be Vietnam Pro" pitchFamily="34" charset="-122"/>
-                <a:cs typeface="Be Vietnam Pro" pitchFamily="34" charset="-120"/>
-              </a:rPr>
-              <a:t> chỉ</a:t>
+              <a:rPr lang="en-US" sz="2550" b="1" dirty="0" spc="1" kern="0">
+                <a:solidFill>
+                  <a:srgbClr val="14161C"/>
+                </a:solidFill>
+                <a:latin typeface="Be Vietnam Pro" pitchFamily="34" charset="0"/>
+                <a:ea typeface="Be Vietnam Pro" pitchFamily="34" charset="-122"/>
+                <a:cs typeface="Be Vietnam Pro" pitchFamily="34" charset="-120"/>
+              </a:rPr>
+              <a:t> giữ</a:t>
             </a:r>
             <a:r>
               <a:rPr lang="en-US" sz="2550" b="1" dirty="0" spc="-2" kern="0">
@@ -6425,29 +6392,51 @@
                 <a:ea typeface="Be Vietnam Pro" pitchFamily="34" charset="-122"/>
                 <a:cs typeface="Be Vietnam Pro" pitchFamily="34" charset="-120"/>
               </a:rPr>
-              <a:t> nói</a:t>
-            </a:r>
-            <a:r>
-              <a:rPr lang="en-US" sz="2550" b="1" dirty="0" spc="2" kern="0">
-                <a:solidFill>
-                  <a:srgbClr val="14161C"/>
-                </a:solidFill>
-                <a:latin typeface="Be Vietnam Pro" pitchFamily="34" charset="0"/>
-                <a:ea typeface="Be Vietnam Pro" pitchFamily="34" charset="-122"/>
-                <a:cs typeface="Be Vietnam Pro" pitchFamily="34" charset="-120"/>
-              </a:rPr>
-              <a:t> cách đọc</a:t>
-            </a:r>
-            <a:r>
-              <a:rPr lang="en-US" sz="2550" b="1" dirty="0" spc="-2" kern="0">
-                <a:solidFill>
-                  <a:srgbClr val="14161C"/>
-                </a:solidFill>
-                <a:latin typeface="Be Vietnam Pro" pitchFamily="34" charset="0"/>
-                <a:ea typeface="Be Vietnam Pro" pitchFamily="34" charset="-122"/>
-                <a:cs typeface="Be Vietnam Pro" pitchFamily="34" charset="-120"/>
-              </a:rPr>
               <a:t> thang</a:t>
+            </a:r>
+            <a:r>
+              <a:rPr lang="en-US" sz="2550" b="1" dirty="0" spc="-21" kern="0">
+                <a:solidFill>
+                  <a:srgbClr val="14161C"/>
+                </a:solidFill>
+                <a:latin typeface="Be Vietnam Pro" pitchFamily="34" charset="0"/>
+                <a:ea typeface="Be Vietnam Pro" pitchFamily="34" charset="-122"/>
+                <a:cs typeface="Be Vietnam Pro" pitchFamily="34" charset="-120"/>
+              </a:rPr>
+              <a:t> và</a:t>
+            </a:r>
+            <a:r>
+              <a:rPr lang="en-US" sz="2550" b="1" dirty="0" spc="-5" kern="0">
+                <a:solidFill>
+                  <a:srgbClr val="14161C"/>
+                </a:solidFill>
+                <a:latin typeface="Be Vietnam Pro" pitchFamily="34" charset="0"/>
+                <a:ea typeface="Be Vietnam Pro" pitchFamily="34" charset="-122"/>
+                <a:cs typeface="Be Vietnam Pro" pitchFamily="34" charset="-120"/>
+              </a:rPr>
+              <a:t> thêm</a:t>
+            </a:r>
+            <a:r>
+              <a:rPr lang="en-US" sz="2550" b="1" dirty="0" spc="-3" kern="0">
+                <a:solidFill>
+                  <a:srgbClr val="14161C"/>
+                </a:solidFill>
+                <a:latin typeface="Be Vietnam Pro" pitchFamily="34" charset="0"/>
+                <a:ea typeface="Be Vietnam Pro" pitchFamily="34" charset="-122"/>
+                <a:cs typeface="Be Vietnam Pro" pitchFamily="34" charset="-120"/>
+              </a:rPr>
+              <a:t> ba</a:t>
+            </a:r>
+            <a:r>
+              <a:rPr lang="en-US" sz="2550" b="1" dirty="0" spc="-1" kern="0">
+                <a:solidFill>
+                  <a:srgbClr val="14161C"/>
+                </a:solidFill>
+                <a:latin typeface="Be Vietnam Pro" pitchFamily="34" charset="0"/>
+                <a:ea typeface="Be Vietnam Pro" pitchFamily="34" charset="-122"/>
+                <a:cs typeface="Be Vietnam Pro" pitchFamily="34" charset="-120"/>
+              </a:rPr>
+              <a:t> ví dụ</a:t>
             </a:r>
             <a:endParaRPr lang="en-US" sz="2550" dirty="0"/>
           </a:p>
@@ -11012,7 +11001,7 @@
               <a:buNone/>
             </a:pPr>
             <a:r>
-              <a:rPr lang="en-US" sz="1950" b="1" spc="225" kern="0" dirty="0">
+              <a:rPr lang="en-US" sz="1950" b="1" spc="214" kern="0" dirty="0">
                 <a:solidFill>
                   <a:srgbClr val="FF6A4D"/>
                 </a:solidFill>
@@ -11020,7 +11009,18 @@
                 <a:ea typeface="Be Vietnam Pro" pitchFamily="34" charset="-122"/>
                 <a:cs typeface="Be Vietnam Pro" pitchFamily="34" charset="-120"/>
               </a:rPr>
-              <a:t>VỀ</a:t>
+              <a:t>BA</a:t>
+            </a:r>
+            <a:r>
+              <a:rPr lang="en-US" sz="1950" b="1" spc="227" kern="0" dirty="0">
+                <a:solidFill>
+                  <a:srgbClr val="FF6A4D"/>
+                </a:solidFill>
+                <a:latin typeface="Be Vietnam Pro" pitchFamily="34" charset="0"/>
+                <a:ea typeface="Be Vietnam Pro" pitchFamily="34" charset="-122"/>
+                <a:cs typeface="Be Vietnam Pro" pitchFamily="34" charset="-120"/>
+              </a:rPr>
+              <a:t> VÍ DỤ</a:t>
             </a:r>
             <a:r>
               <a:rPr lang="en-US" sz="1950" b="1" spc="226" kern="0" dirty="0">
@@ -11031,10 +11031,10 @@
                 <a:ea typeface="Be Vietnam Pro" pitchFamily="34" charset="-122"/>
                 <a:cs typeface="Be Vietnam Pro" pitchFamily="34" charset="-120"/>
               </a:rPr>
-              <a:t> CHÍNH</a:t>
-            </a:r>
-            <a:r>
-              <a:rPr lang="en-US" sz="1950" b="1" spc="225" kern="0" dirty="0">
+              <a:t> DÙNG</a:t>
+            </a:r>
+            <a:r>
+              <a:rPr lang="en-US" sz="1950" b="1" spc="186" kern="0" dirty="0">
                 <a:solidFill>
                   <a:srgbClr val="FF6A4D"/>
                 </a:solidFill>
@@ -11042,18 +11042,7 @@
                 <a:ea typeface="Be Vietnam Pro" pitchFamily="34" charset="-122"/>
                 <a:cs typeface="Be Vietnam Pro" pitchFamily="34" charset="-120"/>
               </a:rPr>
-              <a:t> THANG</a:t>
-            </a:r>
-            <a:r>
-              <a:rPr lang="en-US" sz="1950" b="1" spc="195" kern="0" dirty="0">
-                <a:solidFill>
-                  <a:srgbClr val="FF6A4D"/>
-                </a:solidFill>
-                <a:latin typeface="Be Vietnam Pro" pitchFamily="34" charset="0"/>
-                <a:ea typeface="Be Vietnam Pro" pitchFamily="34" charset="-122"/>
-                <a:cs typeface="Be Vietnam Pro" pitchFamily="34" charset="-120"/>
-              </a:rPr>
-              <a:t> SAO</a:t>
+              <a:t> THẬT</a:t>
             </a:r>
             <a:endParaRPr lang="en-US" sz="1950" dirty="0"/>
           </a:p>
@@ -11087,7 +11076,7 @@
               <a:buNone/>
             </a:pPr>
             <a:r>
-              <a:rPr lang="en-US" sz="7500" dirty="0" spc="-121" kern="0">
+              <a:rPr lang="en-US" sz="7500" dirty="0" spc="-2" kern="0">
                 <a:solidFill>
                   <a:srgbClr val="F3EEE3"/>
                 </a:solidFill>
@@ -11095,10 +11084,10 @@
                 <a:ea typeface="Bricolage Grotesque ExtraBold" pitchFamily="34" charset="-122"/>
                 <a:cs typeface="Bricolage Grotesque ExtraBold" pitchFamily="34" charset="-120"/>
               </a:rPr>
-              <a:t>Xếp</a:t>
-            </a:r>
-            <a:r>
-              <a:rPr lang="en-US" sz="7500" dirty="0" spc="3" kern="0">
+              <a:t>Ba</a:t>
+            </a:r>
+            <a:r>
+              <a:rPr lang="en-US" sz="7500" dirty="0" spc="-1" kern="0">
                 <a:solidFill>
                   <a:srgbClr val="F3EEE3"/>
                 </a:solidFill>
@@ -11106,7 +11095,18 @@
                 <a:ea typeface="Bricolage Grotesque ExtraBold" pitchFamily="34" charset="-122"/>
                 <a:cs typeface="Bricolage Grotesque ExtraBold" pitchFamily="34" charset="-120"/>
               </a:rPr>
-              <a:t> hạng</a:t>
+              <a:t> thuật</a:t>
+            </a:r>
+            <a:r>
+              <a:rPr lang="en-US" sz="7500" dirty="0" spc="-35" kern="0">
+                <a:solidFill>
+                  <a:srgbClr val="F3EEE3"/>
+                </a:solidFill>
+                <a:latin typeface="Bricolage Grotesque ExtraBold" pitchFamily="34" charset="0"/>
+                <a:ea typeface="Bricolage Grotesque ExtraBold" pitchFamily="34" charset="-122"/>
+                <a:cs typeface="Bricolage Grotesque ExtraBold" pitchFamily="34" charset="-120"/>
+              </a:rPr>
+              <a:t> toán</a:t>
             </a:r>
             <a:endParaRPr lang="en-US" sz="7500" dirty="0"/>
           </a:p>
@@ -11118,7 +11118,7 @@
               <a:buNone/>
             </a:pPr>
             <a:r>
-              <a:rPr lang="en-US" sz="7500" dirty="0" spc="2" kern="0">
+              <a:rPr lang="en-US" sz="7500" dirty="0" spc="-16" kern="0">
                 <a:solidFill>
                   <a:srgbClr val="F3EEE3"/>
                 </a:solidFill>
@@ -11126,10 +11126,10 @@
                 <a:ea typeface="Bricolage Grotesque ExtraBold" pitchFamily="34" charset="-122"/>
                 <a:cs typeface="Bricolage Grotesque ExtraBold" pitchFamily="34" charset="-120"/>
               </a:rPr>
-              <a:t>khách</a:t>
-            </a:r>
-            <a:r>
-              <a:rPr lang="en-US" sz="7500" dirty="0" spc="1" kern="0">
+              <a:t>trong</a:t>
+            </a:r>
+            <a:r>
+              <a:rPr lang="en-US" sz="7500" dirty="0" spc="0" kern="0">
                 <a:solidFill>
                   <a:srgbClr val="F3EEE3"/>
                 </a:solidFill>
@@ -11137,7 +11137,7 @@
                 <a:ea typeface="Bricolage Grotesque ExtraBold" pitchFamily="34" charset="-122"/>
                 <a:cs typeface="Bricolage Grotesque ExtraBold" pitchFamily="34" charset="-120"/>
               </a:rPr>
-              <a:t> quan</a:t>
+              <a:t> hệ</a:t>
             </a:r>
             <a:endParaRPr lang="en-US" sz="7500" dirty="0"/>
           </a:p>
@@ -11149,7 +11149,7 @@
               <a:buNone/>
             </a:pPr>
             <a:r>
-              <a:rPr lang="en-US" sz="7500" dirty="0" spc="-44" kern="0">
+              <a:rPr lang="en-US" sz="7500" dirty="0" spc="2" kern="0">
                 <a:solidFill>
                   <a:srgbClr val="F3EEE3"/>
                 </a:solidFill>
@@ -11157,7 +11157,7 @@
                 <a:ea typeface="Bricolage Grotesque ExtraBold" pitchFamily="34" charset="-122"/>
                 <a:cs typeface="Bricolage Grotesque ExtraBold" pitchFamily="34" charset="-120"/>
               </a:rPr>
-              <a:t>rất</a:t>
+              <a:t>thống</a:t>
             </a:r>
             <a:r>
               <a:rPr lang="en-US" sz="7500" dirty="0" spc="-1" kern="0">
@@ -11168,7 +11168,7 @@
                 <a:ea typeface="Bricolage Grotesque ExtraBold" pitchFamily="34" charset="-122"/>
                 <a:cs typeface="Bricolage Grotesque ExtraBold" pitchFamily="34" charset="-120"/>
               </a:rPr>
-              <a:t> khó</a:t>
+              <a:t> thật</a:t>
             </a:r>
             <a:endParaRPr lang="en-US" sz="7500" dirty="0"/>
           </a:p>
@@ -11296,285 +11296,132 @@
           <a:ln/>
         </p:spPr>
         <p:txBody>
-          <a:bodyPr wrap="square" lIns="0" tIns="15383" rIns="0" bIns="-15383" rtlCol="0" anchor="ctr"/>
+          <a:bodyPr wrap="square" lIns="0" tIns="14573" rIns="0" bIns="-14573" rtlCol="0" anchor="ctr"/>
           <a:lstStyle/>
           <a:p>
             <a:pPr algn="l" indent="0" marL="0">
               <a:lnSpc>
-                <a:spcPts val="3705"/>
+                <a:spcPts val="3510"/>
               </a:lnSpc>
               <a:buNone/>
             </a:pPr>
             <a:r>
-              <a:rPr lang="en-US" sz="2850" b="1" dirty="0" spc="-41" kern="0">
-                <a:solidFill>
-                  <a:srgbClr val="F3EEE3"/>
-                </a:solidFill>
-                <a:latin typeface="Be Vietnam Pro" pitchFamily="34" charset="0"/>
-                <a:ea typeface="Be Vietnam Pro" pitchFamily="34" charset="-122"/>
-                <a:cs typeface="Be Vietnam Pro" pitchFamily="34" charset="-120"/>
-              </a:rPr>
-              <a:t>Xếp</a:t>
-            </a:r>
-            <a:r>
-              <a:rPr lang="en-US" sz="2850" b="1" dirty="0" spc="-3" kern="0">
-                <a:solidFill>
-                  <a:srgbClr val="F3EEE3"/>
-                </a:solidFill>
-                <a:latin typeface="Be Vietnam Pro" pitchFamily="34" charset="0"/>
-                <a:ea typeface="Be Vietnam Pro" pitchFamily="34" charset="-122"/>
-                <a:cs typeface="Be Vietnam Pro" pitchFamily="34" charset="-120"/>
-              </a:rPr>
-              <a:t> hạng</a:t>
-            </a:r>
-            <a:r>
-              <a:rPr lang="en-US" sz="2850" b="1" dirty="0" spc="-4" kern="0">
-                <a:solidFill>
-                  <a:srgbClr val="F3EEE3"/>
-                </a:solidFill>
-                <a:latin typeface="Be Vietnam Pro" pitchFamily="34" charset="0"/>
-                <a:ea typeface="Be Vietnam Pro" pitchFamily="34" charset="-122"/>
-                <a:cs typeface="Be Vietnam Pro" pitchFamily="34" charset="-120"/>
-              </a:rPr>
-              <a:t> thuật toán</a:t>
-            </a:r>
-            <a:r>
-              <a:rPr lang="en-US" sz="2850" b="1" dirty="0" spc="-6" kern="0">
-                <a:solidFill>
-                  <a:srgbClr val="F3EEE3"/>
-                </a:solidFill>
-                <a:latin typeface="Be Vietnam Pro" pitchFamily="34" charset="0"/>
-                <a:ea typeface="Be Vietnam Pro" pitchFamily="34" charset="-122"/>
-                <a:cs typeface="Be Vietnam Pro" pitchFamily="34" charset="-120"/>
-              </a:rPr>
-              <a:t> theo</a:t>
-            </a:r>
-            <a:r>
-              <a:rPr lang="en-US" sz="2850" b="1" dirty="0" spc="9" kern="0">
-                <a:solidFill>
-                  <a:srgbClr val="F3EEE3"/>
-                </a:solidFill>
-                <a:latin typeface="Be Vietnam Pro" pitchFamily="34" charset="0"/>
-                <a:ea typeface="Be Vietnam Pro" pitchFamily="34" charset="-122"/>
-                <a:cs typeface="Be Vietnam Pro" pitchFamily="34" charset="-120"/>
-              </a:rPr>
-              <a:t> độ</a:t>
-            </a:r>
-            <a:r>
-              <a:rPr lang="en-US" sz="2850" b="1" dirty="0" spc="5" kern="0">
-                <a:solidFill>
-                  <a:srgbClr val="F3EEE3"/>
-                </a:solidFill>
-                <a:latin typeface="Be Vietnam Pro" pitchFamily="34" charset="0"/>
-                <a:ea typeface="Be Vietnam Pro" pitchFamily="34" charset="-122"/>
-                <a:cs typeface="Be Vietnam Pro" pitchFamily="34" charset="-120"/>
-              </a:rPr>
-              <a:t> quan</a:t>
-            </a:r>
-            <a:r>
-              <a:rPr lang="en-US" sz="2850" b="1" dirty="0" spc="-15" kern="0">
-                <a:solidFill>
-                  <a:srgbClr val="F3EEE3"/>
-                </a:solidFill>
-                <a:latin typeface="Be Vietnam Pro" pitchFamily="34" charset="0"/>
-                <a:ea typeface="Be Vietnam Pro" pitchFamily="34" charset="-122"/>
-                <a:cs typeface="Be Vietnam Pro" pitchFamily="34" charset="-120"/>
-              </a:rPr>
-              <a:t> trọng</a:t>
-            </a:r>
-            <a:endParaRPr lang="en-US" sz="2850" dirty="0"/>
+              <a:rPr lang="en-US" sz="2700" b="1" dirty="0" spc="2" kern="0">
+                <a:solidFill>
+                  <a:srgbClr val="F3EEE3"/>
+                </a:solidFill>
+                <a:latin typeface="Be Vietnam Pro" pitchFamily="34" charset="0"/>
+                <a:ea typeface="Be Vietnam Pro" pitchFamily="34" charset="-122"/>
+                <a:cs typeface="Be Vietnam Pro" pitchFamily="34" charset="-120"/>
+              </a:rPr>
+              <a:t>Bộ</a:t>
+            </a:r>
+            <a:r>
+              <a:rPr lang="en-US" sz="2700" b="1" dirty="0" spc="-8" kern="0">
+                <a:solidFill>
+                  <a:srgbClr val="F3EEE3"/>
+                </a:solidFill>
+                <a:latin typeface="Be Vietnam Pro" pitchFamily="34" charset="0"/>
+                <a:ea typeface="Be Vietnam Pro" pitchFamily="34" charset="-122"/>
+                <a:cs typeface="Be Vietnam Pro" pitchFamily="34" charset="-120"/>
+              </a:rPr>
+              <a:t> lọc</a:t>
+            </a:r>
+            <a:r>
+              <a:rPr lang="en-US" sz="2700" b="1" dirty="0" spc="-6" kern="0">
+                <a:solidFill>
+                  <a:srgbClr val="F3EEE3"/>
+                </a:solidFill>
+                <a:latin typeface="Be Vietnam Pro" pitchFamily="34" charset="0"/>
+                <a:ea typeface="Be Vietnam Pro" pitchFamily="34" charset="-122"/>
+                <a:cs typeface="Be Vietnam Pro" pitchFamily="34" charset="-120"/>
+              </a:rPr>
+              <a:t> Bloom:</a:t>
+            </a:r>
+            <a:r>
+              <a:rPr lang="en-US" sz="2700" b="1" dirty="0" spc="-9" kern="0">
+                <a:solidFill>
+                  <a:srgbClr val="F3EEE3"/>
+                </a:solidFill>
+                <a:latin typeface="Be Vietnam Pro" pitchFamily="34" charset="0"/>
+                <a:ea typeface="Be Vietnam Pro" pitchFamily="34" charset="-122"/>
+                <a:cs typeface="Be Vietnam Pro" pitchFamily="34" charset="-120"/>
+              </a:rPr>
+              <a:t> Cassandra</a:t>
+            </a:r>
+            <a:r>
+              <a:rPr lang="en-US" sz="2700" b="1" dirty="0" spc="-3" kern="0">
+                <a:solidFill>
+                  <a:srgbClr val="F3EEE3"/>
+                </a:solidFill>
+                <a:latin typeface="Be Vietnam Pro" pitchFamily="34" charset="0"/>
+                <a:ea typeface="Be Vietnam Pro" pitchFamily="34" charset="-122"/>
+                <a:cs typeface="Be Vietnam Pro" pitchFamily="34" charset="-120"/>
+              </a:rPr>
+              <a:t> bỏ</a:t>
+            </a:r>
+            <a:r>
+              <a:rPr lang="en-US" sz="2700" b="1" dirty="0" spc="0" kern="0">
+                <a:solidFill>
+                  <a:srgbClr val="F3EEE3"/>
+                </a:solidFill>
+                <a:latin typeface="Be Vietnam Pro" pitchFamily="34" charset="0"/>
+                <a:ea typeface="Be Vietnam Pro" pitchFamily="34" charset="-122"/>
+                <a:cs typeface="Be Vietnam Pro" pitchFamily="34" charset="-120"/>
+              </a:rPr>
+              <a:t> qua</a:t>
+            </a:r>
+            <a:r>
+              <a:rPr lang="en-US" sz="2700" b="1" dirty="0" spc="-9" kern="0">
+                <a:solidFill>
+                  <a:srgbClr val="F3EEE3"/>
+                </a:solidFill>
+                <a:latin typeface="Be Vietnam Pro" pitchFamily="34" charset="0"/>
+                <a:ea typeface="Be Vietnam Pro" pitchFamily="34" charset="-122"/>
+                <a:cs typeface="Be Vietnam Pro" pitchFamily="34" charset="-120"/>
+              </a:rPr>
+              <a:t> tệp</a:t>
+            </a:r>
+            <a:r>
+              <a:rPr lang="en-US" sz="2700" b="1" dirty="0" spc="-6" kern="0">
+                <a:solidFill>
+                  <a:srgbClr val="F3EEE3"/>
+                </a:solidFill>
+                <a:latin typeface="Be Vietnam Pro" pitchFamily="34" charset="0"/>
+                <a:ea typeface="Be Vietnam Pro" pitchFamily="34" charset="-122"/>
+                <a:cs typeface="Be Vietnam Pro" pitchFamily="34" charset="-120"/>
+              </a:rPr>
+              <a:t> không</a:t>
+            </a:r>
+            <a:r>
+              <a:rPr lang="en-US" sz="2700" b="1" dirty="0" spc="11" kern="0">
+                <a:solidFill>
+                  <a:srgbClr val="F3EEE3"/>
+                </a:solidFill>
+                <a:latin typeface="Be Vietnam Pro" pitchFamily="34" charset="0"/>
+                <a:ea typeface="Be Vietnam Pro" pitchFamily="34" charset="-122"/>
+                <a:cs typeface="Be Vietnam Pro" pitchFamily="34" charset="-120"/>
+              </a:rPr>
+              <a:t> chứa</a:t>
+            </a:r>
+            <a:r>
+              <a:rPr lang="en-US" sz="2700" b="1" dirty="0" spc="-5" kern="0">
+                <a:solidFill>
+                  <a:srgbClr val="F3EEE3"/>
+                </a:solidFill>
+                <a:latin typeface="Be Vietnam Pro" pitchFamily="34" charset="0"/>
+                <a:ea typeface="Be Vietnam Pro" pitchFamily="34" charset="-122"/>
+                <a:cs typeface="Be Vietnam Pro" pitchFamily="34" charset="-120"/>
+              </a:rPr>
+              <a:t> khóa</a:t>
+            </a:r>
+            <a:endParaRPr lang="en-US" sz="2700" dirty="0"/>
           </a:p>
         </p:txBody>
       </p:sp>
       <p:sp>
         <p:nvSpPr>
-          <p:cNvPr id="9" name="Shape 7"/>
-          <p:cNvSpPr/>
-          <p:nvPr/>
-        </p:nvSpPr>
-        <p:spPr>
-          <a:xfrm>
-            <a:off x="15080671" y="1952625"/>
-            <a:ext cx="471058" cy="448003"/>
-          </a:xfrm>
-          <a:custGeom>
-            <a:avLst/>
-            <a:gdLst/>
-            <a:ahLst/>
-            <a:cxnLst/>
-            <a:rect l="l" t="t" r="r" b="b"/>
-            <a:pathLst>
-              <a:path w="471058" h="448003">
-                <a:moveTo>
-                  <a:pt x="235529" y="0"/>
-                </a:moveTo>
-                <a:lnTo>
-                  <a:pt x="293755" y="167509"/>
-                </a:lnTo>
-                <a:lnTo>
-                  <a:pt x="471058" y="171122"/>
-                </a:lnTo>
-                <a:lnTo>
-                  <a:pt x="329741" y="278261"/>
-                </a:lnTo>
-                <a:lnTo>
-                  <a:pt x="381094" y="448003"/>
-                </a:lnTo>
-                <a:lnTo>
-                  <a:pt x="235529" y="346710"/>
-                </a:lnTo>
-                <a:lnTo>
-                  <a:pt x="89964" y="448003"/>
-                </a:lnTo>
-                <a:lnTo>
-                  <a:pt x="141317" y="278261"/>
-                </a:lnTo>
-                <a:lnTo>
-                  <a:pt x="0" y="171122"/>
-                </a:lnTo>
-                <a:lnTo>
-                  <a:pt x="177303" y="167509"/>
-                </a:lnTo>
-                <a:lnTo>
-                  <a:pt x="235529" y="0"/>
-                </a:lnTo>
-                <a:close/>
-              </a:path>
-            </a:pathLst>
-          </a:custGeom>
-          <a:solidFill>
-            <a:srgbClr val="7C93FF"/>
-          </a:solidFill>
-          <a:ln/>
-        </p:spPr>
-      </p:sp>
-      <p:sp>
-        <p:nvSpPr>
-          <p:cNvPr id="10" name="Shape 8"/>
-          <p:cNvSpPr/>
-          <p:nvPr/>
-        </p:nvSpPr>
-        <p:spPr>
-          <a:xfrm>
-            <a:off x="15690271" y="1952625"/>
-            <a:ext cx="471058" cy="448003"/>
-          </a:xfrm>
-          <a:custGeom>
-            <a:avLst/>
-            <a:gdLst/>
-            <a:ahLst/>
-            <a:cxnLst/>
-            <a:rect l="l" t="t" r="r" b="b"/>
-            <a:pathLst>
-              <a:path w="471058" h="448003">
-                <a:moveTo>
-                  <a:pt x="235529" y="0"/>
-                </a:moveTo>
-                <a:lnTo>
-                  <a:pt x="293755" y="167509"/>
-                </a:lnTo>
-                <a:lnTo>
-                  <a:pt x="471058" y="171122"/>
-                </a:lnTo>
-                <a:lnTo>
-                  <a:pt x="329741" y="278261"/>
-                </a:lnTo>
-                <a:lnTo>
-                  <a:pt x="381094" y="448003"/>
-                </a:lnTo>
-                <a:lnTo>
-                  <a:pt x="235529" y="346710"/>
-                </a:lnTo>
-                <a:lnTo>
-                  <a:pt x="89964" y="448003"/>
-                </a:lnTo>
-                <a:lnTo>
-                  <a:pt x="141317" y="278261"/>
-                </a:lnTo>
-                <a:lnTo>
-                  <a:pt x="0" y="171122"/>
-                </a:lnTo>
-                <a:lnTo>
-                  <a:pt x="177303" y="167509"/>
-                </a:lnTo>
-                <a:lnTo>
-                  <a:pt x="235529" y="0"/>
-                </a:lnTo>
-                <a:close/>
-              </a:path>
-            </a:pathLst>
-          </a:custGeom>
-          <a:solidFill>
-            <a:srgbClr val="FFB454"/>
-          </a:solidFill>
-          <a:ln/>
-        </p:spPr>
-      </p:sp>
-      <p:sp>
-        <p:nvSpPr>
-          <p:cNvPr id="11" name="Shape 9"/>
-          <p:cNvSpPr/>
-          <p:nvPr/>
-        </p:nvSpPr>
-        <p:spPr>
-          <a:xfrm>
-            <a:off x="16299871" y="1952625"/>
-            <a:ext cx="471058" cy="448003"/>
-          </a:xfrm>
-          <a:custGeom>
-            <a:avLst/>
-            <a:gdLst/>
-            <a:ahLst/>
-            <a:cxnLst/>
-            <a:rect l="l" t="t" r="r" b="b"/>
-            <a:pathLst>
-              <a:path w="471058" h="448003">
-                <a:moveTo>
-                  <a:pt x="235529" y="0"/>
-                </a:moveTo>
-                <a:lnTo>
-                  <a:pt x="293755" y="167509"/>
-                </a:lnTo>
-                <a:lnTo>
-                  <a:pt x="471058" y="171122"/>
-                </a:lnTo>
-                <a:lnTo>
-                  <a:pt x="329741" y="278261"/>
-                </a:lnTo>
-                <a:lnTo>
-                  <a:pt x="381094" y="448003"/>
-                </a:lnTo>
-                <a:lnTo>
-                  <a:pt x="235529" y="346710"/>
-                </a:lnTo>
-                <a:lnTo>
-                  <a:pt x="89964" y="448003"/>
-                </a:lnTo>
-                <a:lnTo>
-                  <a:pt x="141317" y="278261"/>
-                </a:lnTo>
-                <a:lnTo>
-                  <a:pt x="0" y="171122"/>
-                </a:lnTo>
-                <a:lnTo>
-                  <a:pt x="177303" y="167509"/>
-                </a:lnTo>
-                <a:lnTo>
-                  <a:pt x="235529" y="0"/>
-                </a:lnTo>
-                <a:close/>
-              </a:path>
-            </a:pathLst>
-          </a:custGeom>
-          <a:solidFill>
-            <a:srgbClr val="3DD6A0"/>
-          </a:solidFill>
-          <a:ln/>
-        </p:spPr>
-      </p:sp>
-      <p:sp>
-        <p:nvSpPr>
-          <p:cNvPr id="12" name="Connector line-1792338444901-176477059"/>
+          <p:cNvPr id="9" name="Connector line-1792338444901-176477059"/>
           <p:cNvSpPr/>
           <p:nvPr/>
         </p:nvSpPr>
@@ -11599,7 +11446,7 @@
       </p:sp>
       <p:sp>
         <p:nvSpPr>
-          <p:cNvPr id="13" name="Shape 11"/>
+          <p:cNvPr id="10" name="Shape 8"/>
           <p:cNvSpPr/>
           <p:nvPr/>
         </p:nvSpPr>
@@ -11626,7 +11473,7 @@
       </p:sp>
       <p:sp>
         <p:nvSpPr>
-          <p:cNvPr id="14" name="Text 12"/>
+          <p:cNvPr id="11" name="Text 9"/>
           <p:cNvSpPr/>
           <p:nvPr/>
         </p:nvSpPr>
@@ -11649,7 +11496,7 @@
               <a:buNone/>
             </a:pPr>
             <a:r>
-              <a:rPr lang="en-US" sz="1800" b="1" spc="145" kern="0" dirty="0">
+              <a:rPr lang="en-US" sz="1800" b="1" spc="218" kern="0" dirty="0">
                 <a:solidFill>
                   <a:srgbClr val="FF6A4D"/>
                 </a:solidFill>
@@ -11657,10 +11504,10 @@
                 <a:ea typeface="Be Vietnam Pro" pitchFamily="34" charset="-122"/>
                 <a:cs typeface="Be Vietnam Pro" pitchFamily="34" charset="-120"/>
               </a:rPr>
-              <a:t>TÁC</a:t>
-            </a:r>
-            <a:r>
-              <a:rPr lang="en-US" sz="1800" b="1" spc="223" kern="0" dirty="0">
+              <a:t>BĂM</a:t>
+            </a:r>
+            <a:r>
+              <a:rPr lang="en-US" sz="1800" b="1" spc="188" kern="0" dirty="0">
                 <a:solidFill>
                   <a:srgbClr val="FF6A4D"/>
                 </a:solidFill>
@@ -11668,10 +11515,10 @@
                 <a:ea typeface="Be Vietnam Pro" pitchFamily="34" charset="-122"/>
                 <a:cs typeface="Be Vietnam Pro" pitchFamily="34" charset="-120"/>
               </a:rPr>
-              <a:t> GIẢ</a:t>
-            </a:r>
-            <a:r>
-              <a:rPr lang="en-US" sz="1800" b="1" spc="226" kern="0" dirty="0">
+              <a:t> NHẤT</a:t>
+            </a:r>
+            <a:r>
+              <a:rPr lang="en-US" sz="1800" b="1" spc="216" kern="0" dirty="0">
                 <a:solidFill>
                   <a:srgbClr val="FF6A4D"/>
                 </a:solidFill>
@@ -11679,18 +11526,7 @@
                 <a:ea typeface="Be Vietnam Pro" pitchFamily="34" charset="-122"/>
                 <a:cs typeface="Be Vietnam Pro" pitchFamily="34" charset="-120"/>
               </a:rPr>
-              <a:t> THỪA</a:t>
-            </a:r>
-            <a:r>
-              <a:rPr lang="en-US" sz="1800" b="1" spc="225" kern="0" dirty="0">
-                <a:solidFill>
-                  <a:srgbClr val="FF6A4D"/>
-                </a:solidFill>
-                <a:latin typeface="Be Vietnam Pro" pitchFamily="34" charset="0"/>
-                <a:ea typeface="Be Vietnam Pro" pitchFamily="34" charset="-122"/>
-                <a:cs typeface="Be Vietnam Pro" pitchFamily="34" charset="-120"/>
-              </a:rPr>
-              <a:t> NHẬN</a:t>
+              <a:t> QUÁN</a:t>
             </a:r>
             <a:endParaRPr lang="en-US" sz="1800" dirty="0"/>
           </a:p>
@@ -11698,7 +11534,7 @@
       </p:sp>
       <p:sp>
         <p:nvSpPr>
-          <p:cNvPr id="15" name="Text 13"/>
+          <p:cNvPr id="12" name="Text 10"/>
           <p:cNvSpPr/>
           <p:nvPr/>
         </p:nvSpPr>
@@ -11724,15 +11560,15 @@
               <a:buNone/>
             </a:pPr>
             <a:r>
-              <a:rPr lang="en-US" sz="3000" b="1" dirty="0" spc="-58" kern="0">
-                <a:solidFill>
-                  <a:srgbClr val="F3EEE3"/>
-                </a:solidFill>
-                <a:latin typeface="Be Vietnam Pro" pitchFamily="34" charset="0"/>
-                <a:ea typeface="Be Vietnam Pro" pitchFamily="34" charset="-122"/>
-                <a:cs typeface="Be Vietnam Pro" pitchFamily="34" charset="-120"/>
-              </a:rPr>
-              <a:t>Rất</a:t>
+              <a:rPr lang="en-US" sz="3000" b="1" dirty="0" spc="1" kern="0">
+                <a:solidFill>
+                  <a:srgbClr val="F3EEE3"/>
+                </a:solidFill>
+                <a:latin typeface="Be Vietnam Pro" pitchFamily="34" charset="0"/>
+                <a:ea typeface="Be Vietnam Pro" pitchFamily="34" charset="-122"/>
+                <a:cs typeface="Be Vietnam Pro" pitchFamily="34" charset="-120"/>
+              </a:rPr>
+              <a:t>Đổi</a:t>
             </a:r>
             <a:r>
               <a:rPr lang="en-US" sz="3000" b="1" dirty="0" spc="-5" kern="0">
@@ -11743,43 +11579,32 @@
                 <a:ea typeface="Be Vietnam Pro" pitchFamily="34" charset="-122"/>
                 <a:cs typeface="Be Vietnam Pro" pitchFamily="34" charset="-120"/>
               </a:rPr>
-              <a:t> khó</a:t>
-            </a:r>
-            <a:r>
-              <a:rPr lang="en-US" sz="3000" b="1" dirty="0" spc="-1" kern="0">
-                <a:solidFill>
-                  <a:srgbClr val="F3EEE3"/>
-                </a:solidFill>
-                <a:latin typeface="Be Vietnam Pro" pitchFamily="34" charset="0"/>
-                <a:ea typeface="Be Vietnam Pro" pitchFamily="34" charset="-122"/>
-                <a:cs typeface="Be Vietnam Pro" pitchFamily="34" charset="-120"/>
-              </a:rPr>
-              <a:t> làm</a:t>
-            </a:r>
-            <a:r>
-              <a:rPr lang="en-US" sz="3000" b="1" dirty="0" spc="19" kern="0">
-                <a:solidFill>
-                  <a:srgbClr val="F3EEE3"/>
-                </a:solidFill>
-                <a:latin typeface="Be Vietnam Pro" pitchFamily="34" charset="0"/>
-                <a:ea typeface="Be Vietnam Pro" pitchFamily="34" charset="-122"/>
-                <a:cs typeface="Be Vietnam Pro" pitchFamily="34" charset="-120"/>
-              </a:rPr>
-              <a:t> điều</a:t>
-            </a:r>
-            <a:r>
-              <a:rPr lang="en-US" sz="3000" b="1" dirty="0" spc="10" kern="0">
-                <a:solidFill>
-                  <a:srgbClr val="F3EEE3"/>
-                </a:solidFill>
-                <a:latin typeface="Be Vietnam Pro" pitchFamily="34" charset="0"/>
-                <a:ea typeface="Be Vietnam Pro" pitchFamily="34" charset="-122"/>
-                <a:cs typeface="Be Vietnam Pro" pitchFamily="34" charset="-120"/>
-              </a:rPr>
-              <a:t> đó</a:t>
-            </a:r>
-            <a:r>
-              <a:rPr lang="en-US" sz="3000" b="1" dirty="0" spc="-11" kern="0">
+              <a:t> số</a:t>
+            </a:r>
+            <a:r>
+              <a:rPr lang="en-US" sz="3000" b="1" dirty="0" spc="1" kern="0">
+                <a:solidFill>
+                  <a:srgbClr val="F3EEE3"/>
+                </a:solidFill>
+                <a:latin typeface="Be Vietnam Pro" pitchFamily="34" charset="0"/>
+                <a:ea typeface="Be Vietnam Pro" pitchFamily="34" charset="-122"/>
+                <a:cs typeface="Be Vietnam Pro" pitchFamily="34" charset="-120"/>
+              </a:rPr>
+              <a:t> nút chỉ</a:t>
+            </a:r>
+            <a:r>
+              <a:rPr lang="en-US" sz="3000" b="1" dirty="0" spc="-16" kern="0">
+                <a:solidFill>
+                  <a:srgbClr val="F3EEE3"/>
+                </a:solidFill>
+                <a:latin typeface="Be Vietnam Pro" pitchFamily="34" charset="0"/>
+                <a:ea typeface="Be Vietnam Pro" pitchFamily="34" charset="-122"/>
+                <a:cs typeface="Be Vietnam Pro" pitchFamily="34" charset="-120"/>
+              </a:rPr>
+              <a:t> chuyển</a:t>
+            </a:r>
+            <a:r>
+              <a:rPr lang="en-US" sz="3000" b="1" dirty="0" spc="-10" kern="0">
                 <a:solidFill>
                   <a:srgbClr val="F3EEE3"/>
                 </a:solidFill>
@@ -11790,26 +11615,37 @@
               <a:t> một</a:t>
             </a:r>
             <a:r>
-              <a:rPr lang="en-US" sz="3000" b="1" dirty="0" spc="0" kern="0">
-                <a:solidFill>
-                  <a:srgbClr val="F3EEE3"/>
-                </a:solidFill>
-                <a:latin typeface="Be Vietnam Pro" pitchFamily="34" charset="0"/>
-                <a:ea typeface="Be Vietnam Pro" pitchFamily="34" charset="-122"/>
-                <a:cs typeface="Be Vietnam Pro" pitchFamily="34" charset="-120"/>
-              </a:rPr>
-              <a:t> cách khách</a:t>
-            </a:r>
-            <a:r>
-              <a:rPr lang="en-US" sz="3000" b="1" dirty="0" spc="2" kern="0">
-                <a:solidFill>
-                  <a:srgbClr val="F3EEE3"/>
-                </a:solidFill>
-                <a:latin typeface="Be Vietnam Pro" pitchFamily="34" charset="0"/>
-                <a:ea typeface="Be Vietnam Pro" pitchFamily="34" charset="-122"/>
-                <a:cs typeface="Be Vietnam Pro" pitchFamily="34" charset="-120"/>
-              </a:rPr>
-              <a:t> quan</a:t>
+              <a:rPr lang="en-US" sz="3000" b="1" dirty="0" spc="-5" kern="0">
+                <a:solidFill>
+                  <a:srgbClr val="F3EEE3"/>
+                </a:solidFill>
+                <a:latin typeface="Be Vietnam Pro" pitchFamily="34" charset="0"/>
+                <a:ea typeface="Be Vietnam Pro" pitchFamily="34" charset="-122"/>
+                <a:cs typeface="Be Vietnam Pro" pitchFamily="34" charset="-120"/>
+              </a:rPr>
+              <a:t> phần</a:t>
+            </a:r>
+            <a:r>
+              <a:rPr lang="en-US" sz="3000" b="1" dirty="0" spc="-6" kern="0">
+                <a:solidFill>
+                  <a:srgbClr val="F3EEE3"/>
+                </a:solidFill>
+                <a:latin typeface="Be Vietnam Pro" pitchFamily="34" charset="0"/>
+                <a:ea typeface="Be Vietnam Pro" pitchFamily="34" charset="-122"/>
+                <a:cs typeface="Be Vietnam Pro" pitchFamily="34" charset="-120"/>
+              </a:rPr>
+              <a:t> nhỏ</a:t>
+            </a:r>
+            <a:r>
+              <a:rPr lang="en-US" sz="3000" b="1" dirty="0" spc="-8" kern="0">
+                <a:solidFill>
+                  <a:srgbClr val="F3EEE3"/>
+                </a:solidFill>
+                <a:latin typeface="Be Vietnam Pro" pitchFamily="34" charset="0"/>
+                <a:ea typeface="Be Vietnam Pro" pitchFamily="34" charset="-122"/>
+                <a:cs typeface="Be Vietnam Pro" pitchFamily="34" charset="-120"/>
+              </a:rPr>
+              <a:t> khóa</a:t>
             </a:r>
             <a:endParaRPr lang="en-US" sz="3000" dirty="0"/>
           </a:p>
@@ -11817,7 +11653,7 @@
       </p:sp>
       <p:sp>
         <p:nvSpPr>
-          <p:cNvPr id="16" name="Connector line-1792338444906-94315203"/>
+          <p:cNvPr id="13" name="Connector line-1792338444906-94315203"/>
           <p:cNvSpPr/>
           <p:nvPr/>
         </p:nvSpPr>
@@ -11842,7 +11678,7 @@
       </p:sp>
       <p:sp>
         <p:nvSpPr>
-          <p:cNvPr id="17" name="Shape 15"/>
+          <p:cNvPr id="14" name="Shape 12"/>
           <p:cNvSpPr/>
           <p:nvPr/>
         </p:nvSpPr>
@@ -11864,7 +11700,7 @@
       </p:sp>
       <p:sp>
         <p:nvSpPr>
-          <p:cNvPr id="18" name="Text 16"/>
+          <p:cNvPr id="15" name="Text 13"/>
           <p:cNvSpPr/>
           <p:nvPr/>
         </p:nvSpPr>
@@ -11887,37 +11723,15 @@
               <a:buNone/>
             </a:pPr>
             <a:r>
-              <a:rPr lang="en-US" sz="1800" b="1" spc="145" kern="0" dirty="0">
-                <a:solidFill>
-                  <a:srgbClr val="14161C"/>
-                </a:solidFill>
-                <a:latin typeface="Be Vietnam Pro" pitchFamily="34" charset="0"/>
-                <a:ea typeface="Be Vietnam Pro" pitchFamily="34" charset="-122"/>
-                <a:cs typeface="Be Vietnam Pro" pitchFamily="34" charset="-120"/>
-              </a:rPr>
-              <a:t>TÁC</a:t>
-            </a:r>
-            <a:r>
-              <a:rPr lang="en-US" sz="1800" b="1" spc="223" kern="0" dirty="0">
-                <a:solidFill>
-                  <a:srgbClr val="14161C"/>
-                </a:solidFill>
-                <a:latin typeface="Be Vietnam Pro" pitchFamily="34" charset="0"/>
-                <a:ea typeface="Be Vietnam Pro" pitchFamily="34" charset="-122"/>
-                <a:cs typeface="Be Vietnam Pro" pitchFamily="34" charset="-120"/>
-              </a:rPr>
-              <a:t> GIẢ</a:t>
-            </a:r>
-            <a:r>
-              <a:rPr lang="en-US" sz="1800" b="1" spc="225" kern="0" dirty="0">
-                <a:solidFill>
-                  <a:srgbClr val="14161C"/>
-                </a:solidFill>
-                <a:latin typeface="Be Vietnam Pro" pitchFamily="34" charset="0"/>
-                <a:ea typeface="Be Vietnam Pro" pitchFamily="34" charset="-122"/>
-                <a:cs typeface="Be Vietnam Pro" pitchFamily="34" charset="-120"/>
-              </a:rPr>
-              <a:t> NÓI</a:t>
+              <a:rPr lang="en-US" sz="1800" b="1" spc="221" kern="0" dirty="0">
+                <a:solidFill>
+                  <a:srgbClr val="14161C"/>
+                </a:solidFill>
+                <a:latin typeface="Be Vietnam Pro" pitchFamily="34" charset="0"/>
+                <a:ea typeface="Be Vietnam Pro" pitchFamily="34" charset="-122"/>
+                <a:cs typeface="Be Vietnam Pro" pitchFamily="34" charset="-120"/>
+              </a:rPr>
+              <a:t>RAFT</a:t>
             </a:r>
             <a:endParaRPr lang="en-US" sz="1800" dirty="0"/>
           </a:p>
@@ -11925,7 +11739,7 @@
       </p:sp>
       <p:sp>
         <p:nvSpPr>
-          <p:cNvPr id="19" name="Shape 17"/>
+          <p:cNvPr id="16" name="Shape 14"/>
           <p:cNvSpPr/>
           <p:nvPr/>
         </p:nvSpPr>
@@ -11950,7 +11764,7 @@
       </p:sp>
       <p:sp>
         <p:nvSpPr>
-          <p:cNvPr id="20" name="Shape 18"/>
+          <p:cNvPr id="17" name="Shape 15"/>
           <p:cNvSpPr/>
           <p:nvPr/>
         </p:nvSpPr>
@@ -11975,7 +11789,7 @@
       </p:sp>
       <p:sp>
         <p:nvSpPr>
-          <p:cNvPr id="21" name="Shape 19"/>
+          <p:cNvPr id="18" name="Shape 16"/>
           <p:cNvSpPr/>
           <p:nvPr/>
         </p:nvSpPr>
@@ -12000,7 +11814,7 @@
       </p:sp>
       <p:sp>
         <p:nvSpPr>
-          <p:cNvPr id="22" name="Shape 20"/>
+          <p:cNvPr id="19" name="Shape 17"/>
           <p:cNvSpPr/>
           <p:nvPr/>
         </p:nvSpPr>
@@ -12025,7 +11839,7 @@
       </p:sp>
       <p:sp>
         <p:nvSpPr>
-          <p:cNvPr id="23" name="Shape 21"/>
+          <p:cNvPr id="20" name="Shape 18"/>
           <p:cNvSpPr/>
           <p:nvPr/>
         </p:nvSpPr>
@@ -12050,7 +11864,7 @@
       </p:sp>
       <p:sp>
         <p:nvSpPr>
-          <p:cNvPr id="24" name="Shape 22"/>
+          <p:cNvPr id="21" name="Shape 19"/>
           <p:cNvSpPr/>
           <p:nvPr/>
         </p:nvSpPr>
@@ -12075,7 +11889,7 @@
       </p:sp>
       <p:sp>
         <p:nvSpPr>
-          <p:cNvPr id="25" name="Shape 23"/>
+          <p:cNvPr id="22" name="Shape 20"/>
           <p:cNvSpPr/>
           <p:nvPr/>
         </p:nvSpPr>
@@ -12100,7 +11914,7 @@
       </p:sp>
       <p:sp>
         <p:nvSpPr>
-          <p:cNvPr id="26" name="Shape 24"/>
+          <p:cNvPr id="23" name="Shape 21"/>
           <p:cNvSpPr/>
           <p:nvPr/>
         </p:nvSpPr>
@@ -12125,7 +11939,7 @@
       </p:sp>
       <p:sp>
         <p:nvSpPr>
-          <p:cNvPr id="27" name="Text 25"/>
+          <p:cNvPr id="24" name="Text 22"/>
           <p:cNvSpPr/>
           <p:nvPr/>
         </p:nvSpPr>
@@ -12230,7 +12044,7 @@
       </p:sp>
       <p:sp>
         <p:nvSpPr>
-          <p:cNvPr id="28" name="Text 26"/>
+          <p:cNvPr id="25" name="Text 23"/>
           <p:cNvSpPr/>
           <p:nvPr/>
         </p:nvSpPr>
@@ -12256,50 +12070,6 @@
               <a:buNone/>
             </a:pPr>
             <a:r>
-              <a:rPr lang="en-US" sz="3000" b="1" dirty="0" spc="1" kern="0">
-                <a:solidFill>
-                  <a:srgbClr val="14161C"/>
-                </a:solidFill>
-                <a:latin typeface="Be Vietnam Pro" pitchFamily="34" charset="0"/>
-                <a:ea typeface="Be Vietnam Pro" pitchFamily="34" charset="-122"/>
-                <a:cs typeface="Be Vietnam Pro" pitchFamily="34" charset="-120"/>
-              </a:rPr>
-              <a:t>Sẵn</a:t>
-            </a:r>
-            <a:r>
-              <a:rPr lang="en-US" sz="3000" b="1" dirty="0" spc="-11" kern="0">
-                <a:solidFill>
-                  <a:srgbClr val="14161C"/>
-                </a:solidFill>
-                <a:latin typeface="Be Vietnam Pro" pitchFamily="34" charset="0"/>
-                <a:ea typeface="Be Vietnam Pro" pitchFamily="34" charset="-122"/>
-                <a:cs typeface="Be Vietnam Pro" pitchFamily="34" charset="-120"/>
-              </a:rPr>
-              <a:t> lòng</a:t>
-            </a:r>
-            <a:r>
-              <a:rPr lang="en-US" sz="3000" b="1" dirty="0" spc="-4" kern="0">
-                <a:solidFill>
-                  <a:srgbClr val="14161C"/>
-                </a:solidFill>
-                <a:latin typeface="Be Vietnam Pro" pitchFamily="34" charset="0"/>
-                <a:ea typeface="Be Vietnam Pro" pitchFamily="34" charset="-122"/>
-                <a:cs typeface="Be Vietnam Pro" pitchFamily="34" charset="-120"/>
-              </a:rPr>
-              <a:t> nhận</a:t>
-            </a:r>
-            <a:r>
-              <a:rPr lang="en-US" sz="3000" b="1" dirty="0" spc="-8" kern="0">
-                <a:solidFill>
-                  <a:srgbClr val="14161C"/>
-                </a:solidFill>
-                <a:latin typeface="Be Vietnam Pro" pitchFamily="34" charset="0"/>
-                <a:ea typeface="Be Vietnam Pro" pitchFamily="34" charset="-122"/>
-                <a:cs typeface="Be Vietnam Pro" pitchFamily="34" charset="-120"/>
-              </a:rPr>
-              <a:t> góp</a:t>
-            </a:r>
-            <a:r>
               <a:rPr lang="en-US" sz="3000" b="1" dirty="0" spc="2" kern="0">
                 <a:solidFill>
                   <a:srgbClr val="14161C"/>
@@ -12308,7 +12078,40 @@
                 <a:ea typeface="Be Vietnam Pro" pitchFamily="34" charset="-122"/>
                 <a:cs typeface="Be Vietnam Pro" pitchFamily="34" charset="-120"/>
               </a:rPr>
-              <a:t> ý</a:t>
+              <a:t>Cụm</a:t>
+            </a:r>
+            <a:r>
+              <a:rPr lang="en-US" sz="3000" b="1" dirty="0" spc="0" kern="0">
+                <a:solidFill>
+                  <a:srgbClr val="14161C"/>
+                </a:solidFill>
+                <a:latin typeface="Be Vietnam Pro" pitchFamily="34" charset="0"/>
+                <a:ea typeface="Be Vietnam Pro" pitchFamily="34" charset="-122"/>
+                <a:cs typeface="Be Vietnam Pro" pitchFamily="34" charset="-120"/>
+              </a:rPr>
+              <a:t> nút</a:t>
+            </a:r>
+            <a:r>
+              <a:rPr lang="en-US" sz="3000" b="1" dirty="0" spc="2" kern="0">
+                <a:solidFill>
+                  <a:srgbClr val="14161C"/>
+                </a:solidFill>
+                <a:latin typeface="Be Vietnam Pro" pitchFamily="34" charset="0"/>
+                <a:ea typeface="Be Vietnam Pro" pitchFamily="34" charset="-122"/>
+                <a:cs typeface="Be Vietnam Pro" pitchFamily="34" charset="-120"/>
+              </a:rPr>
+              <a:t> giữ</a:t>
+            </a:r>
+            <a:r>
+              <a:rPr lang="en-US" sz="3000" b="1" dirty="0" spc="-3" kern="0">
+                <a:solidFill>
+                  <a:srgbClr val="14161C"/>
+                </a:solidFill>
+                <a:latin typeface="Be Vietnam Pro" pitchFamily="34" charset="0"/>
+                <a:ea typeface="Be Vietnam Pro" pitchFamily="34" charset="-122"/>
+                <a:cs typeface="Be Vietnam Pro" pitchFamily="34" charset="-120"/>
+              </a:rPr>
+              <a:t> chung</a:t>
             </a:r>
             <a:endParaRPr lang="en-US" sz="3000" dirty="0"/>
           </a:p>
@@ -12320,37 +12123,59 @@
               <a:buNone/>
             </a:pPr>
             <a:r>
-              <a:rPr lang="en-US" sz="3000" b="1" dirty="0" spc="15" kern="0">
-                <a:solidFill>
-                  <a:srgbClr val="14161C"/>
-                </a:solidFill>
-                <a:latin typeface="Be Vietnam Pro" pitchFamily="34" charset="0"/>
-                <a:ea typeface="Be Vietnam Pro" pitchFamily="34" charset="-122"/>
-                <a:cs typeface="Be Vietnam Pro" pitchFamily="34" charset="-120"/>
-              </a:rPr>
-              <a:t>để</a:t>
-            </a:r>
-            <a:r>
-              <a:rPr lang="en-US" sz="3000" b="1" dirty="0" spc="0" kern="0">
-                <a:solidFill>
-                  <a:srgbClr val="14161C"/>
-                </a:solidFill>
-                <a:latin typeface="Be Vietnam Pro" pitchFamily="34" charset="0"/>
-                <a:ea typeface="Be Vietnam Pro" pitchFamily="34" charset="-122"/>
-                <a:cs typeface="Be Vietnam Pro" pitchFamily="34" charset="-120"/>
-              </a:rPr>
-              <a:t> chỉnh</a:t>
-            </a:r>
-            <a:r>
-              <a:rPr lang="en-US" sz="3000" b="1" dirty="0" spc="-5" kern="0">
-                <a:solidFill>
-                  <a:srgbClr val="14161C"/>
-                </a:solidFill>
-                <a:latin typeface="Be Vietnam Pro" pitchFamily="34" charset="0"/>
-                <a:ea typeface="Be Vietnam Pro" pitchFamily="34" charset="-122"/>
-                <a:cs typeface="Be Vietnam Pro" pitchFamily="34" charset="-120"/>
-              </a:rPr>
-              <a:t> thang</a:t>
+              <a:rPr lang="en-US" sz="3000" b="1" dirty="0" spc="-16" kern="0">
+                <a:solidFill>
+                  <a:srgbClr val="14161C"/>
+                </a:solidFill>
+                <a:latin typeface="Be Vietnam Pro" pitchFamily="34" charset="0"/>
+                <a:ea typeface="Be Vietnam Pro" pitchFamily="34" charset="-122"/>
+                <a:cs typeface="Be Vietnam Pro" pitchFamily="34" charset="-120"/>
+              </a:rPr>
+              <a:t>một</a:t>
+            </a:r>
+            <a:r>
+              <a:rPr lang="en-US" sz="3000" b="1" dirty="0" spc="-9" kern="0">
+                <a:solidFill>
+                  <a:srgbClr val="14161C"/>
+                </a:solidFill>
+                <a:latin typeface="Be Vietnam Pro" pitchFamily="34" charset="0"/>
+                <a:ea typeface="Be Vietnam Pro" pitchFamily="34" charset="-122"/>
+                <a:cs typeface="Be Vietnam Pro" pitchFamily="34" charset="-120"/>
+              </a:rPr>
+              <a:t> nhật</a:t>
+            </a:r>
+            <a:r>
+              <a:rPr lang="en-US" sz="3000" b="1" dirty="0" spc="2" kern="0">
+                <a:solidFill>
+                  <a:srgbClr val="14161C"/>
+                </a:solidFill>
+                <a:latin typeface="Be Vietnam Pro" pitchFamily="34" charset="0"/>
+                <a:ea typeface="Be Vietnam Pro" pitchFamily="34" charset="-122"/>
+                <a:cs typeface="Be Vietnam Pro" pitchFamily="34" charset="-120"/>
+              </a:rPr>
+              <a:t> ký</a:t>
+            </a:r>
+            <a:r>
+              <a:rPr lang="en-US" sz="3000" b="1" dirty="0" spc="-4" kern="0">
+                <a:solidFill>
+                  <a:srgbClr val="14161C"/>
+                </a:solidFill>
+                <a:latin typeface="Be Vietnam Pro" pitchFamily="34" charset="0"/>
+                <a:ea typeface="Be Vietnam Pro" pitchFamily="34" charset="-122"/>
+                <a:cs typeface="Be Vietnam Pro" pitchFamily="34" charset="-120"/>
+              </a:rPr>
+              <a:t> nhân</a:t>
+            </a:r>
+            <a:r>
+              <a:rPr lang="en-US" sz="3000" b="1" dirty="0" spc="-1" kern="0">
+                <a:solidFill>
+                  <a:srgbClr val="14161C"/>
+                </a:solidFill>
+                <a:latin typeface="Be Vietnam Pro" pitchFamily="34" charset="0"/>
+                <a:ea typeface="Be Vietnam Pro" pitchFamily="34" charset="-122"/>
+                <a:cs typeface="Be Vietnam Pro" pitchFamily="34" charset="-120"/>
+              </a:rPr>
+              <a:t> bản</a:t>
             </a:r>
             <a:endParaRPr lang="en-US" sz="3000" dirty="0"/>
           </a:p>
@@ -12358,7 +12183,7 @@
       </p:sp>
       <p:sp>
         <p:nvSpPr>
-          <p:cNvPr id="29" name="Text 27"/>
+          <p:cNvPr id="26" name="Text 24"/>
           <p:cNvSpPr/>
           <p:nvPr/>
         </p:nvSpPr>
@@ -12384,7 +12209,7 @@
               <a:buNone/>
             </a:pPr>
             <a:r>
-              <a:rPr lang="en-US" sz="2700" dirty="0" spc="-77" kern="0">
+              <a:rPr lang="en-US" sz="2700" dirty="0" spc="-79" kern="0">
                 <a:solidFill>
                   <a:srgbClr val="C4C8D6"/>
                 </a:solidFill>
@@ -12392,7 +12217,7 @@
                 <a:ea typeface="Be Vietnam Pro" pitchFamily="34" charset="-122"/>
                 <a:cs typeface="Be Vietnam Pro" pitchFamily="34" charset="-120"/>
               </a:rPr>
-              <a:t>Tác</a:t>
+              <a:t>Tài</a:t>
             </a:r>
             <a:r>
               <a:rPr lang="en-US" sz="2700" dirty="0" spc="-1" kern="0">
@@ -12403,10 +12228,10 @@
                 <a:ea typeface="Be Vietnam Pro" pitchFamily="34" charset="-122"/>
                 <a:cs typeface="Be Vietnam Pro" pitchFamily="34" charset="-120"/>
               </a:rPr>
-              <a:t> giả</a:t>
-            </a:r>
-            <a:r>
-              <a:rPr lang="en-US" sz="2700" dirty="0" spc="6" kern="0">
+              <a:t> liệu</a:t>
+            </a:r>
+            <a:r>
+              <a:rPr lang="en-US" sz="2700" dirty="0" spc="-2" kern="0">
                 <a:solidFill>
                   <a:srgbClr val="C4C8D6"/>
                 </a:solidFill>
@@ -12414,10 +12239,10 @@
                 <a:ea typeface="Be Vietnam Pro" pitchFamily="34" charset="-122"/>
                 <a:cs typeface="Be Vietnam Pro" pitchFamily="34" charset="-120"/>
               </a:rPr>
-              <a:t> thừa</a:t>
-            </a:r>
-            <a:r>
-              <a:rPr lang="en-US" sz="2700" dirty="0" spc="-2" kern="0">
+              <a:t> của</a:t>
+            </a:r>
+            <a:r>
+              <a:rPr lang="en-US" sz="2700" dirty="0" spc="-16" kern="0">
                 <a:solidFill>
                   <a:srgbClr val="C4C8D6"/>
                 </a:solidFill>
@@ -12425,51 +12250,7 @@
                 <a:ea typeface="Be Vietnam Pro" pitchFamily="34" charset="-122"/>
                 <a:cs typeface="Be Vietnam Pro" pitchFamily="34" charset="-120"/>
               </a:rPr>
-              <a:t> nhận</a:t>
-            </a:r>
-            <a:r>
-              <a:rPr lang="en-US" sz="2700" dirty="0" spc="-41" kern="0">
-                <a:solidFill>
-                  <a:srgbClr val="C4C8D6"/>
-                </a:solidFill>
-                <a:latin typeface="Be Vietnam Pro" pitchFamily="34" charset="0"/>
-                <a:ea typeface="Be Vietnam Pro" pitchFamily="34" charset="-122"/>
-                <a:cs typeface="Be Vietnam Pro" pitchFamily="34" charset="-120"/>
-              </a:rPr>
-              <a:t> rất</a:t>
-            </a:r>
-            <a:r>
-              <a:rPr lang="en-US" sz="2700" dirty="0" spc="-2" kern="0">
-                <a:solidFill>
-                  <a:srgbClr val="C4C8D6"/>
-                </a:solidFill>
-                <a:latin typeface="Be Vietnam Pro" pitchFamily="34" charset="0"/>
-                <a:ea typeface="Be Vietnam Pro" pitchFamily="34" charset="-122"/>
-                <a:cs typeface="Be Vietnam Pro" pitchFamily="34" charset="-120"/>
-              </a:rPr>
-              <a:t> khó</a:t>
-            </a:r>
-            <a:r>
-              <a:rPr lang="en-US" sz="2700" dirty="0" spc="-24" kern="0">
-                <a:solidFill>
-                  <a:srgbClr val="C4C8D6"/>
-                </a:solidFill>
-                <a:latin typeface="Be Vietnam Pro" pitchFamily="34" charset="0"/>
-                <a:ea typeface="Be Vietnam Pro" pitchFamily="34" charset="-122"/>
-                <a:cs typeface="Be Vietnam Pro" pitchFamily="34" charset="-120"/>
-              </a:rPr>
-              <a:t> xếp</a:t>
-            </a:r>
-            <a:r>
-              <a:rPr lang="en-US" sz="2700" dirty="0" spc="-2" kern="0">
-                <a:solidFill>
-                  <a:srgbClr val="C4C8D6"/>
-                </a:solidFill>
-                <a:latin typeface="Be Vietnam Pro" pitchFamily="34" charset="0"/>
-                <a:ea typeface="Be Vietnam Pro" pitchFamily="34" charset="-122"/>
-                <a:cs typeface="Be Vietnam Pro" pitchFamily="34" charset="-120"/>
-              </a:rPr>
-              <a:t> hạng</a:t>
+              <a:t> Cassandra</a:t>
             </a:r>
             <a:endParaRPr lang="en-US" sz="2700" dirty="0"/>
           </a:p>
@@ -12481,6 +12262,39 @@
               <a:buNone/>
             </a:pPr>
             <a:r>
+              <a:rPr lang="en-US" sz="2700" dirty="0" spc="-24" kern="0">
+                <a:solidFill>
+                  <a:srgbClr val="C4C8D6"/>
+                </a:solidFill>
+                <a:latin typeface="Be Vietnam Pro" pitchFamily="34" charset="0"/>
+                <a:ea typeface="Be Vietnam Pro" pitchFamily="34" charset="-122"/>
+                <a:cs typeface="Be Vietnam Pro" pitchFamily="34" charset="-120"/>
+              </a:rPr>
+              <a:t>và</a:t>
+            </a:r>
+            <a:r>
+              <a:rPr lang="en-US" sz="2700" dirty="0" spc="-16" kern="0">
+                <a:solidFill>
+                  <a:srgbClr val="C4C8D6"/>
+                </a:solidFill>
+                <a:latin typeface="Be Vietnam Pro" pitchFamily="34" charset="0"/>
+                <a:ea typeface="Be Vietnam Pro" pitchFamily="34" charset="-122"/>
+                <a:cs typeface="Be Vietnam Pro" pitchFamily="34" charset="-120"/>
+              </a:rPr>
+              <a:t> etcd-io/raft</a:t>
+            </a:r>
+            <a:r>
+              <a:rPr lang="en-US" sz="2700" dirty="0" spc="-1" kern="0">
+                <a:solidFill>
+                  <a:srgbClr val="C4C8D6"/>
+                </a:solidFill>
+                <a:latin typeface="Be Vietnam Pro" pitchFamily="34" charset="0"/>
+                <a:ea typeface="Be Vietnam Pro" pitchFamily="34" charset="-122"/>
+                <a:cs typeface="Be Vietnam Pro" pitchFamily="34" charset="-120"/>
+              </a:rPr>
+              <a:t> cho</a:t>
+            </a:r>
+            <a:r>
               <a:rPr lang="en-US" sz="2700" dirty="0" spc="-8" kern="0">
                 <a:solidFill>
                   <a:srgbClr val="C4C8D6"/>
@@ -12489,62 +12303,7 @@
                 <a:ea typeface="Be Vietnam Pro" pitchFamily="34" charset="-122"/>
                 <a:cs typeface="Be Vietnam Pro" pitchFamily="34" charset="-120"/>
               </a:rPr>
-              <a:t>thuật</a:t>
-            </a:r>
-            <a:r>
-              <a:rPr lang="en-US" sz="2700" dirty="0" spc="-14" kern="0">
-                <a:solidFill>
-                  <a:srgbClr val="C4C8D6"/>
-                </a:solidFill>
-                <a:latin typeface="Be Vietnam Pro" pitchFamily="34" charset="0"/>
-                <a:ea typeface="Be Vietnam Pro" pitchFamily="34" charset="-122"/>
-                <a:cs typeface="Be Vietnam Pro" pitchFamily="34" charset="-120"/>
-              </a:rPr>
-              <a:t> toán</a:t>
-            </a:r>
-            <a:r>
-              <a:rPr lang="en-US" sz="2700" dirty="0" spc="-3" kern="0">
-                <a:solidFill>
-                  <a:srgbClr val="C4C8D6"/>
-                </a:solidFill>
-                <a:latin typeface="Be Vietnam Pro" pitchFamily="34" charset="0"/>
-                <a:ea typeface="Be Vietnam Pro" pitchFamily="34" charset="-122"/>
-                <a:cs typeface="Be Vietnam Pro" pitchFamily="34" charset="-120"/>
-              </a:rPr>
-              <a:t> theo</a:t>
-            </a:r>
-            <a:r>
-              <a:rPr lang="en-US" sz="2700" dirty="0" spc="16" kern="0">
-                <a:solidFill>
-                  <a:srgbClr val="C4C8D6"/>
-                </a:solidFill>
-                <a:latin typeface="Be Vietnam Pro" pitchFamily="34" charset="0"/>
-                <a:ea typeface="Be Vietnam Pro" pitchFamily="34" charset="-122"/>
-                <a:cs typeface="Be Vietnam Pro" pitchFamily="34" charset="-120"/>
-              </a:rPr>
-              <a:t> độ</a:t>
-            </a:r>
-            <a:r>
-              <a:rPr lang="en-US" sz="2700" dirty="0" spc="-2" kern="0">
-                <a:solidFill>
-                  <a:srgbClr val="C4C8D6"/>
-                </a:solidFill>
-                <a:latin typeface="Be Vietnam Pro" pitchFamily="34" charset="0"/>
-                <a:ea typeface="Be Vietnam Pro" pitchFamily="34" charset="-122"/>
-                <a:cs typeface="Be Vietnam Pro" pitchFamily="34" charset="-120"/>
-              </a:rPr>
-              <a:t> quan</a:t>
-            </a:r>
-            <a:r>
-              <a:rPr lang="en-US" sz="2700" dirty="0" spc="-19" kern="0">
-                <a:solidFill>
-                  <a:srgbClr val="C4C8D6"/>
-                </a:solidFill>
-                <a:latin typeface="Be Vietnam Pro" pitchFamily="34" charset="0"/>
-                <a:ea typeface="Be Vietnam Pro" pitchFamily="34" charset="-122"/>
-                <a:cs typeface="Be Vietnam Pro" pitchFamily="34" charset="-120"/>
-              </a:rPr>
-              <a:t> trọng</a:t>
+              <a:t> thấy</a:t>
             </a:r>
             <a:endParaRPr lang="en-US" sz="2700" dirty="0"/>
           </a:p>
@@ -12564,10 +12323,10 @@
                 <a:ea typeface="Be Vietnam Pro" pitchFamily="34" charset="-122"/>
                 <a:cs typeface="Be Vietnam Pro" pitchFamily="34" charset="-120"/>
               </a:rPr>
-              <a:t>một</a:t>
-            </a:r>
-            <a:r>
-              <a:rPr lang="en-US" sz="2700" dirty="0" spc="1" kern="0">
+              <a:t>thuật</a:t>
+            </a:r>
+            <a:r>
+              <a:rPr lang="en-US" sz="2700" dirty="0" spc="-14" kern="0">
                 <a:solidFill>
                   <a:srgbClr val="C4C8D6"/>
                 </a:solidFill>
@@ -12575,10 +12334,10 @@
                 <a:ea typeface="Be Vietnam Pro" pitchFamily="34" charset="-122"/>
                 <a:cs typeface="Be Vietnam Pro" pitchFamily="34" charset="-120"/>
               </a:rPr>
-              <a:t> cách</a:t>
-            </a:r>
-            <a:r>
-              <a:rPr lang="en-US" sz="2700" dirty="0" spc="0" kern="0">
+              <a:t> toán</a:t>
+            </a:r>
+            <a:r>
+              <a:rPr lang="en-US" sz="2700" dirty="0" spc="8" kern="0">
                 <a:solidFill>
                   <a:srgbClr val="C4C8D6"/>
                 </a:solidFill>
@@ -12586,7 +12345,7 @@
                 <a:ea typeface="Be Vietnam Pro" pitchFamily="34" charset="-122"/>
                 <a:cs typeface="Be Vietnam Pro" pitchFamily="34" charset="-120"/>
               </a:rPr>
-              <a:t> khách</a:t>
+              <a:t> được</a:t>
             </a:r>
             <a:r>
               <a:rPr lang="en-US" sz="2700" dirty="0" spc="-2" kern="0">
@@ -12597,7 +12356,29 @@
                 <a:ea typeface="Be Vietnam Pro" pitchFamily="34" charset="-122"/>
                 <a:cs typeface="Be Vietnam Pro" pitchFamily="34" charset="-120"/>
               </a:rPr>
-              <a:t> quan.</a:t>
+              <a:t> dùng</a:t>
+            </a:r>
+            <a:r>
+              <a:rPr lang="en-US" sz="2700" dirty="0" spc="-4" kern="0">
+                <a:solidFill>
+                  <a:srgbClr val="C4C8D6"/>
+                </a:solidFill>
+                <a:latin typeface="Be Vietnam Pro" pitchFamily="34" charset="0"/>
+                <a:ea typeface="Be Vietnam Pro" pitchFamily="34" charset="-122"/>
+                <a:cs typeface="Be Vietnam Pro" pitchFamily="34" charset="-120"/>
+              </a:rPr>
+              <a:t> ở</a:t>
+            </a:r>
+            <a:r>
+              <a:rPr lang="en-US" sz="2700" dirty="0" spc="10" kern="0">
+                <a:solidFill>
+                  <a:srgbClr val="C4C8D6"/>
+                </a:solidFill>
+                <a:latin typeface="Be Vietnam Pro" pitchFamily="34" charset="0"/>
+                <a:ea typeface="Be Vietnam Pro" pitchFamily="34" charset="-122"/>
+                <a:cs typeface="Be Vietnam Pro" pitchFamily="34" charset="-120"/>
+              </a:rPr>
+              <a:t> đâu.</a:t>
             </a:r>
             <a:endParaRPr lang="en-US" sz="2700" dirty="0"/>
           </a:p>
@@ -12605,7 +12386,7 @@
       </p:sp>
       <p:sp>
         <p:nvSpPr>
-          <p:cNvPr id="30" name="Text 28"/>
+          <p:cNvPr id="27" name="Text 25"/>
           <p:cNvSpPr/>
           <p:nvPr/>
         </p:nvSpPr>
@@ -12631,59 +12412,15 @@
               <a:buNone/>
             </a:pPr>
             <a:r>
-              <a:rPr lang="en-US" sz="2550" dirty="0" spc="-77" kern="0">
-                <a:solidFill>
-                  <a:srgbClr val="F3EEE3"/>
-                </a:solidFill>
-                <a:latin typeface="Be Vietnam Pro" pitchFamily="34" charset="0"/>
-                <a:ea typeface="Be Vietnam Pro" pitchFamily="34" charset="-122"/>
-                <a:cs typeface="Be Vietnam Pro" pitchFamily="34" charset="-120"/>
-              </a:rPr>
-              <a:t>Tác</a:t>
-            </a:r>
-            <a:r>
-              <a:rPr lang="en-US" sz="2550" dirty="0" spc="0" kern="0">
-                <a:solidFill>
-                  <a:srgbClr val="F3EEE3"/>
-                </a:solidFill>
-                <a:latin typeface="Be Vietnam Pro" pitchFamily="34" charset="0"/>
-                <a:ea typeface="Be Vietnam Pro" pitchFamily="34" charset="-122"/>
-                <a:cs typeface="Be Vietnam Pro" pitchFamily="34" charset="-120"/>
-              </a:rPr>
-              <a:t> giả</a:t>
-            </a:r>
-            <a:r>
-              <a:rPr lang="en-US" sz="2550" dirty="0" spc="-7" kern="0">
-                <a:solidFill>
-                  <a:srgbClr val="F3EEE3"/>
-                </a:solidFill>
-                <a:latin typeface="Be Vietnam Pro" pitchFamily="34" charset="0"/>
-                <a:ea typeface="Be Vietnam Pro" pitchFamily="34" charset="-122"/>
-                <a:cs typeface="Be Vietnam Pro" pitchFamily="34" charset="-120"/>
-              </a:rPr>
-              <a:t> sẵn</a:t>
-            </a:r>
-            <a:r>
-              <a:rPr lang="en-US" sz="2550" dirty="0" spc="0" kern="0">
-                <a:solidFill>
-                  <a:srgbClr val="F3EEE3"/>
-                </a:solidFill>
-                <a:latin typeface="Be Vietnam Pro" pitchFamily="34" charset="0"/>
-                <a:ea typeface="Be Vietnam Pro" pitchFamily="34" charset="-122"/>
-                <a:cs typeface="Be Vietnam Pro" pitchFamily="34" charset="-120"/>
-              </a:rPr>
-              <a:t> lòng nhận</a:t>
-            </a:r>
-            <a:r>
-              <a:rPr lang="en-US" sz="2550" dirty="0" spc="-13" kern="0">
-                <a:solidFill>
-                  <a:srgbClr val="F3EEE3"/>
-                </a:solidFill>
-                <a:latin typeface="Be Vietnam Pro" pitchFamily="34" charset="0"/>
-                <a:ea typeface="Be Vietnam Pro" pitchFamily="34" charset="-122"/>
-                <a:cs typeface="Be Vietnam Pro" pitchFamily="34" charset="-120"/>
-              </a:rPr>
-              <a:t> góp</a:t>
+              <a:rPr lang="en-US" sz="2550" dirty="0" spc="3" kern="0">
+                <a:solidFill>
+                  <a:srgbClr val="F3EEE3"/>
+                </a:solidFill>
+                <a:latin typeface="Be Vietnam Pro" pitchFamily="34" charset="0"/>
+                <a:ea typeface="Be Vietnam Pro" pitchFamily="34" charset="-122"/>
+                <a:cs typeface="Be Vietnam Pro" pitchFamily="34" charset="-120"/>
+              </a:rPr>
+              <a:t>Ba</a:t>
             </a:r>
             <a:r>
               <a:rPr lang="en-US" sz="2550" dirty="0" spc="-1" kern="0">
@@ -12694,7 +12431,51 @@
                 <a:ea typeface="Be Vietnam Pro" pitchFamily="34" charset="-122"/>
                 <a:cs typeface="Be Vietnam Pro" pitchFamily="34" charset="-120"/>
               </a:rPr>
-              <a:t> ý</a:t>
+              <a:t> ví</a:t>
+            </a:r>
+            <a:r>
+              <a:rPr lang="en-US" sz="2550" dirty="0" spc="-2" kern="0">
+                <a:solidFill>
+                  <a:srgbClr val="F3EEE3"/>
+                </a:solidFill>
+                <a:latin typeface="Be Vietnam Pro" pitchFamily="34" charset="0"/>
+                <a:ea typeface="Be Vietnam Pro" pitchFamily="34" charset="-122"/>
+                <a:cs typeface="Be Vietnam Pro" pitchFamily="34" charset="-120"/>
+              </a:rPr>
+              <a:t> dụ</a:t>
+            </a:r>
+            <a:r>
+              <a:rPr lang="en-US" sz="2550" dirty="0" spc="-1" kern="0">
+                <a:solidFill>
+                  <a:srgbClr val="F3EEE3"/>
+                </a:solidFill>
+                <a:latin typeface="Be Vietnam Pro" pitchFamily="34" charset="0"/>
+                <a:ea typeface="Be Vietnam Pro" pitchFamily="34" charset="-122"/>
+                <a:cs typeface="Be Vietnam Pro" pitchFamily="34" charset="-120"/>
+              </a:rPr>
+              <a:t> do</a:t>
+            </a:r>
+            <a:r>
+              <a:rPr lang="en-US" sz="2550" dirty="0" spc="-3" kern="0">
+                <a:solidFill>
+                  <a:srgbClr val="F3EEE3"/>
+                </a:solidFill>
+                <a:latin typeface="Be Vietnam Pro" pitchFamily="34" charset="0"/>
+                <a:ea typeface="Be Vietnam Pro" pitchFamily="34" charset="-122"/>
+                <a:cs typeface="Be Vietnam Pro" pitchFamily="34" charset="-120"/>
+              </a:rPr>
+              <a:t> bài</a:t>
+            </a:r>
+            <a:r>
+              <a:rPr lang="en-US" sz="2550" dirty="0" spc="-1" kern="0">
+                <a:solidFill>
+                  <a:srgbClr val="F3EEE3"/>
+                </a:solidFill>
+                <a:latin typeface="Be Vietnam Pro" pitchFamily="34" charset="0"/>
+                <a:ea typeface="Be Vietnam Pro" pitchFamily="34" charset="-122"/>
+                <a:cs typeface="Be Vietnam Pro" pitchFamily="34" charset="-120"/>
+              </a:rPr>
+              <a:t> chọn,</a:t>
             </a:r>
             <a:endParaRPr lang="en-US" sz="2550" dirty="0"/>
           </a:p>
@@ -12706,28 +12487,6 @@
               <a:buNone/>
             </a:pPr>
             <a:r>
-              <a:rPr lang="en-US" sz="2550" dirty="0" spc="27" kern="0">
-                <a:solidFill>
-                  <a:srgbClr val="F3EEE3"/>
-                </a:solidFill>
-                <a:latin typeface="Be Vietnam Pro" pitchFamily="34" charset="0"/>
-                <a:ea typeface="Be Vietnam Pro" pitchFamily="34" charset="-122"/>
-                <a:cs typeface="Be Vietnam Pro" pitchFamily="34" charset="-120"/>
-              </a:rPr>
-              <a:t>để</a:t>
-            </a:r>
-            <a:r>
-              <a:rPr lang="en-US" sz="2550" dirty="0" spc="0" kern="0">
-                <a:solidFill>
-                  <a:srgbClr val="F3EEE3"/>
-                </a:solidFill>
-                <a:latin typeface="Be Vietnam Pro" pitchFamily="34" charset="0"/>
-                <a:ea typeface="Be Vietnam Pro" pitchFamily="34" charset="-122"/>
-                <a:cs typeface="Be Vietnam Pro" pitchFamily="34" charset="-120"/>
-              </a:rPr>
-              <a:t> chỉnh</a:t>
-            </a:r>
-            <a:r>
               <a:rPr lang="en-US" sz="2550" dirty="0" spc="1" kern="0">
                 <a:solidFill>
                   <a:srgbClr val="F3EEE3"/>
@@ -12736,10 +12495,21 @@
                 <a:ea typeface="Be Vietnam Pro" pitchFamily="34" charset="-122"/>
                 <a:cs typeface="Be Vietnam Pro" pitchFamily="34" charset="-120"/>
               </a:rPr>
-              <a:t> thang</a:t>
-            </a:r>
-            <a:r>
-              <a:rPr lang="en-US" sz="2550" dirty="0" spc="-6" kern="0">
+              <a:t>không</a:t>
+            </a:r>
+            <a:r>
+              <a:rPr lang="en-US" sz="2550" dirty="0" spc="-13" kern="0">
+                <a:solidFill>
+                  <a:srgbClr val="F3EEE3"/>
+                </a:solidFill>
+                <a:latin typeface="Be Vietnam Pro" pitchFamily="34" charset="0"/>
+                <a:ea typeface="Be Vietnam Pro" pitchFamily="34" charset="-122"/>
+                <a:cs typeface="Be Vietnam Pro" pitchFamily="34" charset="-120"/>
+              </a:rPr>
+              <a:t> gán</a:t>
+            </a:r>
+            <a:r>
+              <a:rPr lang="en-US" sz="2550" dirty="0" spc="-5" kern="0">
                 <a:solidFill>
                   <a:srgbClr val="F3EEE3"/>
                 </a:solidFill>
@@ -12755,7 +12525,7 @@
       </p:sp>
       <p:sp>
         <p:nvSpPr>
-          <p:cNvPr id="31" name="Shape 29"/>
+          <p:cNvPr id="28" name="Shape 26"/>
           <p:cNvSpPr/>
           <p:nvPr/>
         </p:nvSpPr>
@@ -12779,7 +12549,7 @@
       </p:sp>
       <p:pic>
         <p:nvPicPr>
-          <p:cNvPr id="32" name="Moda image moda-export-watermark-27117fd4-5916-4338-b4c3-6a26d03c36ff" descr="">    </p:cNvPr>
+          <p:cNvPr id="29" name="Moda image moda-export-watermark-27117fd4-5916-4338-b4c3-6a26d03c36ff" descr="">    </p:cNvPr>
           <p:cNvPicPr>
             <a:picLocks noChangeAspect="1"/>
           </p:cNvPicPr>
@@ -13073,29 +12843,62 @@
                 <a:ea typeface="Be Vietnam Pro" pitchFamily="34" charset="-122"/>
                 <a:cs typeface="Be Vietnam Pro" pitchFamily="34" charset="-120"/>
               </a:rPr>
-              <a:t>Bài chỉ</a:t>
-            </a:r>
-            <a:r>
-              <a:rPr lang="en-US" sz="2700" dirty="0" spc="18" kern="0">
-                <a:solidFill>
-                  <a:srgbClr val="14161C"/>
-                </a:solidFill>
-                <a:latin typeface="Be Vietnam Pro" pitchFamily="34" charset="0"/>
-                <a:ea typeface="Be Vietnam Pro" pitchFamily="34" charset="-122"/>
-                <a:cs typeface="Be Vietnam Pro" pitchFamily="34" charset="-120"/>
-              </a:rPr>
-              <a:t> dựng</a:t>
-            </a:r>
-            <a:r>
-              <a:rPr lang="en-US" sz="2700" dirty="0" spc="0" kern="0">
-                <a:solidFill>
-                  <a:srgbClr val="14161C"/>
-                </a:solidFill>
-                <a:latin typeface="Be Vietnam Pro" pitchFamily="34" charset="0"/>
-                <a:ea typeface="Be Vietnam Pro" pitchFamily="34" charset="-122"/>
-                <a:cs typeface="Be Vietnam Pro" pitchFamily="34" charset="-120"/>
-              </a:rPr>
-              <a:t> lại</a:t>
+              <a:t>Bài</a:t>
+            </a:r>
+            <a:r>
+              <a:rPr lang="en-US" sz="2700" dirty="0" spc="-3" kern="0">
+                <a:solidFill>
+                  <a:srgbClr val="14161C"/>
+                </a:solidFill>
+                <a:latin typeface="Be Vietnam Pro" pitchFamily="34" charset="0"/>
+                <a:ea typeface="Be Vietnam Pro" pitchFamily="34" charset="-122"/>
+                <a:cs typeface="Be Vietnam Pro" pitchFamily="34" charset="-120"/>
+              </a:rPr>
+              <a:t> giữ</a:t>
+            </a:r>
+            <a:r>
+              <a:rPr lang="en-US" sz="2700" dirty="0" spc="-1" kern="0">
+                <a:solidFill>
+                  <a:srgbClr val="14161C"/>
+                </a:solidFill>
+                <a:latin typeface="Be Vietnam Pro" pitchFamily="34" charset="0"/>
+                <a:ea typeface="Be Vietnam Pro" pitchFamily="34" charset="-122"/>
+                <a:cs typeface="Be Vietnam Pro" pitchFamily="34" charset="-120"/>
+              </a:rPr>
+              <a:t> thang</a:t>
+            </a:r>
+            <a:r>
+              <a:rPr lang="en-US" sz="2700" dirty="0" spc="-18" kern="0">
+                <a:solidFill>
+                  <a:srgbClr val="14161C"/>
+                </a:solidFill>
+                <a:latin typeface="Be Vietnam Pro" pitchFamily="34" charset="0"/>
+                <a:ea typeface="Be Vietnam Pro" pitchFamily="34" charset="-122"/>
+                <a:cs typeface="Be Vietnam Pro" pitchFamily="34" charset="-120"/>
+              </a:rPr>
+              <a:t> và</a:t>
+            </a:r>
+            <a:r>
+              <a:rPr lang="en-US" sz="2700" dirty="0" spc="-1" kern="0">
+                <a:solidFill>
+                  <a:srgbClr val="14161C"/>
+                </a:solidFill>
+                <a:latin typeface="Be Vietnam Pro" pitchFamily="34" charset="0"/>
+                <a:ea typeface="Be Vietnam Pro" pitchFamily="34" charset="-122"/>
+                <a:cs typeface="Be Vietnam Pro" pitchFamily="34" charset="-120"/>
+              </a:rPr>
+              <a:t> lời</a:t>
+            </a:r>
+            <a:r>
+              <a:rPr lang="en-US" sz="2700" dirty="0" spc="-15" kern="0">
+                <a:solidFill>
+                  <a:srgbClr val="14161C"/>
+                </a:solidFill>
+                <a:latin typeface="Be Vietnam Pro" pitchFamily="34" charset="0"/>
+                <a:ea typeface="Be Vietnam Pro" pitchFamily="34" charset="-122"/>
+                <a:cs typeface="Be Vietnam Pro" pitchFamily="34" charset="-120"/>
+              </a:rPr>
+              <a:t> khuyên</a:t>
             </a:r>
             <a:r>
               <a:rPr lang="en-US" sz="2700" dirty="0" spc="-2" kern="0">
@@ -13106,7 +12909,7 @@
                 <a:ea typeface="Be Vietnam Pro" pitchFamily="34" charset="-122"/>
                 <a:cs typeface="Be Vietnam Pro" pitchFamily="34" charset="-120"/>
               </a:rPr>
-              <a:t> phần</a:t>
+              <a:t> của</a:t>
             </a:r>
             <a:r>
               <a:rPr lang="en-US" sz="2700" dirty="0" spc="-1" kern="0">
@@ -13117,18 +12920,7 @@
                 <a:ea typeface="Be Vietnam Pro" pitchFamily="34" charset="-122"/>
                 <a:cs typeface="Be Vietnam Pro" pitchFamily="34" charset="-120"/>
               </a:rPr>
-              <a:t> chữ</a:t>
-            </a:r>
-            <a:r>
-              <a:rPr lang="en-US" sz="2700" dirty="0" spc="-2" kern="0">
-                <a:solidFill>
-                  <a:srgbClr val="14161C"/>
-                </a:solidFill>
-                <a:latin typeface="Be Vietnam Pro" pitchFamily="34" charset="0"/>
-                <a:ea typeface="Be Vietnam Pro" pitchFamily="34" charset="-122"/>
-                <a:cs typeface="Be Vietnam Pro" pitchFamily="34" charset="-120"/>
-              </a:rPr>
-              <a:t> của nguồn:</a:t>
+              <a:t> nguồn,</a:t>
             </a:r>
             <a:endParaRPr lang="en-US" sz="2700" dirty="0"/>
           </a:p>
@@ -13140,17 +12932,6 @@
               <a:buNone/>
             </a:pPr>
             <a:r>
-              <a:rPr lang="en-US" sz="2700" dirty="0" spc="0" kern="0">
-                <a:solidFill>
-                  <a:srgbClr val="14161C"/>
-                </a:solidFill>
-                <a:latin typeface="Be Vietnam Pro" pitchFamily="34" charset="0"/>
-                <a:ea typeface="Be Vietnam Pro" pitchFamily="34" charset="-122"/>
-                <a:cs typeface="Be Vietnam Pro" pitchFamily="34" charset="-120"/>
-              </a:rPr>
-              <a:t>lời</a:t>
-            </a:r>
-            <a:r>
               <a:rPr lang="en-US" sz="2700" dirty="0" spc="-1" kern="0">
                 <a:solidFill>
                   <a:srgbClr val="14161C"/>
@@ -13159,32 +12940,10 @@
                 <a:ea typeface="Be Vietnam Pro" pitchFamily="34" charset="-122"/>
                 <a:cs typeface="Be Vietnam Pro" pitchFamily="34" charset="-120"/>
               </a:rPr>
-              <a:t> dẫn, lời</a:t>
-            </a:r>
-            <a:r>
-              <a:rPr lang="en-US" sz="2700" dirty="0" spc="-15" kern="0">
-                <a:solidFill>
-                  <a:srgbClr val="14161C"/>
-                </a:solidFill>
-                <a:latin typeface="Be Vietnam Pro" pitchFamily="34" charset="0"/>
-                <a:ea typeface="Be Vietnam Pro" pitchFamily="34" charset="-122"/>
-                <a:cs typeface="Be Vietnam Pro" pitchFamily="34" charset="-120"/>
-              </a:rPr>
-              <a:t> khuyên</a:t>
-            </a:r>
-            <a:r>
-              <a:rPr lang="en-US" sz="2700" dirty="0" spc="-18" kern="0">
-                <a:solidFill>
-                  <a:srgbClr val="14161C"/>
-                </a:solidFill>
-                <a:latin typeface="Be Vietnam Pro" pitchFamily="34" charset="0"/>
-                <a:ea typeface="Be Vietnam Pro" pitchFamily="34" charset="-122"/>
-                <a:cs typeface="Be Vietnam Pro" pitchFamily="34" charset="-120"/>
-              </a:rPr>
-              <a:t> và</a:t>
-            </a:r>
-            <a:r>
-              <a:rPr lang="en-US" sz="2700" dirty="0" spc="-8" kern="0">
+              <a:t>thêm</a:t>
+            </a:r>
+            <a:r>
+              <a:rPr lang="en-US" sz="2700" dirty="0" spc="-7" kern="0">
                 <a:solidFill>
                   <a:srgbClr val="14161C"/>
                 </a:solidFill>
@@ -13195,26 +12954,48 @@
               <a:t> ba</a:t>
             </a:r>
             <a:r>
-              <a:rPr lang="en-US" sz="2700" dirty="0" spc="9" kern="0">
-                <a:solidFill>
-                  <a:srgbClr val="14161C"/>
-                </a:solidFill>
-                <a:latin typeface="Be Vietnam Pro" pitchFamily="34" charset="0"/>
-                <a:ea typeface="Be Vietnam Pro" pitchFamily="34" charset="-122"/>
-                <a:cs typeface="Be Vietnam Pro" pitchFamily="34" charset="-120"/>
-              </a:rPr>
-              <a:t> mức</a:t>
-            </a:r>
-            <a:r>
-              <a:rPr lang="en-US" sz="2700" dirty="0" spc="-9" kern="0">
-                <a:solidFill>
-                  <a:srgbClr val="14161C"/>
-                </a:solidFill>
-                <a:latin typeface="Be Vietnam Pro" pitchFamily="34" charset="0"/>
-                <a:ea typeface="Be Vietnam Pro" pitchFamily="34" charset="-122"/>
-                <a:cs typeface="Be Vietnam Pro" pitchFamily="34" charset="-120"/>
-              </a:rPr>
-              <a:t> sao.</a:t>
+              <a:rPr lang="en-US" sz="2700" dirty="0" spc="-2" kern="0">
+                <a:solidFill>
+                  <a:srgbClr val="14161C"/>
+                </a:solidFill>
+                <a:latin typeface="Be Vietnam Pro" pitchFamily="34" charset="0"/>
+                <a:ea typeface="Be Vietnam Pro" pitchFamily="34" charset="-122"/>
+                <a:cs typeface="Be Vietnam Pro" pitchFamily="34" charset="-120"/>
+              </a:rPr>
+              <a:t> ví</a:t>
+            </a:r>
+            <a:r>
+              <a:rPr lang="en-US" sz="2700" dirty="0" spc="-3" kern="0">
+                <a:solidFill>
+                  <a:srgbClr val="14161C"/>
+                </a:solidFill>
+                <a:latin typeface="Be Vietnam Pro" pitchFamily="34" charset="0"/>
+                <a:ea typeface="Be Vietnam Pro" pitchFamily="34" charset="-122"/>
+                <a:cs typeface="Be Vietnam Pro" pitchFamily="34" charset="-120"/>
+              </a:rPr>
+              <a:t> dụ do</a:t>
+            </a:r>
+            <a:r>
+              <a:rPr lang="en-US" sz="2700" dirty="0" spc="-5" kern="0">
+                <a:solidFill>
+                  <a:srgbClr val="14161C"/>
+                </a:solidFill>
+                <a:latin typeface="Be Vietnam Pro" pitchFamily="34" charset="0"/>
+                <a:ea typeface="Be Vietnam Pro" pitchFamily="34" charset="-122"/>
+                <a:cs typeface="Be Vietnam Pro" pitchFamily="34" charset="-120"/>
+              </a:rPr>
+              <a:t> bài</a:t>
+            </a:r>
+            <a:r>
+              <a:rPr lang="en-US" sz="2700" dirty="0" spc="-1" kern="0">
+                <a:solidFill>
+                  <a:srgbClr val="14161C"/>
+                </a:solidFill>
+                <a:latin typeface="Be Vietnam Pro" pitchFamily="34" charset="0"/>
+                <a:ea typeface="Be Vietnam Pro" pitchFamily="34" charset="-122"/>
+                <a:cs typeface="Be Vietnam Pro" pitchFamily="34" charset="-120"/>
+              </a:rPr>
+              <a:t> chọn.</a:t>
             </a:r>
             <a:endParaRPr lang="en-US" sz="2700" dirty="0"/>
           </a:p>
@@ -13590,15 +13371,26 @@
               <a:buNone/>
             </a:pPr>
             <a:r>
-              <a:rPr lang="en-US" sz="2700" b="1" dirty="0" spc="4" kern="0">
-                <a:solidFill>
-                  <a:srgbClr val="14161C"/>
-                </a:solidFill>
-                <a:latin typeface="Be Vietnam Pro" pitchFamily="34" charset="0"/>
-                <a:ea typeface="Be Vietnam Pro" pitchFamily="34" charset="-122"/>
-                <a:cs typeface="Be Vietnam Pro" pitchFamily="34" charset="-120"/>
-              </a:rPr>
-              <a:t>Bài</a:t>
+              <a:rPr lang="en-US" sz="2700" b="1" dirty="0" spc="1" kern="0">
+                <a:solidFill>
+                  <a:srgbClr val="14161C"/>
+                </a:solidFill>
+                <a:latin typeface="Be Vietnam Pro" pitchFamily="34" charset="0"/>
+                <a:ea typeface="Be Vietnam Pro" pitchFamily="34" charset="-122"/>
+                <a:cs typeface="Be Vietnam Pro" pitchFamily="34" charset="-120"/>
+              </a:rPr>
+              <a:t>Ví</a:t>
+            </a:r>
+            <a:r>
+              <a:rPr lang="en-US" sz="2700" b="1" dirty="0" spc="-1" kern="0">
+                <a:solidFill>
+                  <a:srgbClr val="14161C"/>
+                </a:solidFill>
+                <a:latin typeface="Be Vietnam Pro" pitchFamily="34" charset="0"/>
+                <a:ea typeface="Be Vietnam Pro" pitchFamily="34" charset="-122"/>
+                <a:cs typeface="Be Vietnam Pro" pitchFamily="34" charset="-120"/>
+              </a:rPr>
+              <a:t> dụ</a:t>
             </a:r>
             <a:r>
               <a:rPr lang="en-US" sz="2700" b="1" dirty="0" spc="-6" kern="0">
@@ -13612,26 +13404,26 @@
               <a:t> không</a:t>
             </a:r>
             <a:r>
-              <a:rPr lang="en-US" sz="2700" b="1" dirty="0" spc="-3" kern="0">
-                <a:solidFill>
-                  <a:srgbClr val="14161C"/>
-                </a:solidFill>
-                <a:latin typeface="Be Vietnam Pro" pitchFamily="34" charset="0"/>
-                <a:ea typeface="Be Vietnam Pro" pitchFamily="34" charset="-122"/>
-                <a:cs typeface="Be Vietnam Pro" pitchFamily="34" charset="-120"/>
-              </a:rPr>
-              <a:t> nêu</a:t>
-            </a:r>
-            <a:r>
-              <a:rPr lang="en-US" sz="2700" b="1" dirty="0" spc="-10" kern="0">
-                <a:solidFill>
-                  <a:srgbClr val="14161C"/>
-                </a:solidFill>
-                <a:latin typeface="Be Vietnam Pro" pitchFamily="34" charset="0"/>
-                <a:ea typeface="Be Vietnam Pro" pitchFamily="34" charset="-122"/>
-                <a:cs typeface="Be Vietnam Pro" pitchFamily="34" charset="-120"/>
-              </a:rPr>
-              <a:t> tên</a:t>
+              <a:rPr lang="en-US" sz="2700" b="1" dirty="0" spc="-2" kern="0">
+                <a:solidFill>
+                  <a:srgbClr val="14161C"/>
+                </a:solidFill>
+                <a:latin typeface="Be Vietnam Pro" pitchFamily="34" charset="0"/>
+                <a:ea typeface="Be Vietnam Pro" pitchFamily="34" charset="-122"/>
+                <a:cs typeface="Be Vietnam Pro" pitchFamily="34" charset="-120"/>
+              </a:rPr>
+              <a:t> gán</a:t>
+            </a:r>
+            <a:r>
+              <a:rPr lang="en-US" sz="2700" b="1" dirty="0" spc="1" kern="0">
+                <a:solidFill>
+                  <a:srgbClr val="14161C"/>
+                </a:solidFill>
+                <a:latin typeface="Be Vietnam Pro" pitchFamily="34" charset="0"/>
+                <a:ea typeface="Be Vietnam Pro" pitchFamily="34" charset="-122"/>
+                <a:cs typeface="Be Vietnam Pro" pitchFamily="34" charset="-120"/>
+              </a:rPr>
+              <a:t> sao</a:t>
             </a:r>
             <a:endParaRPr lang="en-US" sz="2700" dirty="0"/>
           </a:p>
@@ -13643,6 +13435,17 @@
               <a:buNone/>
             </a:pPr>
             <a:r>
+              <a:rPr lang="en-US" sz="2700" b="1" dirty="0" spc="-4" kern="0">
+                <a:solidFill>
+                  <a:srgbClr val="14161C"/>
+                </a:solidFill>
+                <a:latin typeface="Be Vietnam Pro" pitchFamily="34" charset="0"/>
+                <a:ea typeface="Be Vietnam Pro" pitchFamily="34" charset="-122"/>
+                <a:cs typeface="Be Vietnam Pro" pitchFamily="34" charset="-120"/>
+              </a:rPr>
+              <a:t>cho</a:t>
+            </a:r>
+            <a:r>
               <a:rPr lang="en-US" sz="2700" b="1" dirty="0" spc="-5" kern="0">
                 <a:solidFill>
                   <a:srgbClr val="14161C"/>
@@ -13651,7 +13454,7 @@
                 <a:ea typeface="Be Vietnam Pro" pitchFamily="34" charset="-122"/>
                 <a:cs typeface="Be Vietnam Pro" pitchFamily="34" charset="-120"/>
               </a:rPr>
-              <a:t>thuật</a:t>
+              <a:t> thuật</a:t>
             </a:r>
             <a:r>
               <a:rPr lang="en-US" sz="2700" b="1" dirty="0" spc="-6" kern="0">
@@ -15201,15 +15004,37 @@
               <a:buNone/>
             </a:pPr>
             <a:r>
-              <a:rPr lang="en-US" sz="2700" dirty="0" spc="-7" kern="0">
-                <a:solidFill>
-                  <a:srgbClr val="F3EEE3"/>
-                </a:solidFill>
-                <a:latin typeface="Be Vietnam Pro" pitchFamily="34" charset="0"/>
-                <a:ea typeface="Be Vietnam Pro" pitchFamily="34" charset="-122"/>
-                <a:cs typeface="Be Vietnam Pro" pitchFamily="34" charset="-120"/>
-              </a:rPr>
-              <a:t>Một thuật</a:t>
+              <a:rPr lang="en-US" sz="2700" dirty="0" spc="-18" kern="0">
+                <a:solidFill>
+                  <a:srgbClr val="F3EEE3"/>
+                </a:solidFill>
+                <a:latin typeface="Be Vietnam Pro" pitchFamily="34" charset="0"/>
+                <a:ea typeface="Be Vietnam Pro" pitchFamily="34" charset="-122"/>
+                <a:cs typeface="Be Vietnam Pro" pitchFamily="34" charset="-120"/>
+              </a:rPr>
+              <a:t>Cassandra</a:t>
+            </a:r>
+            <a:r>
+              <a:rPr lang="en-US" sz="2700" dirty="0" spc="-1" kern="0">
+                <a:solidFill>
+                  <a:srgbClr val="F3EEE3"/>
+                </a:solidFill>
+                <a:latin typeface="Be Vietnam Pro" pitchFamily="34" charset="0"/>
+                <a:ea typeface="Be Vietnam Pro" pitchFamily="34" charset="-122"/>
+                <a:cs typeface="Be Vietnam Pro" pitchFamily="34" charset="-120"/>
+              </a:rPr>
+              <a:t> mở</a:t>
+            </a:r>
+            <a:r>
+              <a:rPr lang="en-US" sz="2700" dirty="0" spc="-2" kern="0">
+                <a:solidFill>
+                  <a:srgbClr val="F3EEE3"/>
+                </a:solidFill>
+                <a:latin typeface="Be Vietnam Pro" pitchFamily="34" charset="0"/>
+                <a:ea typeface="Be Vietnam Pro" pitchFamily="34" charset="-122"/>
+                <a:cs typeface="Be Vietnam Pro" pitchFamily="34" charset="-120"/>
+              </a:rPr>
+              <a:t> nhiều</a:t>
             </a:r>
             <a:r>
               <a:rPr lang="en-US" sz="2700" dirty="0" spc="-15" kern="0">
@@ -15220,18 +15045,7 @@
                 <a:ea typeface="Be Vietnam Pro" pitchFamily="34" charset="-122"/>
                 <a:cs typeface="Be Vietnam Pro" pitchFamily="34" charset="-120"/>
               </a:rPr>
-              <a:t> toán</a:t>
-            </a:r>
-            <a:r>
-              <a:rPr lang="en-US" sz="2700" dirty="0" spc="9" kern="0">
-                <a:solidFill>
-                  <a:srgbClr val="F3EEE3"/>
-                </a:solidFill>
-                <a:latin typeface="Be Vietnam Pro" pitchFamily="34" charset="0"/>
-                <a:ea typeface="Be Vietnam Pro" pitchFamily="34" charset="-122"/>
-                <a:cs typeface="Be Vietnam Pro" pitchFamily="34" charset="-120"/>
-              </a:rPr>
-              <a:t> được</a:t>
+              <a:t> tệp</a:t>
             </a:r>
             <a:r>
               <a:rPr lang="en-US" sz="2700" dirty="0" spc="-24" kern="0">
@@ -15242,29 +15056,18 @@
                 <a:ea typeface="Be Vietnam Pro" pitchFamily="34" charset="-122"/>
                 <a:cs typeface="Be Vietnam Pro" pitchFamily="34" charset="-120"/>
               </a:rPr>
-              <a:t> xếp</a:t>
-            </a:r>
-            <a:r>
-              <a:rPr lang="en-US" sz="2700" dirty="0" spc="-7" kern="0">
-                <a:solidFill>
-                  <a:srgbClr val="F3EEE3"/>
-                </a:solidFill>
-                <a:latin typeface="Be Vietnam Pro" pitchFamily="34" charset="0"/>
-                <a:ea typeface="Be Vietnam Pro" pitchFamily="34" charset="-122"/>
-                <a:cs typeface="Be Vietnam Pro" pitchFamily="34" charset="-120"/>
-              </a:rPr>
-              <a:t> một</a:t>
-            </a:r>
-            <a:r>
-              <a:rPr lang="en-US" sz="2700" dirty="0" spc="-9" kern="0">
-                <a:solidFill>
-                  <a:srgbClr val="F3EEE3"/>
-                </a:solidFill>
-                <a:latin typeface="Be Vietnam Pro" pitchFamily="34" charset="0"/>
-                <a:ea typeface="Be Vietnam Pro" pitchFamily="34" charset="-122"/>
-                <a:cs typeface="Be Vietnam Pro" pitchFamily="34" charset="-120"/>
-              </a:rPr>
-              <a:t> sao.</a:t>
+              <a:t> trên</a:t>
+            </a:r>
+            <a:r>
+              <a:rPr lang="en-US" sz="2700" dirty="0" spc="19" kern="0">
+                <a:solidFill>
+                  <a:srgbClr val="F3EEE3"/>
+                </a:solidFill>
+                <a:latin typeface="Be Vietnam Pro" pitchFamily="34" charset="0"/>
+                <a:ea typeface="Be Vietnam Pro" pitchFamily="34" charset="-122"/>
+                <a:cs typeface="Be Vietnam Pro" pitchFamily="34" charset="-120"/>
+              </a:rPr>
+              <a:t> đĩa.</a:t>
             </a:r>
             <a:endParaRPr lang="en-US" sz="2700" dirty="0"/>
           </a:p>
@@ -15279,26 +15082,26 @@
               <a:buNone/>
             </a:pPr>
             <a:r>
-              <a:rPr lang="en-US" sz="2700" dirty="0" spc="0" kern="0">
-                <a:solidFill>
-                  <a:srgbClr val="F3EEE3"/>
-                </a:solidFill>
-                <a:latin typeface="Be Vietnam Pro" pitchFamily="34" charset="0"/>
-                <a:ea typeface="Be Vietnam Pro" pitchFamily="34" charset="-122"/>
-                <a:cs typeface="Be Vietnam Pro" pitchFamily="34" charset="-120"/>
-              </a:rPr>
-              <a:t>Nguồn</a:t>
-            </a:r>
-            <a:r>
-              <a:rPr lang="en-US" sz="2700" dirty="0" spc="-3" kern="0">
-                <a:solidFill>
-                  <a:srgbClr val="F3EEE3"/>
-                </a:solidFill>
-                <a:latin typeface="Be Vietnam Pro" pitchFamily="34" charset="0"/>
-                <a:ea typeface="Be Vietnam Pro" pitchFamily="34" charset="-122"/>
-                <a:cs typeface="Be Vietnam Pro" pitchFamily="34" charset="-120"/>
-              </a:rPr>
-              <a:t> nói</a:t>
+              <a:rPr lang="en-US" sz="2700" dirty="0" spc="-8" kern="0">
+                <a:solidFill>
+                  <a:srgbClr val="F3EEE3"/>
+                </a:solidFill>
+                <a:latin typeface="Be Vietnam Pro" pitchFamily="34" charset="0"/>
+                <a:ea typeface="Be Vietnam Pro" pitchFamily="34" charset="-122"/>
+                <a:cs typeface="Be Vietnam Pro" pitchFamily="34" charset="-120"/>
+              </a:rPr>
+              <a:t>Thuật</a:t>
+            </a:r>
+            <a:r>
+              <a:rPr lang="en-US" sz="2700" dirty="0" spc="-15" kern="0">
+                <a:solidFill>
+                  <a:srgbClr val="F3EEE3"/>
+                </a:solidFill>
+                <a:latin typeface="Be Vietnam Pro" pitchFamily="34" charset="0"/>
+                <a:ea typeface="Be Vietnam Pro" pitchFamily="34" charset="-122"/>
+                <a:cs typeface="Be Vietnam Pro" pitchFamily="34" charset="-120"/>
+              </a:rPr>
+              <a:t> toán</a:t>
             </a:r>
             <a:r>
               <a:rPr lang="en-US" sz="2700" dirty="0" spc="-2" kern="0">
@@ -15309,40 +15112,40 @@
                 <a:ea typeface="Be Vietnam Pro" pitchFamily="34" charset="-122"/>
                 <a:cs typeface="Be Vietnam Pro" pitchFamily="34" charset="-120"/>
               </a:rPr>
-              <a:t> nó</a:t>
-            </a:r>
-            <a:r>
-              <a:rPr lang="en-US" sz="2700" dirty="0" spc="-1" kern="0">
-                <a:solidFill>
-                  <a:srgbClr val="F3EEE3"/>
-                </a:solidFill>
-                <a:latin typeface="Be Vietnam Pro" pitchFamily="34" charset="0"/>
-                <a:ea typeface="Be Vietnam Pro" pitchFamily="34" charset="-122"/>
-                <a:cs typeface="Be Vietnam Pro" pitchFamily="34" charset="-120"/>
-              </a:rPr>
-              <a:t> thuộc</a:t>
-            </a:r>
-            <a:r>
-              <a:rPr lang="en-US" sz="2700" dirty="0" spc="-3" kern="0">
-                <a:solidFill>
-                  <a:srgbClr val="F3EEE3"/>
-                </a:solidFill>
-                <a:latin typeface="Be Vietnam Pro" pitchFamily="34" charset="0"/>
-                <a:ea typeface="Be Vietnam Pro" pitchFamily="34" charset="-122"/>
-                <a:cs typeface="Be Vietnam Pro" pitchFamily="34" charset="-120"/>
-              </a:rPr>
-              <a:t> nhóm</a:t>
-            </a:r>
-            <a:r>
-              <a:rPr lang="en-US" sz="2700" dirty="0" spc="-1" kern="0">
-                <a:solidFill>
-                  <a:srgbClr val="F3EEE3"/>
-                </a:solidFill>
-                <a:latin typeface="Be Vietnam Pro" pitchFamily="34" charset="0"/>
-                <a:ea typeface="Be Vietnam Pro" pitchFamily="34" charset="-122"/>
-                <a:cs typeface="Be Vietnam Pro" pitchFamily="34" charset="-120"/>
-              </a:rPr>
-              <a:t> nào,</a:t>
+              <a:t> nào giúp</a:t>
+            </a:r>
+            <a:r>
+              <a:rPr lang="en-US" sz="2700" dirty="0" spc="-8" kern="0">
+                <a:solidFill>
+                  <a:srgbClr val="F3EEE3"/>
+                </a:solidFill>
+                <a:latin typeface="Be Vietnam Pro" pitchFamily="34" charset="0"/>
+                <a:ea typeface="Be Vietnam Pro" pitchFamily="34" charset="-122"/>
+                <a:cs typeface="Be Vietnam Pro" pitchFamily="34" charset="-120"/>
+              </a:rPr>
+              <a:t> bỏ</a:t>
+            </a:r>
+            <a:r>
+              <a:rPr lang="en-US" sz="2700" dirty="0" spc="-2" kern="0">
+                <a:solidFill>
+                  <a:srgbClr val="F3EEE3"/>
+                </a:solidFill>
+                <a:latin typeface="Be Vietnam Pro" pitchFamily="34" charset="0"/>
+                <a:ea typeface="Be Vietnam Pro" pitchFamily="34" charset="-122"/>
+                <a:cs typeface="Be Vietnam Pro" pitchFamily="34" charset="-120"/>
+              </a:rPr>
+              <a:t> qua</a:t>
+            </a:r>
+            <a:r>
+              <a:rPr lang="en-US" sz="2700" dirty="0" spc="-15" kern="0">
+                <a:solidFill>
+                  <a:srgbClr val="F3EEE3"/>
+                </a:solidFill>
+                <a:latin typeface="Be Vietnam Pro" pitchFamily="34" charset="0"/>
+                <a:ea typeface="Be Vietnam Pro" pitchFamily="34" charset="-122"/>
+                <a:cs typeface="Be Vietnam Pro" pitchFamily="34" charset="-120"/>
+              </a:rPr>
+              <a:t> tệp</a:t>
             </a:r>
             <a:endParaRPr lang="en-US" sz="2700" dirty="0"/>
           </a:p>
@@ -15357,15 +15160,15 @@
               <a:buNone/>
             </a:pPr>
             <a:r>
-              <a:rPr lang="en-US" sz="2700" dirty="0" spc="-24" kern="0">
-                <a:solidFill>
-                  <a:srgbClr val="F3EEE3"/>
-                </a:solidFill>
-                <a:latin typeface="Be Vietnam Pro" pitchFamily="34" charset="0"/>
-                <a:ea typeface="Be Vietnam Pro" pitchFamily="34" charset="-122"/>
-                <a:cs typeface="Be Vietnam Pro" pitchFamily="34" charset="-120"/>
-              </a:rPr>
-              <a:t>và</a:t>
+              <a:rPr lang="en-US" sz="2700" dirty="0" spc="2" kern="0">
+                <a:solidFill>
+                  <a:srgbClr val="F3EEE3"/>
+                </a:solidFill>
+                <a:latin typeface="Be Vietnam Pro" pitchFamily="34" charset="0"/>
+                <a:ea typeface="Be Vietnam Pro" pitchFamily="34" charset="-122"/>
+                <a:cs typeface="Be Vietnam Pro" pitchFamily="34" charset="-120"/>
+              </a:rPr>
+              <a:t>chắc</a:t>
             </a:r>
             <a:r>
               <a:rPr lang="en-US" sz="2700" dirty="0" spc="0" kern="0">
@@ -15376,18 +15179,7 @@
                 <a:ea typeface="Be Vietnam Pro" pitchFamily="34" charset="-122"/>
                 <a:cs typeface="Be Vietnam Pro" pitchFamily="34" charset="-120"/>
               </a:rPr>
-              <a:t> có</a:t>
-            </a:r>
-            <a:r>
-              <a:rPr lang="en-US" sz="2700" dirty="0" spc="-1" kern="0">
-                <a:solidFill>
-                  <a:srgbClr val="F3EEE3"/>
-                </a:solidFill>
-                <a:latin typeface="Be Vietnam Pro" pitchFamily="34" charset="0"/>
-                <a:ea typeface="Be Vietnam Pro" pitchFamily="34" charset="-122"/>
-                <a:cs typeface="Be Vietnam Pro" pitchFamily="34" charset="-120"/>
-              </a:rPr>
-              <a:t> cần</a:t>
+              <a:t> chắn</a:t>
             </a:r>
             <a:r>
               <a:rPr lang="en-US" sz="2700" dirty="0" spc="-2" kern="0">
@@ -15398,140 +15190,29 @@
                 <a:ea typeface="Be Vietnam Pro" pitchFamily="34" charset="-122"/>
                 <a:cs typeface="Be Vietnam Pro" pitchFamily="34" charset="-120"/>
               </a:rPr>
-              <a:t> nắm</a:t>
-            </a:r>
-            <a:r>
-              <a:rPr lang="en-US" sz="2700" dirty="0" spc="1" kern="0">
-                <a:solidFill>
-                  <a:srgbClr val="F3EEE3"/>
-                </a:solidFill>
-                <a:latin typeface="Be Vietnam Pro" pitchFamily="34" charset="0"/>
-                <a:ea typeface="Be Vietnam Pro" pitchFamily="34" charset="-122"/>
-                <a:cs typeface="Be Vietnam Pro" pitchFamily="34" charset="-120"/>
-              </a:rPr>
-              <a:t> chi</a:t>
-            </a:r>
-            <a:r>
-              <a:rPr lang="en-US" sz="2700" dirty="0" spc="-5" kern="0">
-                <a:solidFill>
-                  <a:srgbClr val="F3EEE3"/>
-                </a:solidFill>
-                <a:latin typeface="Be Vietnam Pro" pitchFamily="34" charset="0"/>
-                <a:ea typeface="Be Vietnam Pro" pitchFamily="34" charset="-122"/>
-                <a:cs typeface="Be Vietnam Pro" pitchFamily="34" charset="-120"/>
-              </a:rPr>
-              <a:t> tiết</a:t>
-            </a:r>
-            <a:r>
-              <a:rPr lang="en-US" sz="2700" dirty="0" spc="0" kern="0">
-                <a:solidFill>
-                  <a:srgbClr val="F3EEE3"/>
-                </a:solidFill>
-                <a:latin typeface="Be Vietnam Pro" pitchFamily="34" charset="0"/>
-                <a:ea typeface="Be Vietnam Pro" pitchFamily="34" charset="-122"/>
-                <a:cs typeface="Be Vietnam Pro" pitchFamily="34" charset="-120"/>
-              </a:rPr>
-              <a:t> cài</a:t>
-            </a:r>
-            <a:r>
-              <a:rPr lang="en-US" sz="2700" dirty="0" spc="1" kern="0">
-                <a:solidFill>
-                  <a:srgbClr val="F3EEE3"/>
-                </a:solidFill>
-                <a:latin typeface="Be Vietnam Pro" pitchFamily="34" charset="0"/>
-                <a:ea typeface="Be Vietnam Pro" pitchFamily="34" charset="-122"/>
-                <a:cs typeface="Be Vietnam Pro" pitchFamily="34" charset="-120"/>
-              </a:rPr>
-              <a:t> đặt</a:t>
-            </a:r>
-            <a:r>
-              <a:rPr lang="en-US" sz="2700" dirty="0" spc="-2" kern="0">
-                <a:solidFill>
-                  <a:srgbClr val="F3EEE3"/>
-                </a:solidFill>
-                <a:latin typeface="Be Vietnam Pro" pitchFamily="34" charset="0"/>
-                <a:ea typeface="Be Vietnam Pro" pitchFamily="34" charset="-122"/>
-                <a:cs typeface="Be Vietnam Pro" pitchFamily="34" charset="-120"/>
-              </a:rPr>
-              <a:t> không?</a:t>
-            </a:r>
-            <a:endParaRPr lang="en-US" sz="2700" dirty="0"/>
-          </a:p>
-          <a:p>
-            <a:pPr algn="l" indent="0" marL="0">
-              <a:lnSpc>
-                <a:spcPts val="3645"/>
-              </a:lnSpc>
-              <a:spcAft>
-                <a:spcPts val="1350"/>
-              </a:spcAft>
-              <a:buNone/>
-            </a:pPr>
-            <a:r>
-              <a:rPr lang="en-US" sz="2700" dirty="0" spc="0" kern="0">
-                <a:solidFill>
-                  <a:srgbClr val="F3EEE3"/>
-                </a:solidFill>
-                <a:latin typeface="Be Vietnam Pro" pitchFamily="34" charset="0"/>
-                <a:ea typeface="Be Vietnam Pro" pitchFamily="34" charset="-122"/>
-                <a:cs typeface="Be Vietnam Pro" pitchFamily="34" charset="-120"/>
-              </a:rPr>
-              <a:t>Còn</a:t>
-            </a:r>
-            <a:r>
-              <a:rPr lang="en-US" sz="2700" dirty="0" spc="-14" kern="0">
-                <a:solidFill>
-                  <a:srgbClr val="F3EEE3"/>
-                </a:solidFill>
-                <a:latin typeface="Be Vietnam Pro" pitchFamily="34" charset="0"/>
-                <a:ea typeface="Be Vietnam Pro" pitchFamily="34" charset="-122"/>
-                <a:cs typeface="Be Vietnam Pro" pitchFamily="34" charset="-120"/>
-              </a:rPr>
-              <a:t> với</a:t>
-            </a:r>
-            <a:r>
-              <a:rPr lang="en-US" sz="2700" dirty="0" spc="-2" kern="0">
-                <a:solidFill>
-                  <a:srgbClr val="F3EEE3"/>
-                </a:solidFill>
-                <a:latin typeface="Be Vietnam Pro" pitchFamily="34" charset="0"/>
-                <a:ea typeface="Be Vietnam Pro" pitchFamily="34" charset="-122"/>
-                <a:cs typeface="Be Vietnam Pro" pitchFamily="34" charset="-120"/>
-              </a:rPr>
-              <a:t> năm</a:t>
-            </a:r>
-            <a:r>
-              <a:rPr lang="en-US" sz="2700" dirty="0" spc="-7" kern="0">
-                <a:solidFill>
-                  <a:srgbClr val="F3EEE3"/>
-                </a:solidFill>
-                <a:latin typeface="Be Vietnam Pro" pitchFamily="34" charset="0"/>
-                <a:ea typeface="Be Vietnam Pro" pitchFamily="34" charset="-122"/>
-                <a:cs typeface="Be Vietnam Pro" pitchFamily="34" charset="-120"/>
-              </a:rPr>
-              <a:t> sao,</a:t>
-            </a:r>
-            <a:r>
-              <a:rPr lang="en-US" sz="2700" dirty="0" spc="-2" kern="0">
-                <a:solidFill>
-                  <a:srgbClr val="F3EEE3"/>
-                </a:solidFill>
-                <a:latin typeface="Be Vietnam Pro" pitchFamily="34" charset="0"/>
-                <a:ea typeface="Be Vietnam Pro" pitchFamily="34" charset="-122"/>
-                <a:cs typeface="Be Vietnam Pro" pitchFamily="34" charset="-120"/>
-              </a:rPr>
-              <a:t> nguồn</a:t>
-            </a:r>
-            <a:r>
-              <a:rPr lang="en-US" sz="2700" dirty="0" spc="-15" kern="0">
-                <a:solidFill>
-                  <a:srgbClr val="F3EEE3"/>
-                </a:solidFill>
-                <a:latin typeface="Be Vietnam Pro" pitchFamily="34" charset="0"/>
-                <a:ea typeface="Be Vietnam Pro" pitchFamily="34" charset="-122"/>
-                <a:cs typeface="Be Vietnam Pro" pitchFamily="34" charset="-120"/>
-              </a:rPr>
-              <a:t> khuyên</a:t>
+              <a:t> không</a:t>
+            </a:r>
+            <a:r>
+              <a:rPr lang="en-US" sz="2700" dirty="0" spc="6" kern="0">
+                <a:solidFill>
+                  <a:srgbClr val="F3EEE3"/>
+                </a:solidFill>
+                <a:latin typeface="Be Vietnam Pro" pitchFamily="34" charset="0"/>
+                <a:ea typeface="Be Vietnam Pro" pitchFamily="34" charset="-122"/>
+                <a:cs typeface="Be Vietnam Pro" pitchFamily="34" charset="-120"/>
+              </a:rPr>
+              <a:t> chứa</a:t>
+            </a:r>
+            <a:r>
+              <a:rPr lang="en-US" sz="2700" dirty="0" spc="-3" kern="0">
+                <a:solidFill>
+                  <a:srgbClr val="F3EEE3"/>
+                </a:solidFill>
+                <a:latin typeface="Be Vietnam Pro" pitchFamily="34" charset="0"/>
+                <a:ea typeface="Be Vietnam Pro" pitchFamily="34" charset="-122"/>
+                <a:cs typeface="Be Vietnam Pro" pitchFamily="34" charset="-120"/>
+              </a:rPr>
+              <a:t> khóa,</a:t>
             </a:r>
             <a:endParaRPr lang="en-US" sz="2700" dirty="0"/>
           </a:p>
@@ -15543,15 +15224,37 @@
               <a:buNone/>
             </a:pPr>
             <a:r>
-              <a:rPr lang="en-US" sz="2700" dirty="0" spc="2" kern="0">
-                <a:solidFill>
-                  <a:srgbClr val="F3EEE3"/>
-                </a:solidFill>
-                <a:latin typeface="Be Vietnam Pro" pitchFamily="34" charset="0"/>
-                <a:ea typeface="Be Vietnam Pro" pitchFamily="34" charset="-122"/>
-                <a:cs typeface="Be Vietnam Pro" pitchFamily="34" charset="-120"/>
-              </a:rPr>
-              <a:t>cố</a:t>
+              <a:rPr lang="en-US" sz="2700" dirty="0" spc="-24" kern="0">
+                <a:solidFill>
+                  <a:srgbClr val="F3EEE3"/>
+                </a:solidFill>
+                <a:latin typeface="Be Vietnam Pro" pitchFamily="34" charset="0"/>
+                <a:ea typeface="Be Vietnam Pro" pitchFamily="34" charset="-122"/>
+                <a:cs typeface="Be Vietnam Pro" pitchFamily="34" charset="-120"/>
+              </a:rPr>
+              <a:t>và</a:t>
+            </a:r>
+            <a:r>
+              <a:rPr lang="en-US" sz="2700" dirty="0" spc="-3" kern="0">
+                <a:solidFill>
+                  <a:srgbClr val="F3EEE3"/>
+                </a:solidFill>
+                <a:latin typeface="Be Vietnam Pro" pitchFamily="34" charset="0"/>
+                <a:ea typeface="Be Vietnam Pro" pitchFamily="34" charset="-122"/>
+                <a:cs typeface="Be Vietnam Pro" pitchFamily="34" charset="-120"/>
+              </a:rPr>
+              <a:t> nó</a:t>
+            </a:r>
+            <a:r>
+              <a:rPr lang="en-US" sz="2700" dirty="0" spc="0" kern="0">
+                <a:solidFill>
+                  <a:srgbClr val="F3EEE3"/>
+                </a:solidFill>
+                <a:latin typeface="Be Vietnam Pro" pitchFamily="34" charset="0"/>
+                <a:ea typeface="Be Vietnam Pro" pitchFamily="34" charset="-122"/>
+                <a:cs typeface="Be Vietnam Pro" pitchFamily="34" charset="-120"/>
+              </a:rPr>
+              <a:t> có</a:t>
             </a:r>
             <a:r>
               <a:rPr lang="en-US" sz="2700" dirty="0" spc="-2" kern="0">
@@ -15562,29 +15265,51 @@
                 <a:ea typeface="Be Vietnam Pro" pitchFamily="34" charset="-122"/>
                 <a:cs typeface="Be Vietnam Pro" pitchFamily="34" charset="-120"/>
               </a:rPr>
-              <a:t> hiểu</a:t>
-            </a:r>
-            <a:r>
-              <a:rPr lang="en-US" sz="2700" dirty="0" spc="21" kern="0">
-                <a:solidFill>
-                  <a:srgbClr val="F3EEE3"/>
-                </a:solidFill>
-                <a:latin typeface="Be Vietnam Pro" pitchFamily="34" charset="0"/>
-                <a:ea typeface="Be Vietnam Pro" pitchFamily="34" charset="-122"/>
-                <a:cs typeface="Be Vietnam Pro" pitchFamily="34" charset="-120"/>
-              </a:rPr>
-              <a:t> điều</a:t>
-            </a:r>
-            <a:r>
-              <a:rPr lang="en-US" sz="2700" dirty="0" spc="-4" kern="0">
-                <a:solidFill>
-                  <a:srgbClr val="F3EEE3"/>
-                </a:solidFill>
-                <a:latin typeface="Be Vietnam Pro" pitchFamily="34" charset="0"/>
-                <a:ea typeface="Be Vietnam Pro" pitchFamily="34" charset="-122"/>
-                <a:cs typeface="Be Vietnam Pro" pitchFamily="34" charset="-120"/>
-              </a:rPr>
-              <a:t> gì?</a:t>
+              <a:t> thể</a:t>
+            </a:r>
+            <a:r>
+              <a:rPr lang="en-US" sz="2700" dirty="0" spc="-9" kern="0">
+                <a:solidFill>
+                  <a:srgbClr val="F3EEE3"/>
+                </a:solidFill>
+                <a:latin typeface="Be Vietnam Pro" pitchFamily="34" charset="0"/>
+                <a:ea typeface="Be Vietnam Pro" pitchFamily="34" charset="-122"/>
+                <a:cs typeface="Be Vietnam Pro" pitchFamily="34" charset="-120"/>
+              </a:rPr>
+              <a:t> sai</a:t>
+            </a:r>
+            <a:r>
+              <a:rPr lang="en-US" sz="2700" dirty="0" spc="-3" kern="0">
+                <a:solidFill>
+                  <a:srgbClr val="F3EEE3"/>
+                </a:solidFill>
+                <a:latin typeface="Be Vietnam Pro" pitchFamily="34" charset="0"/>
+                <a:ea typeface="Be Vietnam Pro" pitchFamily="34" charset="-122"/>
+                <a:cs typeface="Be Vietnam Pro" pitchFamily="34" charset="-120"/>
+              </a:rPr>
+              <a:t> theo</a:t>
+            </a:r>
+            <a:r>
+              <a:rPr lang="en-US" sz="2700" dirty="0" spc="0" kern="0">
+                <a:solidFill>
+                  <a:srgbClr val="F3EEE3"/>
+                </a:solidFill>
+                <a:latin typeface="Be Vietnam Pro" pitchFamily="34" charset="0"/>
+                <a:ea typeface="Be Vietnam Pro" pitchFamily="34" charset="-122"/>
+                <a:cs typeface="Be Vietnam Pro" pitchFamily="34" charset="-120"/>
+              </a:rPr>
+              <a:t> chiều</a:t>
+            </a:r>
+            <a:r>
+              <a:rPr lang="en-US" sz="2700" dirty="0" spc="-3" kern="0">
+                <a:solidFill>
+                  <a:srgbClr val="F3EEE3"/>
+                </a:solidFill>
+                <a:latin typeface="Be Vietnam Pro" pitchFamily="34" charset="0"/>
+                <a:ea typeface="Be Vietnam Pro" pitchFamily="34" charset="-122"/>
+                <a:cs typeface="Be Vietnam Pro" pitchFamily="34" charset="-120"/>
+              </a:rPr>
+              <a:t> nào?</a:t>
             </a:r>
             <a:endParaRPr lang="en-US" sz="2700" dirty="0"/>
           </a:p>
@@ -15688,7 +15413,7 @@
               <a:buNone/>
             </a:pPr>
             <a:r>
-              <a:rPr lang="en-US" sz="2700" b="1" dirty="0" spc="-16" kern="0">
+              <a:rPr lang="en-US" sz="2700" b="1" dirty="0" spc="2" kern="0">
                 <a:solidFill>
                   <a:srgbClr val="3DD6A0"/>
                 </a:solidFill>
@@ -15696,10 +15421,10 @@
                 <a:ea typeface="Be Vietnam Pro" pitchFamily="34" charset="-122"/>
                 <a:cs typeface="Be Vietnam Pro" pitchFamily="34" charset="-120"/>
               </a:rPr>
-              <a:t>Một</a:t>
-            </a:r>
-            <a:r>
-              <a:rPr lang="en-US" sz="2700" b="1" dirty="0" spc="1" kern="0">
+              <a:t>Bộ</a:t>
+            </a:r>
+            <a:r>
+              <a:rPr lang="en-US" sz="2700" b="1" dirty="0" spc="-8" kern="0">
                 <a:solidFill>
                   <a:srgbClr val="3DD6A0"/>
                 </a:solidFill>
@@ -15707,40 +15432,7 @@
                 <a:ea typeface="Be Vietnam Pro" pitchFamily="34" charset="-122"/>
                 <a:cs typeface="Be Vietnam Pro" pitchFamily="34" charset="-120"/>
               </a:rPr>
-              <a:t> sao</a:t>
-            </a:r>
-            <a:r>
-              <a:rPr lang="en-US" sz="2700" b="1" dirty="0" spc="-5" kern="0">
-                <a:solidFill>
-                  <a:srgbClr val="3DD6A0"/>
-                </a:solidFill>
-                <a:latin typeface="Be Vietnam Pro" pitchFamily="34" charset="0"/>
-                <a:ea typeface="Be Vietnam Pro" pitchFamily="34" charset="-122"/>
-                <a:cs typeface="Be Vietnam Pro" pitchFamily="34" charset="-120"/>
-              </a:rPr>
-              <a:t> là</a:t>
-            </a:r>
-            <a:r>
-              <a:rPr lang="en-US" sz="2700" b="1" dirty="0" spc="-4" kern="0">
-                <a:solidFill>
-                  <a:srgbClr val="3DD6A0"/>
-                </a:solidFill>
-                <a:latin typeface="Be Vietnam Pro" pitchFamily="34" charset="0"/>
-                <a:ea typeface="Be Vietnam Pro" pitchFamily="34" charset="-122"/>
-                <a:cs typeface="Be Vietnam Pro" pitchFamily="34" charset="-120"/>
-              </a:rPr>
-              <a:t> nâng</a:t>
-            </a:r>
-            <a:r>
-              <a:rPr lang="en-US" sz="2700" b="1" dirty="0" spc="0" kern="0">
-                <a:solidFill>
-                  <a:srgbClr val="3DD6A0"/>
-                </a:solidFill>
-                <a:latin typeface="Be Vietnam Pro" pitchFamily="34" charset="0"/>
-                <a:ea typeface="Be Vietnam Pro" pitchFamily="34" charset="-122"/>
-                <a:cs typeface="Be Vietnam Pro" pitchFamily="34" charset="-120"/>
-              </a:rPr>
-              <a:t> cao</a:t>
+              <a:t> lọc Bloom</a:t>
             </a:r>
             <a:endParaRPr lang="en-US" sz="2700" dirty="0"/>
           </a:p>
@@ -15774,15 +15466,15 @@
               <a:buNone/>
             </a:pPr>
             <a:r>
-              <a:rPr lang="en-US" sz="2400" dirty="0" spc="-5" kern="0">
-                <a:solidFill>
-                  <a:srgbClr val="F3EEE3"/>
-                </a:solidFill>
-                <a:latin typeface="Be Vietnam Pro" pitchFamily="34" charset="0"/>
-                <a:ea typeface="Be Vietnam Pro" pitchFamily="34" charset="-122"/>
-                <a:cs typeface="Be Vietnam Pro" pitchFamily="34" charset="-120"/>
-              </a:rPr>
-              <a:t>Biết</a:t>
+              <a:rPr lang="en-US" sz="2400" dirty="0" spc="-1" kern="0">
+                <a:solidFill>
+                  <a:srgbClr val="F3EEE3"/>
+                </a:solidFill>
+                <a:latin typeface="Be Vietnam Pro" pitchFamily="34" charset="0"/>
+                <a:ea typeface="Be Vietnam Pro" pitchFamily="34" charset="-122"/>
+                <a:cs typeface="Be Vietnam Pro" pitchFamily="34" charset="-120"/>
+              </a:rPr>
+              <a:t>Chỉ</a:t>
             </a:r>
             <a:r>
               <a:rPr lang="en-US" sz="2400" dirty="0" spc="0" kern="0">
@@ -15793,18 +15485,29 @@
                 <a:ea typeface="Be Vietnam Pro" pitchFamily="34" charset="-122"/>
                 <a:cs typeface="Be Vietnam Pro" pitchFamily="34" charset="-120"/>
               </a:rPr>
-              <a:t> thì</a:t>
-            </a:r>
-            <a:r>
-              <a:rPr lang="en-US" sz="2400" dirty="0" spc="-15" kern="0">
-                <a:solidFill>
-                  <a:srgbClr val="F3EEE3"/>
-                </a:solidFill>
-                <a:latin typeface="Be Vietnam Pro" pitchFamily="34" charset="0"/>
-                <a:ea typeface="Be Vietnam Pro" pitchFamily="34" charset="-122"/>
-                <a:cs typeface="Be Vietnam Pro" pitchFamily="34" charset="-120"/>
-              </a:rPr>
-              <a:t> tốt</a:t>
+              <a:t> báo</a:t>
+            </a:r>
+            <a:r>
+              <a:rPr lang="en-US" sz="2400" dirty="0" spc="2" kern="0">
+                <a:solidFill>
+                  <a:srgbClr val="F3EEE3"/>
+                </a:solidFill>
+                <a:latin typeface="Be Vietnam Pro" pitchFamily="34" charset="0"/>
+                <a:ea typeface="Be Vietnam Pro" pitchFamily="34" charset="-122"/>
+                <a:cs typeface="Be Vietnam Pro" pitchFamily="34" charset="-120"/>
+              </a:rPr>
+              <a:t> nhầm</a:t>
+            </a:r>
+            <a:r>
+              <a:rPr lang="en-US" sz="2400" dirty="0" spc="3" kern="0">
+                <a:solidFill>
+                  <a:srgbClr val="F3EEE3"/>
+                </a:solidFill>
+                <a:latin typeface="Be Vietnam Pro" pitchFamily="34" charset="0"/>
+                <a:ea typeface="Be Vietnam Pro" pitchFamily="34" charset="-122"/>
+                <a:cs typeface="Be Vietnam Pro" pitchFamily="34" charset="-120"/>
+              </a:rPr>
+              <a:t> là</a:t>
             </a:r>
             <a:r>
               <a:rPr lang="en-US" sz="2400" dirty="0" spc="0" kern="0">
@@ -15815,29 +15518,7 @@
                 <a:ea typeface="Be Vietnam Pro" pitchFamily="34" charset="-122"/>
                 <a:cs typeface="Be Vietnam Pro" pitchFamily="34" charset="-120"/>
               </a:rPr>
-              <a:t> cho</a:t>
-            </a:r>
-            <a:r>
-              <a:rPr lang="en-US" sz="2400" dirty="0" spc="27" kern="0">
-                <a:solidFill>
-                  <a:srgbClr val="F3EEE3"/>
-                </a:solidFill>
-                <a:latin typeface="Be Vietnam Pro" pitchFamily="34" charset="0"/>
-                <a:ea typeface="Be Vietnam Pro" pitchFamily="34" charset="-122"/>
-                <a:cs typeface="Be Vietnam Pro" pitchFamily="34" charset="-120"/>
-              </a:rPr>
-              <a:t> ứng</a:t>
-            </a:r>
-            <a:r>
-              <a:rPr lang="en-US" sz="2400" dirty="0" spc="-1" kern="0">
-                <a:solidFill>
-                  <a:srgbClr val="F3EEE3"/>
-                </a:solidFill>
-                <a:latin typeface="Be Vietnam Pro" pitchFamily="34" charset="0"/>
-                <a:ea typeface="Be Vietnam Pro" pitchFamily="34" charset="-122"/>
-                <a:cs typeface="Be Vietnam Pro" pitchFamily="34" charset="-120"/>
-              </a:rPr>
-              <a:t> viên</a:t>
+              <a:t> có,</a:t>
             </a:r>
             <a:endParaRPr lang="en-US" sz="2400" dirty="0"/>
           </a:p>
@@ -15849,6 +15530,17 @@
               <a:buNone/>
             </a:pPr>
             <a:r>
+              <a:rPr lang="en-US" sz="2400" dirty="0" spc="0" kern="0">
+                <a:solidFill>
+                  <a:srgbClr val="F3EEE3"/>
+                </a:solidFill>
+                <a:latin typeface="Be Vietnam Pro" pitchFamily="34" charset="0"/>
+                <a:ea typeface="Be Vietnam Pro" pitchFamily="34" charset="-122"/>
+                <a:cs typeface="Be Vietnam Pro" pitchFamily="34" charset="-120"/>
+              </a:rPr>
+              <a:t>không</a:t>
+            </a:r>
+            <a:r>
               <a:rPr lang="en-US" sz="2400" dirty="0" spc="1" kern="0">
                 <a:solidFill>
                   <a:srgbClr val="F3EEE3"/>
@@ -15857,18 +15549,29 @@
                 <a:ea typeface="Be Vietnam Pro" pitchFamily="34" charset="-122"/>
                 <a:cs typeface="Be Vietnam Pro" pitchFamily="34" charset="-120"/>
               </a:rPr>
-              <a:t>cấp cao</a:t>
-            </a:r>
-            <a:r>
-              <a:rPr lang="en-US" sz="2400" dirty="0" spc="-2" kern="0">
-                <a:solidFill>
-                  <a:srgbClr val="F3EEE3"/>
-                </a:solidFill>
-                <a:latin typeface="Be Vietnam Pro" pitchFamily="34" charset="0"/>
-                <a:ea typeface="Be Vietnam Pro" pitchFamily="34" charset="-122"/>
-                <a:cs typeface="Be Vietnam Pro" pitchFamily="34" charset="-120"/>
-              </a:rPr>
-              <a:t> (senior).</a:t>
+              <a:t> báo</a:t>
+            </a:r>
+            <a:r>
+              <a:rPr lang="en-US" sz="2400" dirty="0" spc="2" kern="0">
+                <a:solidFill>
+                  <a:srgbClr val="F3EEE3"/>
+                </a:solidFill>
+                <a:latin typeface="Be Vietnam Pro" pitchFamily="34" charset="0"/>
+                <a:ea typeface="Be Vietnam Pro" pitchFamily="34" charset="-122"/>
+                <a:cs typeface="Be Vietnam Pro" pitchFamily="34" charset="-120"/>
+              </a:rPr>
+              <a:t> nhầm là</a:t>
+            </a:r>
+            <a:r>
+              <a:rPr lang="en-US" sz="2400" dirty="0" spc="0" kern="0">
+                <a:solidFill>
+                  <a:srgbClr val="F3EEE3"/>
+                </a:solidFill>
+                <a:latin typeface="Be Vietnam Pro" pitchFamily="34" charset="0"/>
+                <a:ea typeface="Be Vietnam Pro" pitchFamily="34" charset="-122"/>
+                <a:cs typeface="Be Vietnam Pro" pitchFamily="34" charset="-120"/>
+              </a:rPr>
+              <a:t> không.</a:t>
             </a:r>
             <a:endParaRPr lang="en-US" sz="2400" dirty="0"/>
           </a:p>
@@ -15972,7 +15675,7 @@
               <a:buNone/>
             </a:pPr>
             <a:r>
-              <a:rPr lang="en-US" sz="2700" b="1" dirty="0" spc="3" kern="0">
+              <a:rPr lang="en-US" sz="2700" b="1" dirty="0" spc="-6" kern="0">
                 <a:solidFill>
                   <a:srgbClr val="FF6A4D"/>
                 </a:solidFill>
@@ -15980,10 +15683,10 @@
                 <a:ea typeface="Be Vietnam Pro" pitchFamily="34" charset="-122"/>
                 <a:cs typeface="Be Vietnam Pro" pitchFamily="34" charset="-120"/>
               </a:rPr>
-              <a:t>Chi</a:t>
-            </a:r>
-            <a:r>
-              <a:rPr lang="en-US" sz="2700" b="1" dirty="0" spc="-7" kern="0">
+              <a:t>Thêm</a:t>
+            </a:r>
+            <a:r>
+              <a:rPr lang="en-US" sz="2700" b="1" dirty="0" spc="-15" kern="0">
                 <a:solidFill>
                   <a:srgbClr val="FF6A4D"/>
                 </a:solidFill>
@@ -15991,10 +15694,10 @@
                 <a:ea typeface="Be Vietnam Pro" pitchFamily="34" charset="-122"/>
                 <a:cs typeface="Be Vietnam Pro" pitchFamily="34" charset="-120"/>
               </a:rPr>
-              <a:t> tiết</a:t>
-            </a:r>
-            <a:r>
-              <a:rPr lang="en-US" sz="2700" b="1" dirty="0" spc="-3" kern="0">
+              <a:t> một</a:t>
+            </a:r>
+            <a:r>
+              <a:rPr lang="en-US" sz="2700" b="1" dirty="0" spc="-2" kern="0">
                 <a:solidFill>
                   <a:srgbClr val="FF6A4D"/>
                 </a:solidFill>
@@ -16002,21 +15705,10 @@
                 <a:ea typeface="Be Vietnam Pro" pitchFamily="34" charset="-122"/>
                 <a:cs typeface="Be Vietnam Pro" pitchFamily="34" charset="-120"/>
               </a:rPr>
-              <a:t> cài</a:t>
-            </a:r>
-            <a:r>
-              <a:rPr lang="en-US" sz="2700" b="1" dirty="0" spc="-2" kern="0">
-                <a:solidFill>
-                  <a:srgbClr val="FF6A4D"/>
-                </a:solidFill>
-                <a:latin typeface="Be Vietnam Pro" pitchFamily="34" charset="0"/>
-                <a:ea typeface="Be Vietnam Pro" pitchFamily="34" charset="-122"/>
-                <a:cs typeface="Be Vietnam Pro" pitchFamily="34" charset="-120"/>
-              </a:rPr>
-              <a:t> đặt</a:t>
-            </a:r>
-            <a:r>
-              <a:rPr lang="en-US" sz="2700" b="1" dirty="0" spc="-1" kern="0">
+              <a:t> nút</a:t>
+            </a:r>
+            <a:r>
+              <a:rPr lang="en-US" sz="2700" b="1" dirty="0" spc="0" kern="0">
                 <a:solidFill>
                   <a:srgbClr val="FF6A4D"/>
                 </a:solidFill>
@@ -16069,15 +15761,26 @@
               <a:buNone/>
             </a:pPr>
             <a:r>
-              <a:rPr lang="en-US" sz="2400" dirty="0" spc="-2" kern="0">
-                <a:solidFill>
-                  <a:srgbClr val="F3EEE3"/>
-                </a:solidFill>
-                <a:latin typeface="Be Vietnam Pro" pitchFamily="34" charset="0"/>
-                <a:ea typeface="Be Vietnam Pro" pitchFamily="34" charset="-122"/>
-                <a:cs typeface="Be Vietnam Pro" pitchFamily="34" charset="-120"/>
-              </a:rPr>
-              <a:t>Nói</a:t>
+              <a:rPr lang="en-US" sz="2400" dirty="0" spc="-1" kern="0">
+                <a:solidFill>
+                  <a:srgbClr val="F3EEE3"/>
+                </a:solidFill>
+                <a:latin typeface="Be Vietnam Pro" pitchFamily="34" charset="0"/>
+                <a:ea typeface="Be Vietnam Pro" pitchFamily="34" charset="-122"/>
+                <a:cs typeface="Be Vietnam Pro" pitchFamily="34" charset="-120"/>
+              </a:rPr>
+              <a:t>Chia</a:t>
+            </a:r>
+            <a:r>
+              <a:rPr lang="en-US" sz="2400" dirty="0" spc="-8" kern="0">
+                <a:solidFill>
+                  <a:srgbClr val="F3EEE3"/>
+                </a:solidFill>
+                <a:latin typeface="Be Vietnam Pro" pitchFamily="34" charset="0"/>
+                <a:ea typeface="Be Vietnam Pro" pitchFamily="34" charset="-122"/>
+                <a:cs typeface="Be Vietnam Pro" pitchFamily="34" charset="-120"/>
+              </a:rPr>
+              <a:t> lấy</a:t>
             </a:r>
             <a:r>
               <a:rPr lang="en-US" sz="2400" dirty="0" spc="0" kern="0">
@@ -16088,7 +15791,18 @@
                 <a:ea typeface="Be Vietnam Pro" pitchFamily="34" charset="-122"/>
                 <a:cs typeface="Be Vietnam Pro" pitchFamily="34" charset="-120"/>
               </a:rPr>
-              <a:t> chung,</a:t>
+              <a:t> dư</a:t>
+            </a:r>
+            <a:r>
+              <a:rPr lang="en-US" sz="2400" dirty="0" spc="3" kern="0">
+                <a:solidFill>
+                  <a:srgbClr val="F3EEE3"/>
+                </a:solidFill>
+                <a:latin typeface="Be Vietnam Pro" pitchFamily="34" charset="0"/>
+                <a:ea typeface="Be Vietnam Pro" pitchFamily="34" charset="-122"/>
+                <a:cs typeface="Be Vietnam Pro" pitchFamily="34" charset="-120"/>
+              </a:rPr>
+              <a:t> làm</a:t>
             </a:r>
             <a:r>
               <a:rPr lang="en-US" sz="2400" dirty="0" spc="1" kern="0">
@@ -16099,29 +15813,18 @@
                 <a:ea typeface="Be Vietnam Pro" pitchFamily="34" charset="-122"/>
                 <a:cs typeface="Be Vietnam Pro" pitchFamily="34" charset="-120"/>
               </a:rPr>
-              <a:t> nguồn nhấn</a:t>
-            </a:r>
-            <a:r>
-              <a:rPr lang="en-US" sz="2400" dirty="0" spc="-10" kern="0">
-                <a:solidFill>
-                  <a:srgbClr val="F3EEE3"/>
-                </a:solidFill>
-                <a:latin typeface="Be Vietnam Pro" pitchFamily="34" charset="0"/>
-                <a:ea typeface="Be Vietnam Pro" pitchFamily="34" charset="-122"/>
-                <a:cs typeface="Be Vietnam Pro" pitchFamily="34" charset="-120"/>
-              </a:rPr>
-              <a:t> vào</a:t>
-            </a:r>
-            <a:r>
-              <a:rPr lang="en-US" sz="2400" dirty="0" spc="-1" kern="0">
-                <a:solidFill>
-                  <a:srgbClr val="F3EEE3"/>
-                </a:solidFill>
-                <a:latin typeface="Be Vietnam Pro" pitchFamily="34" charset="0"/>
-                <a:ea typeface="Be Vietnam Pro" pitchFamily="34" charset="-122"/>
-                <a:cs typeface="Be Vietnam Pro" pitchFamily="34" charset="-120"/>
-              </a:rPr>
-              <a:t> cách</a:t>
+              <a:t> hầu</a:t>
+            </a:r>
+            <a:r>
+              <a:rPr lang="en-US" sz="2400" dirty="0" spc="-6" kern="0">
+                <a:solidFill>
+                  <a:srgbClr val="F3EEE3"/>
+                </a:solidFill>
+                <a:latin typeface="Be Vietnam Pro" pitchFamily="34" charset="0"/>
+                <a:ea typeface="Be Vietnam Pro" pitchFamily="34" charset="-122"/>
+                <a:cs typeface="Be Vietnam Pro" pitchFamily="34" charset="-120"/>
+              </a:rPr>
+              <a:t> hết</a:t>
             </a:r>
             <a:endParaRPr lang="en-US" sz="2400" dirty="0"/>
           </a:p>
@@ -16133,28 +15836,6 @@
               <a:buNone/>
             </a:pPr>
             <a:r>
-              <a:rPr lang="en-US" sz="2400" dirty="0" spc="4" kern="0">
-                <a:solidFill>
-                  <a:srgbClr val="F3EEE3"/>
-                </a:solidFill>
-                <a:latin typeface="Be Vietnam Pro" pitchFamily="34" charset="0"/>
-                <a:ea typeface="Be Vietnam Pro" pitchFamily="34" charset="-122"/>
-                <a:cs typeface="Be Vietnam Pro" pitchFamily="34" charset="-120"/>
-              </a:rPr>
-              <a:t>dùng</a:t>
-            </a:r>
-            <a:r>
-              <a:rPr lang="en-US" sz="2400" dirty="0" spc="-14" kern="0">
-                <a:solidFill>
-                  <a:srgbClr val="F3EEE3"/>
-                </a:solidFill>
-                <a:latin typeface="Be Vietnam Pro" pitchFamily="34" charset="0"/>
-                <a:ea typeface="Be Vietnam Pro" pitchFamily="34" charset="-122"/>
-                <a:cs typeface="Be Vietnam Pro" pitchFamily="34" charset="-120"/>
-              </a:rPr>
-              <a:t> trong</a:t>
-            </a:r>
-            <a:r>
               <a:rPr lang="en-US" sz="2400" dirty="0" spc="1" kern="0">
                 <a:solidFill>
                   <a:srgbClr val="F3EEE3"/>
@@ -16163,18 +15844,18 @@
                 <a:ea typeface="Be Vietnam Pro" pitchFamily="34" charset="-122"/>
                 <a:cs typeface="Be Vietnam Pro" pitchFamily="34" charset="-120"/>
               </a:rPr>
-              <a:t> hệ</a:t>
-            </a:r>
-            <a:r>
-              <a:rPr lang="en-US" sz="2400" dirty="0" spc="2" kern="0">
-                <a:solidFill>
-                  <a:srgbClr val="F3EEE3"/>
-                </a:solidFill>
-                <a:latin typeface="Be Vietnam Pro" pitchFamily="34" charset="0"/>
-                <a:ea typeface="Be Vietnam Pro" pitchFamily="34" charset="-122"/>
-                <a:cs typeface="Be Vietnam Pro" pitchFamily="34" charset="-120"/>
-              </a:rPr>
-              <a:t> thống</a:t>
+              <a:t>ánh</a:t>
+            </a:r>
+            <a:r>
+              <a:rPr lang="en-US" sz="2400" dirty="0" spc="-20" kern="0">
+                <a:solidFill>
+                  <a:srgbClr val="F3EEE3"/>
+                </a:solidFill>
+                <a:latin typeface="Be Vietnam Pro" pitchFamily="34" charset="0"/>
+                <a:ea typeface="Be Vietnam Pro" pitchFamily="34" charset="-122"/>
+                <a:cs typeface="Be Vietnam Pro" pitchFamily="34" charset="-120"/>
+              </a:rPr>
+              <a:t> xạ</a:t>
             </a:r>
             <a:r>
               <a:rPr lang="en-US" sz="2400" dirty="0" spc="-8" kern="0">
@@ -16185,18 +15866,40 @@
                 <a:ea typeface="Be Vietnam Pro" pitchFamily="34" charset="-122"/>
                 <a:cs typeface="Be Vietnam Pro" pitchFamily="34" charset="-120"/>
               </a:rPr>
-              <a:t> thật</a:t>
-            </a:r>
-            <a:r>
-              <a:rPr lang="en-US" sz="2400" dirty="0" spc="2" kern="0">
-                <a:solidFill>
-                  <a:srgbClr val="F3EEE3"/>
-                </a:solidFill>
-                <a:latin typeface="Be Vietnam Pro" pitchFamily="34" charset="0"/>
-                <a:ea typeface="Be Vietnam Pro" pitchFamily="34" charset="-122"/>
-                <a:cs typeface="Be Vietnam Pro" pitchFamily="34" charset="-120"/>
-              </a:rPr>
-              <a:t> hơn</a:t>
+              <a:t> mất</a:t>
+            </a:r>
+            <a:r>
+              <a:rPr lang="en-US" sz="2400" dirty="0" spc="-2" kern="0">
+                <a:solidFill>
+                  <a:srgbClr val="F3EEE3"/>
+                </a:solidFill>
+                <a:latin typeface="Be Vietnam Pro" pitchFamily="34" charset="0"/>
+                <a:ea typeface="Be Vietnam Pro" pitchFamily="34" charset="-122"/>
+                <a:cs typeface="Be Vietnam Pro" pitchFamily="34" charset="-120"/>
+              </a:rPr>
+              <a:t> hiệu</a:t>
+            </a:r>
+            <a:r>
+              <a:rPr lang="en-US" sz="2400" dirty="0" spc="9" kern="0">
+                <a:solidFill>
+                  <a:srgbClr val="F3EEE3"/>
+                </a:solidFill>
+                <a:latin typeface="Be Vietnam Pro" pitchFamily="34" charset="0"/>
+                <a:ea typeface="Be Vietnam Pro" pitchFamily="34" charset="-122"/>
+                <a:cs typeface="Be Vietnam Pro" pitchFamily="34" charset="-120"/>
+              </a:rPr>
+              <a:t> lực;</a:t>
+            </a:r>
+            <a:r>
+              <a:rPr lang="en-US" sz="2400" dirty="0" spc="0" kern="0">
+                <a:solidFill>
+                  <a:srgbClr val="F3EEE3"/>
+                </a:solidFill>
+                <a:latin typeface="Be Vietnam Pro" pitchFamily="34" charset="0"/>
+                <a:ea typeface="Be Vietnam Pro" pitchFamily="34" charset="-122"/>
+                <a:cs typeface="Be Vietnam Pro" pitchFamily="34" charset="-120"/>
+              </a:rPr>
+              <a:t> băm</a:t>
             </a:r>
             <a:endParaRPr lang="en-US" sz="2400" dirty="0"/>
           </a:p>
@@ -16208,15 +15911,59 @@
               <a:buNone/>
             </a:pPr>
             <a:r>
-              <a:rPr lang="en-US" sz="2400" dirty="0" spc="2" kern="0">
-                <a:solidFill>
-                  <a:srgbClr val="F3EEE3"/>
-                </a:solidFill>
-                <a:latin typeface="Be Vietnam Pro" pitchFamily="34" charset="0"/>
-                <a:ea typeface="Be Vietnam Pro" pitchFamily="34" charset="-122"/>
-                <a:cs typeface="Be Vietnam Pro" pitchFamily="34" charset="-120"/>
-              </a:rPr>
-              <a:t>là</a:t>
+              <a:rPr lang="en-US" sz="2400" dirty="0" spc="-10" kern="0">
+                <a:solidFill>
+                  <a:srgbClr val="F3EEE3"/>
+                </a:solidFill>
+                <a:latin typeface="Be Vietnam Pro" pitchFamily="34" charset="0"/>
+                <a:ea typeface="Be Vietnam Pro" pitchFamily="34" charset="-122"/>
+                <a:cs typeface="Be Vietnam Pro" pitchFamily="34" charset="-120"/>
+              </a:rPr>
+              <a:t>nhất</a:t>
+            </a:r>
+            <a:r>
+              <a:rPr lang="en-US" sz="2400" dirty="0" spc="1" kern="0">
+                <a:solidFill>
+                  <a:srgbClr val="F3EEE3"/>
+                </a:solidFill>
+                <a:latin typeface="Be Vietnam Pro" pitchFamily="34" charset="0"/>
+                <a:ea typeface="Be Vietnam Pro" pitchFamily="34" charset="-122"/>
+                <a:cs typeface="Be Vietnam Pro" pitchFamily="34" charset="-120"/>
+              </a:rPr>
+              <a:t> quán</a:t>
+            </a:r>
+            <a:r>
+              <a:rPr lang="en-US" sz="2400" dirty="0" spc="-1" kern="0">
+                <a:solidFill>
+                  <a:srgbClr val="F3EEE3"/>
+                </a:solidFill>
+                <a:latin typeface="Be Vietnam Pro" pitchFamily="34" charset="0"/>
+                <a:ea typeface="Be Vietnam Pro" pitchFamily="34" charset="-122"/>
+                <a:cs typeface="Be Vietnam Pro" pitchFamily="34" charset="-120"/>
+              </a:rPr>
+              <a:t> chỉ</a:t>
+            </a:r>
+            <a:r>
+              <a:rPr lang="en-US" sz="2400" dirty="0" spc="-13" kern="0">
+                <a:solidFill>
+                  <a:srgbClr val="F3EEE3"/>
+                </a:solidFill>
+                <a:latin typeface="Be Vietnam Pro" pitchFamily="34" charset="0"/>
+                <a:ea typeface="Be Vietnam Pro" pitchFamily="34" charset="-122"/>
+                <a:cs typeface="Be Vietnam Pro" pitchFamily="34" charset="-120"/>
+              </a:rPr>
+              <a:t> chuyển</a:t>
+            </a:r>
+            <a:r>
+              <a:rPr lang="en-US" sz="2400" dirty="0" spc="1" kern="0">
+                <a:solidFill>
+                  <a:srgbClr val="F3EEE3"/>
+                </a:solidFill>
+                <a:latin typeface="Be Vietnam Pro" pitchFamily="34" charset="0"/>
+                <a:ea typeface="Be Vietnam Pro" pitchFamily="34" charset="-122"/>
+                <a:cs typeface="Be Vietnam Pro" pitchFamily="34" charset="-120"/>
+              </a:rPr>
+              <a:t> ít</a:t>
             </a:r>
             <a:r>
               <a:rPr lang="en-US" sz="2400" dirty="0" spc="-2" kern="0">
@@ -16227,40 +15974,7 @@
                 <a:ea typeface="Be Vietnam Pro" pitchFamily="34" charset="-122"/>
                 <a:cs typeface="Be Vietnam Pro" pitchFamily="34" charset="-120"/>
               </a:rPr>
-              <a:t> chi</a:t>
-            </a:r>
-            <a:r>
-              <a:rPr lang="en-US" sz="2400" dirty="0" spc="-4" kern="0">
-                <a:solidFill>
-                  <a:srgbClr val="F3EEE3"/>
-                </a:solidFill>
-                <a:latin typeface="Be Vietnam Pro" pitchFamily="34" charset="0"/>
-                <a:ea typeface="Be Vietnam Pro" pitchFamily="34" charset="-122"/>
-                <a:cs typeface="Be Vietnam Pro" pitchFamily="34" charset="-120"/>
-              </a:rPr>
-              <a:t> tiết</a:t>
-            </a:r>
-            <a:r>
-              <a:rPr lang="en-US" sz="2400" dirty="0" spc="0" kern="0">
-                <a:solidFill>
-                  <a:srgbClr val="F3EEE3"/>
-                </a:solidFill>
-                <a:latin typeface="Be Vietnam Pro" pitchFamily="34" charset="0"/>
-                <a:ea typeface="Be Vietnam Pro" pitchFamily="34" charset="-122"/>
-                <a:cs typeface="Be Vietnam Pro" pitchFamily="34" charset="-120"/>
-              </a:rPr>
-              <a:t> cài</a:t>
-            </a:r>
-            <a:r>
-              <a:rPr lang="en-US" sz="2400" dirty="0" spc="1" kern="0">
-                <a:solidFill>
-                  <a:srgbClr val="F3EEE3"/>
-                </a:solidFill>
-                <a:latin typeface="Be Vietnam Pro" pitchFamily="34" charset="0"/>
-                <a:ea typeface="Be Vietnam Pro" pitchFamily="34" charset="-122"/>
-                <a:cs typeface="Be Vietnam Pro" pitchFamily="34" charset="-120"/>
-              </a:rPr>
-              <a:t> đặt.</a:t>
+              <a:t> khóa.</a:t>
             </a:r>
             <a:endParaRPr lang="en-US" sz="2400" dirty="0"/>
           </a:p>
@@ -18335,18 +18049,51 @@
                 <a:ea typeface="Be Vietnam Pro" pitchFamily="34" charset="-122"/>
                 <a:cs typeface="Be Vietnam Pro" pitchFamily="34" charset="-120"/>
               </a:rPr>
-              <a:t>ByteByteGo,</a:t>
-            </a:r>
-            <a:r>
-              <a:rPr lang="en-US" sz="2250" dirty="0" spc="-3" kern="0">
-                <a:solidFill>
-                  <a:srgbClr val="F3EEE3"/>
-                </a:solidFill>
-                <a:latin typeface="Be Vietnam Pro" pitchFamily="34" charset="0"/>
-                <a:ea typeface="Be Vietnam Pro" pitchFamily="34" charset="-122"/>
-                <a:cs typeface="Be Vietnam Pro" pitchFamily="34" charset="-120"/>
-              </a:rPr>
-              <a:t> bài</a:t>
+              <a:t>ByteByteGo</a:t>
+            </a:r>
+            <a:r>
+              <a:rPr lang="en-US" sz="2250" dirty="0" spc="0" kern="0">
+                <a:solidFill>
+                  <a:srgbClr val="F3EEE3"/>
+                </a:solidFill>
+                <a:latin typeface="Be Vietnam Pro" pitchFamily="34" charset="0"/>
+                <a:ea typeface="Be Vietnam Pro" pitchFamily="34" charset="-122"/>
+                <a:cs typeface="Be Vietnam Pro" pitchFamily="34" charset="-120"/>
+              </a:rPr>
+              <a:t> (thang</a:t>
+            </a:r>
+            <a:r>
+              <a:rPr lang="en-US" sz="2250" dirty="0" spc="-5" kern="0">
+                <a:solidFill>
+                  <a:srgbClr val="F3EEE3"/>
+                </a:solidFill>
+                <a:latin typeface="Be Vietnam Pro" pitchFamily="34" charset="0"/>
+                <a:ea typeface="Be Vietnam Pro" pitchFamily="34" charset="-122"/>
+                <a:cs typeface="Be Vietnam Pro" pitchFamily="34" charset="-120"/>
+              </a:rPr>
+              <a:t> sao);</a:t>
+            </a:r>
+            <a:r>
+              <a:rPr lang="en-US" sz="2250" dirty="0" spc="0" kern="0">
+                <a:solidFill>
+                  <a:srgbClr val="F3EEE3"/>
+                </a:solidFill>
+                <a:latin typeface="Be Vietnam Pro" pitchFamily="34" charset="0"/>
+                <a:ea typeface="Be Vietnam Pro" pitchFamily="34" charset="-122"/>
+                <a:cs typeface="Be Vietnam Pro" pitchFamily="34" charset="-120"/>
+              </a:rPr>
+              <a:t> Apache</a:t>
+            </a:r>
+            <a:r>
+              <a:rPr lang="en-US" sz="2250" dirty="0" spc="-12" kern="0">
+                <a:solidFill>
+                  <a:srgbClr val="F3EEE3"/>
+                </a:solidFill>
+                <a:latin typeface="Be Vietnam Pro" pitchFamily="34" charset="0"/>
+                <a:ea typeface="Be Vietnam Pro" pitchFamily="34" charset="-122"/>
+                <a:cs typeface="Be Vietnam Pro" pitchFamily="34" charset="-120"/>
+              </a:rPr>
+              <a:t> Cassandra</a:t>
             </a:r>
             <a:r>
               <a:rPr lang="en-US" sz="2250" dirty="0" spc="1" kern="0">
@@ -18357,84 +18104,40 @@
                 <a:ea typeface="Be Vietnam Pro" pitchFamily="34" charset="-122"/>
                 <a:cs typeface="Be Vietnam Pro" pitchFamily="34" charset="-120"/>
               </a:rPr>
-              <a:t> nguồn</a:t>
-            </a:r>
-            <a:r>
-              <a:rPr lang="en-US" sz="2250" dirty="0" spc="-12" kern="0">
-                <a:solidFill>
-                  <a:srgbClr val="F3EEE3"/>
-                </a:solidFill>
-                <a:latin typeface="Be Vietnam Pro" pitchFamily="34" charset="0"/>
-                <a:ea typeface="Be Vietnam Pro" pitchFamily="34" charset="-122"/>
-                <a:cs typeface="Be Vietnam Pro" pitchFamily="34" charset="-120"/>
-              </a:rPr>
-              <a:t> tại</a:t>
-            </a:r>
-            <a:r>
-              <a:rPr lang="en-US" sz="2250" dirty="0" spc="-1" kern="0">
-                <a:solidFill>
-                  <a:srgbClr val="F3EEE3"/>
-                </a:solidFill>
-                <a:latin typeface="Be Vietnam Pro" pitchFamily="34" charset="0"/>
-                <a:ea typeface="Be Vietnam Pro" pitchFamily="34" charset="-122"/>
-                <a:cs typeface="Be Vietnam Pro" pitchFamily="34" charset="-120"/>
-              </a:rPr>
-              <a:t> commit</a:t>
-            </a:r>
-            <a:r>
-              <a:rPr lang="en-US" sz="2250" dirty="0" spc="4" kern="0">
-                <a:solidFill>
-                  <a:srgbClr val="F3EEE3"/>
-                </a:solidFill>
-                <a:latin typeface="Be Vietnam Pro" pitchFamily="34" charset="0"/>
-                <a:ea typeface="Be Vietnam Pro" pitchFamily="34" charset="-122"/>
-                <a:cs typeface="Be Vietnam Pro" pitchFamily="34" charset="-120"/>
-              </a:rPr>
-              <a:t> cố</a:t>
-            </a:r>
-            <a:r>
-              <a:rPr lang="en-US" sz="2250" dirty="0" spc="16" kern="0">
-                <a:solidFill>
-                  <a:srgbClr val="F3EEE3"/>
-                </a:solidFill>
-                <a:latin typeface="Be Vietnam Pro" pitchFamily="34" charset="0"/>
-                <a:ea typeface="Be Vietnam Pro" pitchFamily="34" charset="-122"/>
-                <a:cs typeface="Be Vietnam Pro" pitchFamily="34" charset="-120"/>
-              </a:rPr>
-              <a:t> định:</a:t>
-            </a:r>
-            <a:r>
-              <a:rPr lang="en-US" sz="2250" dirty="0" spc="1" kern="0">
-                <a:solidFill>
-                  <a:srgbClr val="F3EEE3"/>
-                </a:solidFill>
-                <a:latin typeface="Be Vietnam Pro" pitchFamily="34" charset="0"/>
-                <a:ea typeface="Be Vietnam Pro" pitchFamily="34" charset="-122"/>
-                <a:cs typeface="Be Vietnam Pro" pitchFamily="34" charset="-120"/>
-              </a:rPr>
-              <a:t> lời</a:t>
-            </a:r>
-            <a:r>
-              <a:rPr lang="en-US" sz="2250" dirty="0" spc="-11" kern="0">
-                <a:solidFill>
-                  <a:srgbClr val="F3EEE3"/>
-                </a:solidFill>
-                <a:latin typeface="Be Vietnam Pro" pitchFamily="34" charset="0"/>
-                <a:ea typeface="Be Vietnam Pro" pitchFamily="34" charset="-122"/>
-                <a:cs typeface="Be Vietnam Pro" pitchFamily="34" charset="-120"/>
-              </a:rPr>
-              <a:t> khuyên</a:t>
-            </a:r>
-            <a:r>
-              <a:rPr lang="en-US" sz="2250" dirty="0" spc="-18" kern="0">
-                <a:solidFill>
-                  <a:srgbClr val="F3EEE3"/>
-                </a:solidFill>
-                <a:latin typeface="Be Vietnam Pro" pitchFamily="34" charset="0"/>
-                <a:ea typeface="Be Vietnam Pro" pitchFamily="34" charset="-122"/>
-                <a:cs typeface="Be Vietnam Pro" pitchFamily="34" charset="-120"/>
-              </a:rPr>
-              <a:t> và</a:t>
+              <a:t> (bộ lọc</a:t>
+            </a:r>
+            <a:r>
+              <a:rPr lang="en-US" sz="2250" dirty="0" spc="-4" kern="0">
+                <a:solidFill>
+                  <a:srgbClr val="F3EEE3"/>
+                </a:solidFill>
+                <a:latin typeface="Be Vietnam Pro" pitchFamily="34" charset="0"/>
+                <a:ea typeface="Be Vietnam Pro" pitchFamily="34" charset="-122"/>
+                <a:cs typeface="Be Vietnam Pro" pitchFamily="34" charset="-120"/>
+              </a:rPr>
+              <a:t> Bloom,</a:t>
+            </a:r>
+            <a:r>
+              <a:rPr lang="en-US" sz="2250" dirty="0" spc="-2" kern="0">
+                <a:solidFill>
+                  <a:srgbClr val="F3EEE3"/>
+                </a:solidFill>
+                <a:latin typeface="Be Vietnam Pro" pitchFamily="34" charset="0"/>
+                <a:ea typeface="Be Vietnam Pro" pitchFamily="34" charset="-122"/>
+                <a:cs typeface="Be Vietnam Pro" pitchFamily="34" charset="-120"/>
+              </a:rPr>
+              <a:t> băm</a:t>
+            </a:r>
+            <a:r>
+              <a:rPr lang="en-US" sz="2250" dirty="0" spc="-9" kern="0">
+                <a:solidFill>
+                  <a:srgbClr val="F3EEE3"/>
+                </a:solidFill>
+                <a:latin typeface="Be Vietnam Pro" pitchFamily="34" charset="0"/>
+                <a:ea typeface="Be Vietnam Pro" pitchFamily="34" charset="-122"/>
+                <a:cs typeface="Be Vietnam Pro" pitchFamily="34" charset="-120"/>
+              </a:rPr>
+              <a:t> nhất</a:t>
             </a:r>
             <a:r>
               <a:rPr lang="en-US" sz="2250" dirty="0" spc="0" kern="0">
@@ -18445,84 +18148,29 @@
                 <a:ea typeface="Be Vietnam Pro" pitchFamily="34" charset="-122"/>
                 <a:cs typeface="Be Vietnam Pro" pitchFamily="34" charset="-120"/>
               </a:rPr>
-              <a:t> thang</a:t>
-            </a:r>
-            <a:r>
-              <a:rPr lang="en-US" sz="2250" dirty="0" spc="-6" kern="0">
-                <a:solidFill>
-                  <a:srgbClr val="F3EEE3"/>
-                </a:solidFill>
-                <a:latin typeface="Be Vietnam Pro" pitchFamily="34" charset="0"/>
-                <a:ea typeface="Be Vietnam Pro" pitchFamily="34" charset="-122"/>
-                <a:cs typeface="Be Vietnam Pro" pitchFamily="34" charset="-120"/>
-              </a:rPr>
-              <a:t> sao;</a:t>
-            </a:r>
-            <a:r>
-              <a:rPr lang="en-US" sz="2250" dirty="0" spc="1" kern="0">
-                <a:solidFill>
-                  <a:srgbClr val="F3EEE3"/>
-                </a:solidFill>
-                <a:latin typeface="Be Vietnam Pro" pitchFamily="34" charset="0"/>
-                <a:ea typeface="Be Vietnam Pro" pitchFamily="34" charset="-122"/>
-                <a:cs typeface="Be Vietnam Pro" pitchFamily="34" charset="-120"/>
-              </a:rPr>
-              <a:t> danh</a:t>
-            </a:r>
-            <a:r>
-              <a:rPr lang="en-US" sz="2250" dirty="0" spc="-3" kern="0">
-                <a:solidFill>
-                  <a:srgbClr val="F3EEE3"/>
-                </a:solidFill>
-                <a:latin typeface="Be Vietnam Pro" pitchFamily="34" charset="0"/>
-                <a:ea typeface="Be Vietnam Pro" pitchFamily="34" charset="-122"/>
-                <a:cs typeface="Be Vietnam Pro" pitchFamily="34" charset="-120"/>
-              </a:rPr>
-              <a:t> sách</a:t>
-            </a:r>
-            <a:r>
-              <a:rPr lang="en-US" sz="2250" dirty="0" spc="1" kern="0">
-                <a:solidFill>
-                  <a:srgbClr val="F3EEE3"/>
-                </a:solidFill>
-                <a:latin typeface="Be Vietnam Pro" pitchFamily="34" charset="0"/>
-                <a:ea typeface="Be Vietnam Pro" pitchFamily="34" charset="-122"/>
-                <a:cs typeface="Be Vietnam Pro" pitchFamily="34" charset="-120"/>
-              </a:rPr>
-              <a:t> chỉ</a:t>
-            </a:r>
-            <a:r>
-              <a:rPr lang="en-US" sz="2250" dirty="0" spc="5" kern="0">
-                <a:solidFill>
-                  <a:srgbClr val="F3EEE3"/>
-                </a:solidFill>
-                <a:latin typeface="Be Vietnam Pro" pitchFamily="34" charset="0"/>
-                <a:ea typeface="Be Vietnam Pro" pitchFamily="34" charset="-122"/>
-                <a:cs typeface="Be Vietnam Pro" pitchFamily="34" charset="-120"/>
-              </a:rPr>
-              <a:t> có</a:t>
-            </a:r>
-            <a:r>
-              <a:rPr lang="en-US" sz="2250" dirty="0" spc="-16" kern="0">
-                <a:solidFill>
-                  <a:srgbClr val="F3EEE3"/>
-                </a:solidFill>
-                <a:latin typeface="Be Vietnam Pro" pitchFamily="34" charset="0"/>
-                <a:ea typeface="Be Vietnam Pro" pitchFamily="34" charset="-122"/>
-                <a:cs typeface="Be Vietnam Pro" pitchFamily="34" charset="-120"/>
-              </a:rPr>
-              <a:t> trong</a:t>
-            </a:r>
-            <a:r>
-              <a:rPr lang="en-US" sz="2250" dirty="0" spc="1" kern="0">
-                <a:solidFill>
-                  <a:srgbClr val="F3EEE3"/>
-                </a:solidFill>
-                <a:latin typeface="Be Vietnam Pro" pitchFamily="34" charset="0"/>
-                <a:ea typeface="Be Vietnam Pro" pitchFamily="34" charset="-122"/>
-                <a:cs typeface="Be Vietnam Pro" pitchFamily="34" charset="-120"/>
-              </a:rPr>
-              <a:t> ảnh.</a:t>
+              <a:t> quán);</a:t>
+            </a:r>
+            <a:r>
+              <a:rPr lang="en-US" sz="2250" dirty="0" spc="-14" kern="0">
+                <a:solidFill>
+                  <a:srgbClr val="F3EEE3"/>
+                </a:solidFill>
+                <a:latin typeface="Be Vietnam Pro" pitchFamily="34" charset="0"/>
+                <a:ea typeface="Be Vietnam Pro" pitchFamily="34" charset="-122"/>
+                <a:cs typeface="Be Vietnam Pro" pitchFamily="34" charset="-120"/>
+              </a:rPr>
+              <a:t> etcd-io/raft</a:t>
+            </a:r>
+            <a:r>
+              <a:rPr lang="en-US" sz="2250" dirty="0" spc="-15" kern="0">
+                <a:solidFill>
+                  <a:srgbClr val="F3EEE3"/>
+                </a:solidFill>
+                <a:latin typeface="Be Vietnam Pro" pitchFamily="34" charset="0"/>
+                <a:ea typeface="Be Vietnam Pro" pitchFamily="34" charset="-122"/>
+                <a:cs typeface="Be Vietnam Pro" pitchFamily="34" charset="-120"/>
+              </a:rPr>
+              <a:t> (Raft).</a:t>
             </a:r>
             <a:endParaRPr lang="en-US" sz="2250" dirty="0"/>
           </a:p>
@@ -18597,7 +18245,7 @@
               <a:t> ngày</a:t>
             </a:r>
             <a:r>
-              <a:rPr lang="en-US" sz="2100" dirty="0" spc="-1" kern="0">
+              <a:rPr lang="en-US" sz="2100" dirty="0" spc="0" kern="0">
                 <a:solidFill>
                   <a:srgbClr val="9AA0B5"/>
                 </a:solidFill>
@@ -18605,10 +18253,10 @@
                 <a:ea typeface="Be Vietnam Pro" pitchFamily="34" charset="-122"/>
                 <a:cs typeface="Be Vietnam Pro" pitchFamily="34" charset="-120"/>
               </a:rPr>
-              <a:t> 2026-10-18.</a:t>
-            </a:r>
-            <a:r>
-              <a:rPr lang="en-US" sz="2100" dirty="0" spc="0" kern="0">
+              <a:t> 2026-10-19. Hình minh</a:t>
+            </a:r>
+            <a:r>
+              <a:rPr lang="en-US" sz="2100" dirty="0" spc="-5" kern="0">
                 <a:solidFill>
                   <a:srgbClr val="9AA0B5"/>
                 </a:solidFill>
@@ -18616,10 +18264,10 @@
                 <a:ea typeface="Be Vietnam Pro" pitchFamily="34" charset="-122"/>
                 <a:cs typeface="Be Vietnam Pro" pitchFamily="34" charset="-120"/>
               </a:rPr>
-              <a:t> Hình</a:t>
-            </a:r>
-            <a:r>
-              <a:rPr lang="en-US" sz="2100" dirty="0" spc="1" kern="0">
+              <a:t> họa</a:t>
+            </a:r>
+            <a:r>
+              <a:rPr lang="en-US" sz="2100" dirty="0" spc="-4" kern="0">
                 <a:solidFill>
                   <a:srgbClr val="9AA0B5"/>
                 </a:solidFill>
@@ -18627,10 +18275,10 @@
                 <a:ea typeface="Be Vietnam Pro" pitchFamily="34" charset="-122"/>
                 <a:cs typeface="Be Vietnam Pro" pitchFamily="34" charset="-120"/>
               </a:rPr>
-              <a:t> minh</a:t>
-            </a:r>
-            <a:r>
-              <a:rPr lang="en-US" sz="2100" dirty="0" spc="-6" kern="0">
+              <a:t> là</a:t>
+            </a:r>
+            <a:r>
+              <a:rPr lang="en-US" sz="2100" dirty="0" spc="-3" kern="0">
                 <a:solidFill>
                   <a:srgbClr val="9AA0B5"/>
                 </a:solidFill>
@@ -18638,32 +18286,10 @@
                 <a:ea typeface="Be Vietnam Pro" pitchFamily="34" charset="-122"/>
                 <a:cs typeface="Be Vietnam Pro" pitchFamily="34" charset="-120"/>
               </a:rPr>
-              <a:t> họa</a:t>
-            </a:r>
-            <a:r>
-              <a:rPr lang="en-US" sz="2100" dirty="0" spc="-3" kern="0">
-                <a:solidFill>
-                  <a:srgbClr val="9AA0B5"/>
-                </a:solidFill>
-                <a:latin typeface="Be Vietnam Pro" pitchFamily="34" charset="0"/>
-                <a:ea typeface="Be Vietnam Pro" pitchFamily="34" charset="-122"/>
-                <a:cs typeface="Be Vietnam Pro" pitchFamily="34" charset="-120"/>
-              </a:rPr>
-              <a:t> là</a:t>
-            </a:r>
-            <a:r>
-              <a:rPr lang="en-US" sz="2100" dirty="0" spc="-4" kern="0">
-                <a:solidFill>
-                  <a:srgbClr val="9AA0B5"/>
-                </a:solidFill>
-                <a:latin typeface="Be Vietnam Pro" pitchFamily="34" charset="0"/>
-                <a:ea typeface="Be Vietnam Pro" pitchFamily="34" charset="-122"/>
-                <a:cs typeface="Be Vietnam Pro" pitchFamily="34" charset="-120"/>
-              </a:rPr>
               <a:t> thiết</a:t>
             </a:r>
             <a:r>
-              <a:rPr lang="en-US" sz="2100" dirty="0" spc="-30" kern="0">
+              <a:rPr lang="en-US" sz="2100" dirty="0" spc="-31" kern="0">
                 <a:solidFill>
                   <a:srgbClr val="9AA0B5"/>
                 </a:solidFill>

</xml_diff>